<commit_message>
Simplify presentation limitations slide
</commit_message>
<xml_diff>
--- a/docs/presentation/Damka_Presentation.pptx
+++ b/docs/presentation/Damka_Presentation.pptx
@@ -1458,7 +1458,7 @@
               <a:rPr sz="1200">
                 <a:latin typeface="Arial"/>
               </a:rPr>
-              <a:t>המימוש הנוכחי מיועד לרשת מקומית. כתובת ופורט ניתנים להגדרה, אך אין TLS ולכן ההודעות אינן מוצפנות. לאחר זיהוי ניתוק במשחק פעיל המשחק מסתיים לטובת היריב; אין שחזור של אותו משחק לאחר התחברות מחדש. תוצאות BOT מדווחות מהלקוח, ומשחק לא מקוון או משחק שאיבד את חיבור החשבון אינו נשמר או מועלה מאוחר יותר.</a:t>
+              <a:t>לאחר זיהוי ניתוק במשחק פעיל המשחק מסתיים לטובת היריב; אין שחזור של אותו משחק לאחר התחברות מחדש. תוצאות BOT מדווחות מהלקוח, ומשחק לא מקוון או משחק שאיבד את חיבור החשבון אינו נשמר או מועלה מאוחר יותר.</a:t>
             </a:r>
           </a:p>
           <a:p>
@@ -14534,7 +14534,7 @@
         <p:spPr>
           <a:xfrm>
             <a:off x="548640" y="1938528"/>
-            <a:ext cx="3538728" cy="2423160"/>
+            <a:ext cx="5367528" cy="2423160"/>
           </a:xfrm>
           <a:prstGeom prst="roundRect">
             <a:avLst>
@@ -14626,7 +14626,7 @@
         <p:spPr>
           <a:xfrm>
             <a:off x="777240" y="2157984"/>
-            <a:ext cx="3081528" cy="594360"/>
+            <a:ext cx="4910328" cy="594360"/>
           </a:xfrm>
           <a:prstGeom prst="rect">
             <a:avLst/>
@@ -14657,7 +14657,7 @@
               </a:defRPr>
             </a:pPr>
             <a:r>
-              <a:t>LAN focus</a:t>
+              <a:t>No match resume</a:t>
             </a:r>
           </a:p>
         </p:txBody>
@@ -14671,7 +14671,7 @@
         <p:spPr>
           <a:xfrm>
             <a:off x="777240" y="2898648"/>
-            <a:ext cx="3081528" cy="1307592"/>
+            <a:ext cx="4910328" cy="1307592"/>
           </a:xfrm>
           <a:prstGeom prst="rect">
             <a:avLst/>
@@ -14694,7 +14694,7 @@
               <a:spcAft>
                 <a:spcPts val="400"/>
               </a:spcAft>
-              <a:defRPr sz="2300" b="0">
+              <a:defRPr sz="2400" b="0">
                 <a:solidFill>
                   <a:srgbClr val="425D50"/>
                 </a:solidFill>
@@ -14702,7 +14702,29 @@
               </a:defRPr>
             </a:pPr>
             <a:r>
-              <a:t>No TLS in this version</a:t>
+              <a:t>A detected disconnect</a:t>
+            </a:r>
+          </a:p>
+          <a:p>
+            <a:pPr algn="l">
+              <a:lnSpc>
+                <a:spcPct val="106000"/>
+              </a:lnSpc>
+              <a:spcBef>
+                <a:spcPts val="0"/>
+              </a:spcBef>
+              <a:spcAft>
+                <a:spcPts val="400"/>
+              </a:spcAft>
+              <a:defRPr sz="2400" b="0">
+                <a:solidFill>
+                  <a:srgbClr val="425D50"/>
+                </a:solidFill>
+                <a:latin typeface="Arial"/>
+              </a:defRPr>
+            </a:pPr>
+            <a:r>
+              <a:t>ends the active match</a:t>
             </a:r>
           </a:p>
         </p:txBody>
@@ -14715,8 +14737,8 @@
         </p:nvSpPr>
         <p:spPr>
           <a:xfrm>
-            <a:off x="4325112" y="1938528"/>
-            <a:ext cx="3538728" cy="2423160"/>
+            <a:off x="6281928" y="1938528"/>
+            <a:ext cx="5367528" cy="2423160"/>
           </a:xfrm>
           <a:prstGeom prst="roundRect">
             <a:avLst>
@@ -14763,14 +14785,14 @@
         </p:nvSpPr>
         <p:spPr>
           <a:xfrm>
-            <a:off x="4343400" y="2139696"/>
+            <a:off x="6300216" y="2139696"/>
             <a:ext cx="41148" cy="2020824"/>
           </a:xfrm>
           <a:prstGeom prst="rect">
             <a:avLst/>
           </a:prstGeom>
           <a:solidFill>
-            <a:srgbClr val="285942"/>
+            <a:srgbClr val="BD614A"/>
           </a:solidFill>
           <a:ln>
             <a:noFill/>
@@ -14807,8 +14829,8 @@
         </p:nvSpPr>
         <p:spPr>
           <a:xfrm>
-            <a:off x="4553712" y="2157984"/>
-            <a:ext cx="3081528" cy="594360"/>
+            <a:off x="6510528" y="2157984"/>
+            <a:ext cx="4910328" cy="594360"/>
           </a:xfrm>
           <a:prstGeom prst="rect">
             <a:avLst/>
@@ -14839,7 +14861,7 @@
               </a:defRPr>
             </a:pPr>
             <a:r>
-              <a:t>No match resume</a:t>
+              <a:t>Local BOT results</a:t>
             </a:r>
           </a:p>
         </p:txBody>
@@ -14852,8 +14874,8 @@
         </p:nvSpPr>
         <p:spPr>
           <a:xfrm>
-            <a:off x="4553712" y="2898648"/>
-            <a:ext cx="3081528" cy="1307592"/>
+            <a:off x="6510528" y="2898648"/>
+            <a:ext cx="4910328" cy="1307592"/>
           </a:xfrm>
           <a:prstGeom prst="rect">
             <a:avLst/>
@@ -14876,7 +14898,7 @@
               <a:spcAft>
                 <a:spcPts val="400"/>
               </a:spcAft>
-              <a:defRPr sz="2300" b="0">
+              <a:defRPr sz="2400" b="0">
                 <a:solidFill>
                   <a:srgbClr val="425D50"/>
                 </a:solidFill>
@@ -14884,7 +14906,7 @@
               </a:defRPr>
             </a:pPr>
             <a:r>
-              <a:t>A detected disconnect</a:t>
+              <a:t>Client-reported</a:t>
             </a:r>
           </a:p>
           <a:p>
@@ -14898,7 +14920,7 @@
               <a:spcAft>
                 <a:spcPts val="400"/>
               </a:spcAft>
-              <a:defRPr sz="2300" b="0">
+              <a:defRPr sz="2400" b="0">
                 <a:solidFill>
                   <a:srgbClr val="425D50"/>
                 </a:solidFill>
@@ -14906,7 +14928,7 @@
               </a:defRPr>
             </a:pPr>
             <a:r>
-              <a:t>ends the active match</a:t>
+              <a:t>No offline upload queue</a:t>
             </a:r>
           </a:p>
         </p:txBody>
@@ -14914,210 +14936,6 @@
       <p:sp>
         <p:nvSpPr>
           <p:cNvPr id="18" name="Rounded Rectangle 17"/>
-          <p:cNvSpPr/>
-          <p:nvPr/>
-        </p:nvSpPr>
-        <p:spPr>
-          <a:xfrm>
-            <a:off x="8110727" y="1938528"/>
-            <a:ext cx="3538728" cy="2423160"/>
-          </a:xfrm>
-          <a:prstGeom prst="roundRect">
-            <a:avLst>
-              <a:gd name="adj" fmla="val 12000"/>
-            </a:avLst>
-          </a:prstGeom>
-          <a:solidFill>
-            <a:srgbClr val="FFFFFF"/>
-          </a:solidFill>
-          <a:ln w="12700">
-            <a:solidFill>
-              <a:srgbClr val="CBD8CF"/>
-            </a:solidFill>
-          </a:ln>
-          <a:effectLst/>
-        </p:spPr>
-        <p:style>
-          <a:lnRef idx="1">
-            <a:schemeClr val="accent1"/>
-          </a:lnRef>
-          <a:fillRef idx="3">
-            <a:schemeClr val="accent1"/>
-          </a:fillRef>
-          <a:effectRef idx="0">
-            <a:schemeClr val="accent1"/>
-          </a:effectRef>
-          <a:fontRef idx="minor">
-            <a:schemeClr val="lt1"/>
-          </a:fontRef>
-        </p:style>
-        <p:txBody>
-          <a:bodyPr rtlCol="0" anchor="ctr"/>
-          <a:lstStyle/>
-          <a:p>
-            <a:pPr algn="ctr"/>
-          </a:p>
-        </p:txBody>
-      </p:sp>
-      <p:sp>
-        <p:nvSpPr>
-          <p:cNvPr id="19" name="Rectangle 18"/>
-          <p:cNvSpPr/>
-          <p:nvPr/>
-        </p:nvSpPr>
-        <p:spPr>
-          <a:xfrm>
-            <a:off x="8129015" y="2139696"/>
-            <a:ext cx="41148" cy="2020824"/>
-          </a:xfrm>
-          <a:prstGeom prst="rect">
-            <a:avLst/>
-          </a:prstGeom>
-          <a:solidFill>
-            <a:srgbClr val="285942"/>
-          </a:solidFill>
-          <a:ln>
-            <a:noFill/>
-          </a:ln>
-          <a:effectLst/>
-        </p:spPr>
-        <p:style>
-          <a:lnRef idx="1">
-            <a:schemeClr val="accent1"/>
-          </a:lnRef>
-          <a:fillRef idx="3">
-            <a:schemeClr val="accent1"/>
-          </a:fillRef>
-          <a:effectRef idx="0">
-            <a:schemeClr val="accent1"/>
-          </a:effectRef>
-          <a:fontRef idx="minor">
-            <a:schemeClr val="lt1"/>
-          </a:fontRef>
-        </p:style>
-        <p:txBody>
-          <a:bodyPr rtlCol="0" anchor="ctr"/>
-          <a:lstStyle/>
-          <a:p>
-            <a:pPr algn="ctr"/>
-          </a:p>
-        </p:txBody>
-      </p:sp>
-      <p:sp>
-        <p:nvSpPr>
-          <p:cNvPr id="20" name="TextBox 19"/>
-          <p:cNvSpPr txBox="1"/>
-          <p:nvPr/>
-        </p:nvSpPr>
-        <p:spPr>
-          <a:xfrm>
-            <a:off x="8339327" y="2157984"/>
-            <a:ext cx="3081528" cy="594360"/>
-          </a:xfrm>
-          <a:prstGeom prst="rect">
-            <a:avLst/>
-          </a:prstGeom>
-          <a:noFill/>
-        </p:spPr>
-        <p:txBody>
-          <a:bodyPr wrap="square" lIns="0" rIns="0" tIns="0" bIns="0">
-            <a:noAutofit/>
-          </a:bodyPr>
-          <a:lstStyle/>
-          <a:p>
-            <a:pPr algn="l">
-              <a:lnSpc>
-                <a:spcPct val="106000"/>
-              </a:lnSpc>
-              <a:spcBef>
-                <a:spcPts val="0"/>
-              </a:spcBef>
-              <a:spcAft>
-                <a:spcPts val="400"/>
-              </a:spcAft>
-              <a:defRPr sz="2700" b="1">
-                <a:solidFill>
-                  <a:srgbClr val="153B2D"/>
-                </a:solidFill>
-                <a:latin typeface="Arial"/>
-              </a:defRPr>
-            </a:pPr>
-            <a:r>
-              <a:t>Local BOT results</a:t>
-            </a:r>
-          </a:p>
-        </p:txBody>
-      </p:sp>
-      <p:sp>
-        <p:nvSpPr>
-          <p:cNvPr id="21" name="TextBox 20"/>
-          <p:cNvSpPr txBox="1"/>
-          <p:nvPr/>
-        </p:nvSpPr>
-        <p:spPr>
-          <a:xfrm>
-            <a:off x="8339327" y="2898648"/>
-            <a:ext cx="3081528" cy="1307592"/>
-          </a:xfrm>
-          <a:prstGeom prst="rect">
-            <a:avLst/>
-          </a:prstGeom>
-          <a:noFill/>
-        </p:spPr>
-        <p:txBody>
-          <a:bodyPr wrap="square" lIns="0" rIns="0" tIns="0" bIns="0">
-            <a:noAutofit/>
-          </a:bodyPr>
-          <a:lstStyle/>
-          <a:p>
-            <a:pPr algn="l">
-              <a:lnSpc>
-                <a:spcPct val="106000"/>
-              </a:lnSpc>
-              <a:spcBef>
-                <a:spcPts val="0"/>
-              </a:spcBef>
-              <a:spcAft>
-                <a:spcPts val="400"/>
-              </a:spcAft>
-              <a:defRPr sz="2300" b="0">
-                <a:solidFill>
-                  <a:srgbClr val="425D50"/>
-                </a:solidFill>
-                <a:latin typeface="Arial"/>
-              </a:defRPr>
-            </a:pPr>
-            <a:r>
-              <a:t>Client-reported</a:t>
-            </a:r>
-          </a:p>
-          <a:p>
-            <a:pPr algn="l">
-              <a:lnSpc>
-                <a:spcPct val="106000"/>
-              </a:lnSpc>
-              <a:spcBef>
-                <a:spcPts val="0"/>
-              </a:spcBef>
-              <a:spcAft>
-                <a:spcPts val="400"/>
-              </a:spcAft>
-              <a:defRPr sz="2300" b="0">
-                <a:solidFill>
-                  <a:srgbClr val="425D50"/>
-                </a:solidFill>
-                <a:latin typeface="Arial"/>
-              </a:defRPr>
-            </a:pPr>
-            <a:r>
-              <a:t>No offline upload queue</a:t>
-            </a:r>
-          </a:p>
-        </p:txBody>
-      </p:sp>
-      <p:sp>
-        <p:nvSpPr>
-          <p:cNvPr id="22" name="Rounded Rectangle 21"/>
           <p:cNvSpPr/>
           <p:nvPr/>
         </p:nvSpPr>
@@ -15165,7 +14983,7 @@
       </p:sp>
       <p:sp>
         <p:nvSpPr>
-          <p:cNvPr id="23" name="TextBox 22"/>
+          <p:cNvPr id="19" name="TextBox 18"/>
           <p:cNvSpPr txBox="1"/>
           <p:nvPr/>
         </p:nvSpPr>
@@ -15210,7 +15028,7 @@
       </p:sp>
       <p:sp>
         <p:nvSpPr>
-          <p:cNvPr id="24" name="TextBox 23"/>
+          <p:cNvPr id="20" name="TextBox 19"/>
           <p:cNvSpPr txBox="1"/>
           <p:nvPr/>
         </p:nvSpPr>

</xml_diff>

<commit_message>
Remove dedicated presentation limitations slide
</commit_message>
<xml_diff>
--- a/docs/presentation/Damka_Presentation.pptx
+++ b/docs/presentation/Damka_Presentation.pptx
@@ -14,7 +14,6 @@
     <p:sldId id="262" r:id="rId14"/>
     <p:sldId id="263" r:id="rId15"/>
     <p:sldId id="264" r:id="rId16"/>
-    <p:sldId id="265" r:id="rId17"/>
   </p:sldIdLst>
   <p:sldSz cx="12191999" cy="6858000" type="screen4x3"/>
   <p:notesSz cx="6858000" cy="9144000"/>
@@ -561,101 +560,6 @@
 </p:notes>
 </file>
 
-<file path=ppt/notesSlides/notesSlide10.xml><?xml version="1.0" encoding="utf-8"?>
-<p:notes xmlns:a="http://schemas.openxmlformats.org/drawingml/2006/main" xmlns:p="http://schemas.openxmlformats.org/presentationml/2006/main" xmlns:r="http://schemas.openxmlformats.org/officeDocument/2006/relationships">
-  <p:cSld>
-    <p:spTree>
-      <p:nvGrpSpPr>
-        <p:cNvPr id="1" name=""/>
-        <p:cNvGrpSpPr/>
-        <p:nvPr/>
-      </p:nvGrpSpPr>
-      <p:grpSpPr>
-        <a:xfrm>
-          <a:off x="0" y="0"/>
-          <a:ext cx="0" cy="0"/>
-          <a:chOff x="0" y="0"/>
-          <a:chExt cx="0" cy="0"/>
-        </a:xfrm>
-      </p:grpSpPr>
-      <p:sp>
-        <p:nvSpPr>
-          <p:cNvPr id="2" name="Slide Image Placeholder 1"/>
-          <p:cNvSpPr>
-            <a:spLocks noGrp="1"/>
-          </p:cNvSpPr>
-          <p:nvPr>
-            <p:ph type="sldImg" idx="2"/>
-          </p:nvPr>
-        </p:nvSpPr>
-        <p:spPr/>
-      </p:sp>
-      <p:sp>
-        <p:nvSpPr>
-          <p:cNvPr id="3" name="Notes Placeholder 2"/>
-          <p:cNvSpPr>
-            <a:spLocks noGrp="1"/>
-          </p:cNvSpPr>
-          <p:nvPr>
-            <p:ph type="body" idx="3" sz="quarter"/>
-          </p:nvPr>
-        </p:nvSpPr>
-        <p:spPr/>
-        <p:txBody>
-          <a:bodyPr/>
-          <a:lstStyle/>
-          <a:p>
-            <a:pPr algn="r" rtl="1"/>
-            <a:r>
-              <a:rPr sz="1200">
-                <a:latin typeface="Arial"/>
-              </a:rPr>
-              <a:t>תודה ושאלות</a:t>
-            </a:r>
-          </a:p>
-          <a:p>
-            <a:pPr algn="r" rtl="1"/>
-            <a:r>
-              <a:rPr sz="1200">
-                <a:latin typeface="Arial"/>
-              </a:rPr>
-              <a:t>זמן מומלץ: 15 שניות</a:t>
-            </a:r>
-          </a:p>
-          <a:p>
-            <a:pPr algn="r" rtl="1"/>
-          </a:p>
-          <a:p>
-            <a:pPr algn="r" rtl="1"/>
-            <a:r>
-              <a:rPr sz="1200">
-                <a:latin typeface="Arial"/>
-              </a:rPr>
-              <a:t>להודות למנחה ולקהל ולהזמין שאלות. אפשר להשאיר את השקף מוצג בזמן הדיון. ההדגמה מוכנה בנפרד ואינה שקף במצגת.</a:t>
-            </a:r>
-          </a:p>
-        </p:txBody>
-      </p:sp>
-      <p:sp>
-        <p:nvSpPr>
-          <p:cNvPr id="4" name="Slide Number Placeholder 3"/>
-          <p:cNvSpPr>
-            <a:spLocks noGrp="1"/>
-          </p:cNvSpPr>
-          <p:nvPr>
-            <p:ph type="sldNum" idx="5" sz="quarter"/>
-          </p:nvPr>
-        </p:nvSpPr>
-        <p:spPr/>
-      </p:sp>
-    </p:spTree>
-  </p:cSld>
-  <p:clrMapOvr>
-    <a:masterClrMapping/>
-  </p:clrMapOvr>
-</p:notes>
-</file>
-
 <file path=ppt/notesSlides/notesSlide2.xml><?xml version="1.0" encoding="utf-8"?>
 <p:notes xmlns:a="http://schemas.openxmlformats.org/drawingml/2006/main" xmlns:p="http://schemas.openxmlformats.org/presentationml/2006/main" xmlns:r="http://schemas.openxmlformats.org/officeDocument/2006/relationships">
   <p:cSld>
@@ -1437,7 +1341,7 @@
               <a:rPr sz="1200">
                 <a:latin typeface="Arial"/>
               </a:rPr>
-              <a:t>מגבלות והמשך פיתוח</a:t>
+              <a:t>סיכום ותרומה אישית</a:t>
             </a:r>
           </a:p>
           <a:p>
@@ -1458,7 +1362,7 @@
               <a:rPr sz="1200">
                 <a:latin typeface="Arial"/>
               </a:rPr>
-              <a:t>לאחר זיהוי ניתוק במשחק פעיל המשחק מסתיים לטובת היריב; אין שחזור של אותו משחק לאחר התחברות מחדש. תוצאות BOT מדווחות מהלקוח, ומשחק לא מקוון או משחק שאיבד את חיבור החשבון אינו נשמר או מועלה מאוחר יותר.</a:t>
+              <a:t>לסכם בתוצר: שני לקוחות מסונכרנים, שרת שמאמת מהלכים, מנוע כללים משותף ונתונים שנשמרים בפרופיל. הלמידה המרכזית היא חיבור ידע תאורטי ברשתות לתקשורת מעשית, עבודה עם JavaFX והפרדת כללי משחק מהתצוגה.</a:t>
             </a:r>
           </a:p>
           <a:p>
@@ -1470,7 +1374,31 @@
               <a:rPr sz="1200">
                 <a:latin typeface="Arial"/>
               </a:rPr>
-              <a:t>אלה גבולות ההיקף הנוכחי. כיוון המשך טבעי הוא צ׳אט בתוך החדר, דרך החיבורים הקיימים והשרת. זו תוספת עתידית, לא יכולת שכבר קיימת. אפשר להזכיר בעל פה גם שחיפוש BOT מוגבל לעומק שנבחר ולפונקציית הערכה פשוטה.</a:t>
+              <a:t>חלוקת תחומי האחריות שהוגדרה בפרויקט: רביע — לוגיקת המשחק; מותנא — חיבור TCP. קישור המאגר מופיע בשקף וניתן ללחיצה.</a:t>
+            </a:r>
+          </a:p>
+          <a:p>
+            <a:pPr algn="r" rtl="1"/>
+          </a:p>
+          <a:p>
+            <a:pPr algn="r" rtl="1"/>
+            <a:r>
+              <a:rPr sz="1200">
+                <a:latin typeface="Arial"/>
+              </a:rPr>
+              <a:t>כיוון פיתוח עתידי הוא צ׳אט בתוך החדר, דרך חיבורי TCP הקיימים והשרת. זו הצעה להמשך ולא יכולת קיימת.</a:t>
+            </a:r>
+          </a:p>
+          <a:p>
+            <a:pPr algn="r" rtl="1"/>
+          </a:p>
+          <a:p>
+            <a:pPr algn="r" rtl="1"/>
+            <a:r>
+              <a:rPr sz="1200">
+                <a:latin typeface="Arial"/>
+              </a:rPr>
+              <a:t>תקציב המצגת הוא 9:45 דקות לשקפים, 3 דקות להדגמה נפרדת ועוד 2:15 לשאלות. לתרגל מראש תשובות: למה יש שרת? מתי נפתח Socket? מי מאשר מהלך? איך BOT בוחרת? איך נמנעת שמירה כפולה? מה ההבדל בין גיבוב סיסמה להצפנת התקשורת?</a:t>
             </a:r>
           </a:p>
         </p:txBody>
@@ -1544,7 +1472,7 @@
               <a:rPr sz="1200">
                 <a:latin typeface="Arial"/>
               </a:rPr>
-              <a:t>סיכום ותרומה אישית</a:t>
+              <a:t>תודה ושאלות</a:t>
             </a:r>
           </a:p>
           <a:p>
@@ -1553,7 +1481,7 @@
               <a:rPr sz="1200">
                 <a:latin typeface="Arial"/>
               </a:rPr>
-              <a:t>זמן מומלץ: 45 שניות</a:t>
+              <a:t>זמן מומלץ: 15 שניות</a:t>
             </a:r>
           </a:p>
           <a:p>
@@ -1565,31 +1493,7 @@
               <a:rPr sz="1200">
                 <a:latin typeface="Arial"/>
               </a:rPr>
-              <a:t>לסכם בתוצר: שני לקוחות מסונכרנים, שרת שמאמת מהלכים, מנוע כללים משותף ונתונים שנשמרים בפרופיל. הלמידה המרכזית היא חיבור ידע תאורטי ברשתות לתקשורת מעשית, עבודה עם JavaFX והפרדת כללי משחק מהתצוגה.</a:t>
-            </a:r>
-          </a:p>
-          <a:p>
-            <a:pPr algn="r" rtl="1"/>
-          </a:p>
-          <a:p>
-            <a:pPr algn="r" rtl="1"/>
-            <a:r>
-              <a:rPr sz="1200">
-                <a:latin typeface="Arial"/>
-              </a:rPr>
-              <a:t>חלוקת תחומי האחריות שהוגדרה בפרויקט: רביע — לוגיקת המשחק; מותנא — חיבור TCP. קישור המאגר מופיע בשקף וניתן ללחיצה.</a:t>
-            </a:r>
-          </a:p>
-          <a:p>
-            <a:pPr algn="r" rtl="1"/>
-          </a:p>
-          <a:p>
-            <a:pPr algn="r" rtl="1"/>
-            <a:r>
-              <a:rPr sz="1200">
-                <a:latin typeface="Arial"/>
-              </a:rPr>
-              <a:t>תקציב המצגת הוא 10:30 דקות לשקפים, 3 דקות להדגמה נפרדת ועוד 1:30 לשאלות. לתרגל מראש תשובות: למה יש שרת? מתי נפתח Socket? מי מאשר מהלך? איך BOT בוחרת? איך נמנעת שמירה כפולה? מה ההבדל בין גיבוב סיסמה להצפנת התקשורת?</a:t>
+              <a:t>להודות למנחה ולקהל ולהזמין שאלות. אפשר להשאיר את השקף מוצג בזמן הדיון. ההדגמה מוכנה בנפרד ואינה שקף במצגת.</a:t>
             </a:r>
           </a:p>
         </p:txBody>
@@ -4939,7 +4843,7 @@
               </a:defRPr>
             </a:pPr>
             <a:r>
-              <a:t>01 / 10</a:t>
+              <a:t>01 / 09</a:t>
             </a:r>
           </a:p>
         </p:txBody>
@@ -5280,1388 +5184,6 @@
             </a:pPr>
             <a:r>
               <a:t>Supervisor: Inbal Ronen</a:t>
-            </a:r>
-          </a:p>
-        </p:txBody>
-      </p:sp>
-    </p:spTree>
-  </p:cSld>
-  <p:clrMapOvr>
-    <a:masterClrMapping/>
-  </p:clrMapOvr>
-</p:sld>
-</file>
-
-<file path=ppt/slides/slide10.xml><?xml version="1.0" encoding="utf-8"?>
-<p:sld xmlns:a="http://schemas.openxmlformats.org/drawingml/2006/main" xmlns:p="http://schemas.openxmlformats.org/presentationml/2006/main" xmlns:r="http://schemas.openxmlformats.org/officeDocument/2006/relationships">
-  <p:cSld>
-    <p:bg>
-      <p:bgPr>
-        <a:solidFill>
-          <a:srgbClr val="F6F8F4"/>
-        </a:solidFill>
-        <a:effectLst/>
-      </p:bgPr>
-    </p:bg>
-    <p:spTree>
-      <p:nvGrpSpPr>
-        <p:cNvPr id="1" name=""/>
-        <p:cNvGrpSpPr/>
-        <p:nvPr/>
-      </p:nvGrpSpPr>
-      <p:grpSpPr/>
-      <p:sp>
-        <p:nvSpPr>
-          <p:cNvPr id="2" name="TextBox 1"/>
-          <p:cNvSpPr txBox="1"/>
-          <p:nvPr/>
-        </p:nvSpPr>
-        <p:spPr>
-          <a:xfrm>
-            <a:off x="502920" y="219456"/>
-            <a:ext cx="1828800" cy="274320"/>
-          </a:xfrm>
-          <a:prstGeom prst="rect">
-            <a:avLst/>
-          </a:prstGeom>
-          <a:noFill/>
-        </p:spPr>
-        <p:txBody>
-          <a:bodyPr wrap="square" lIns="0" rIns="0" tIns="0" bIns="0">
-            <a:noAutofit/>
-          </a:bodyPr>
-          <a:lstStyle/>
-          <a:p>
-            <a:pPr algn="l">
-              <a:lnSpc>
-                <a:spcPct val="106000"/>
-              </a:lnSpc>
-              <a:spcBef>
-                <a:spcPts val="0"/>
-              </a:spcBef>
-              <a:spcAft>
-                <a:spcPts val="400"/>
-              </a:spcAft>
-              <a:defRPr sz="1500" b="1">
-                <a:solidFill>
-                  <a:srgbClr val="285942"/>
-                </a:solidFill>
-                <a:latin typeface="Arial"/>
-              </a:defRPr>
-            </a:pPr>
-            <a:r>
-              <a:t>DAMKA</a:t>
-            </a:r>
-          </a:p>
-        </p:txBody>
-      </p:sp>
-      <p:sp>
-        <p:nvSpPr>
-          <p:cNvPr id="3" name="TextBox 2"/>
-          <p:cNvSpPr txBox="1"/>
-          <p:nvPr/>
-        </p:nvSpPr>
-        <p:spPr>
-          <a:xfrm>
-            <a:off x="7315200" y="219456"/>
-            <a:ext cx="4370832" cy="274320"/>
-          </a:xfrm>
-          <a:prstGeom prst="rect">
-            <a:avLst/>
-          </a:prstGeom>
-          <a:noFill/>
-        </p:spPr>
-        <p:txBody>
-          <a:bodyPr wrap="square" lIns="0" rIns="0" tIns="0" bIns="0">
-            <a:noAutofit/>
-          </a:bodyPr>
-          <a:lstStyle/>
-          <a:p>
-            <a:pPr algn="r">
-              <a:lnSpc>
-                <a:spcPct val="106000"/>
-              </a:lnSpc>
-              <a:spcBef>
-                <a:spcPts val="0"/>
-              </a:spcBef>
-              <a:spcAft>
-                <a:spcPts val="400"/>
-              </a:spcAft>
-              <a:defRPr sz="1300" b="0">
-                <a:solidFill>
-                  <a:srgbClr val="425D50"/>
-                </a:solidFill>
-                <a:latin typeface="Arial"/>
-              </a:defRPr>
-            </a:pPr>
-            <a:r>
-              <a:t>THANK YOU</a:t>
-            </a:r>
-          </a:p>
-        </p:txBody>
-      </p:sp>
-      <p:cxnSp>
-        <p:nvCxnSpPr>
-          <p:cNvPr id="4" name="Connector 3"/>
-          <p:cNvCxnSpPr/>
-          <p:nvPr/>
-        </p:nvCxnSpPr>
-        <p:spPr>
-          <a:xfrm>
-            <a:off x="502920" y="694944"/>
-            <a:ext cx="11183112" cy="0"/>
-          </a:xfrm>
-          <a:prstGeom prst="line">
-            <a:avLst/>
-          </a:prstGeom>
-          <a:ln w="12700">
-            <a:solidFill>
-              <a:srgbClr val="CBD8CF"/>
-            </a:solidFill>
-          </a:ln>
-          <a:effectLst/>
-        </p:spPr>
-        <p:style>
-          <a:lnRef idx="2">
-            <a:schemeClr val="accent1"/>
-          </a:lnRef>
-          <a:fillRef idx="0">
-            <a:schemeClr val="accent1"/>
-          </a:fillRef>
-          <a:effectRef idx="0">
-            <a:schemeClr val="accent1"/>
-          </a:effectRef>
-          <a:fontRef idx="minor">
-            <a:schemeClr val="tx1"/>
-          </a:fontRef>
-        </p:style>
-      </p:cxnSp>
-      <p:sp>
-        <p:nvSpPr>
-          <p:cNvPr id="5" name="Rectangle 4"/>
-          <p:cNvSpPr/>
-          <p:nvPr/>
-        </p:nvSpPr>
-        <p:spPr>
-          <a:xfrm>
-            <a:off x="502920" y="667512"/>
-            <a:ext cx="1005840" cy="50292"/>
-          </a:xfrm>
-          <a:prstGeom prst="rect">
-            <a:avLst/>
-          </a:prstGeom>
-          <a:solidFill>
-            <a:srgbClr val="285942"/>
-          </a:solidFill>
-          <a:ln>
-            <a:noFill/>
-          </a:ln>
-          <a:effectLst/>
-        </p:spPr>
-        <p:style>
-          <a:lnRef idx="1">
-            <a:schemeClr val="accent1"/>
-          </a:lnRef>
-          <a:fillRef idx="3">
-            <a:schemeClr val="accent1"/>
-          </a:fillRef>
-          <a:effectRef idx="0">
-            <a:schemeClr val="accent1"/>
-          </a:effectRef>
-          <a:fontRef idx="minor">
-            <a:schemeClr val="lt1"/>
-          </a:fontRef>
-        </p:style>
-        <p:txBody>
-          <a:bodyPr rtlCol="0" anchor="ctr"/>
-          <a:lstStyle/>
-          <a:p>
-            <a:pPr algn="ctr"/>
-          </a:p>
-        </p:txBody>
-      </p:sp>
-      <p:sp>
-        <p:nvSpPr>
-          <p:cNvPr id="6" name="TextBox 5"/>
-          <p:cNvSpPr txBox="1"/>
-          <p:nvPr/>
-        </p:nvSpPr>
-        <p:spPr>
-          <a:xfrm>
-            <a:off x="502920" y="932688"/>
-            <a:ext cx="11183112" cy="777240"/>
-          </a:xfrm>
-          <a:prstGeom prst="rect">
-            <a:avLst/>
-          </a:prstGeom>
-          <a:noFill/>
-        </p:spPr>
-        <p:txBody>
-          <a:bodyPr wrap="square" lIns="0" rIns="0" tIns="0" bIns="0">
-            <a:noAutofit/>
-          </a:bodyPr>
-          <a:lstStyle/>
-          <a:p>
-            <a:pPr algn="l">
-              <a:lnSpc>
-                <a:spcPct val="106000"/>
-              </a:lnSpc>
-              <a:spcBef>
-                <a:spcPts val="0"/>
-              </a:spcBef>
-              <a:spcAft>
-                <a:spcPts val="400"/>
-              </a:spcAft>
-              <a:defRPr sz="3700" b="1">
-                <a:solidFill>
-                  <a:srgbClr val="153B2D"/>
-                </a:solidFill>
-                <a:latin typeface="Arial"/>
-              </a:defRPr>
-            </a:pPr>
-          </a:p>
-        </p:txBody>
-      </p:sp>
-      <p:cxnSp>
-        <p:nvCxnSpPr>
-          <p:cNvPr id="7" name="Connector 6"/>
-          <p:cNvCxnSpPr/>
-          <p:nvPr/>
-        </p:nvCxnSpPr>
-        <p:spPr>
-          <a:xfrm>
-            <a:off x="502920" y="6437376"/>
-            <a:ext cx="11183112" cy="0"/>
-          </a:xfrm>
-          <a:prstGeom prst="line">
-            <a:avLst/>
-          </a:prstGeom>
-          <a:ln w="10160">
-            <a:solidFill>
-              <a:srgbClr val="CBD8CF"/>
-            </a:solidFill>
-          </a:ln>
-          <a:effectLst/>
-        </p:spPr>
-        <p:style>
-          <a:lnRef idx="2">
-            <a:schemeClr val="accent1"/>
-          </a:lnRef>
-          <a:fillRef idx="0">
-            <a:schemeClr val="accent1"/>
-          </a:fillRef>
-          <a:effectRef idx="0">
-            <a:schemeClr val="accent1"/>
-          </a:effectRef>
-          <a:fontRef idx="minor">
-            <a:schemeClr val="tx1"/>
-          </a:fontRef>
-        </p:style>
-      </p:cxnSp>
-      <p:sp>
-        <p:nvSpPr>
-          <p:cNvPr id="8" name="TextBox 7"/>
-          <p:cNvSpPr txBox="1"/>
-          <p:nvPr/>
-        </p:nvSpPr>
-        <p:spPr>
-          <a:xfrm>
-            <a:off x="502920" y="6528816"/>
-            <a:ext cx="7315200" cy="182880"/>
-          </a:xfrm>
-          <a:prstGeom prst="rect">
-            <a:avLst/>
-          </a:prstGeom>
-          <a:noFill/>
-        </p:spPr>
-        <p:txBody>
-          <a:bodyPr wrap="square" lIns="0" rIns="0" tIns="0" bIns="0">
-            <a:noAutofit/>
-          </a:bodyPr>
-          <a:lstStyle/>
-          <a:p>
-            <a:pPr algn="l">
-              <a:lnSpc>
-                <a:spcPct val="106000"/>
-              </a:lnSpc>
-              <a:spcBef>
-                <a:spcPts val="0"/>
-              </a:spcBef>
-              <a:spcAft>
-                <a:spcPts val="400"/>
-              </a:spcAft>
-              <a:defRPr sz="1000" b="0">
-                <a:solidFill>
-                  <a:srgbClr val="425D50"/>
-                </a:solidFill>
-                <a:latin typeface="Arial"/>
-              </a:defRPr>
-            </a:pPr>
-            <a:r>
-              <a:t>DAMKA  /  FINAL PROJECT</a:t>
-            </a:r>
-          </a:p>
-        </p:txBody>
-      </p:sp>
-      <p:sp>
-        <p:nvSpPr>
-          <p:cNvPr id="9" name="TextBox 8"/>
-          <p:cNvSpPr txBox="1"/>
-          <p:nvPr/>
-        </p:nvSpPr>
-        <p:spPr>
-          <a:xfrm>
-            <a:off x="10698480" y="6510528"/>
-            <a:ext cx="987552" cy="228600"/>
-          </a:xfrm>
-          <a:prstGeom prst="rect">
-            <a:avLst/>
-          </a:prstGeom>
-          <a:noFill/>
-        </p:spPr>
-        <p:txBody>
-          <a:bodyPr wrap="square" lIns="0" rIns="0" tIns="0" bIns="0">
-            <a:noAutofit/>
-          </a:bodyPr>
-          <a:lstStyle/>
-          <a:p>
-            <a:pPr algn="r">
-              <a:lnSpc>
-                <a:spcPct val="106000"/>
-              </a:lnSpc>
-              <a:spcBef>
-                <a:spcPts val="0"/>
-              </a:spcBef>
-              <a:spcAft>
-                <a:spcPts val="400"/>
-              </a:spcAft>
-              <a:defRPr sz="1200" b="0">
-                <a:solidFill>
-                  <a:srgbClr val="425D50"/>
-                </a:solidFill>
-                <a:latin typeface="Arial"/>
-              </a:defRPr>
-            </a:pPr>
-            <a:r>
-              <a:t>10 / 10</a:t>
-            </a:r>
-          </a:p>
-        </p:txBody>
-      </p:sp>
-      <p:sp>
-        <p:nvSpPr>
-          <p:cNvPr id="10" name="Rectangle 9"/>
-          <p:cNvSpPr/>
-          <p:nvPr/>
-        </p:nvSpPr>
-        <p:spPr>
-          <a:xfrm>
-            <a:off x="9034272" y="2423160"/>
-            <a:ext cx="475488" cy="475488"/>
-          </a:xfrm>
-          <a:prstGeom prst="rect">
-            <a:avLst/>
-          </a:prstGeom>
-          <a:solidFill>
-            <a:srgbClr val="E8F0E7"/>
-          </a:solidFill>
-          <a:ln>
-            <a:noFill/>
-          </a:ln>
-          <a:effectLst/>
-        </p:spPr>
-        <p:style>
-          <a:lnRef idx="1">
-            <a:schemeClr val="accent1"/>
-          </a:lnRef>
-          <a:fillRef idx="3">
-            <a:schemeClr val="accent1"/>
-          </a:fillRef>
-          <a:effectRef idx="0">
-            <a:schemeClr val="accent1"/>
-          </a:effectRef>
-          <a:fontRef idx="minor">
-            <a:schemeClr val="lt1"/>
-          </a:fontRef>
-        </p:style>
-        <p:txBody>
-          <a:bodyPr rtlCol="0" anchor="ctr"/>
-          <a:lstStyle/>
-          <a:p>
-            <a:pPr algn="ctr"/>
-          </a:p>
-        </p:txBody>
-      </p:sp>
-      <p:sp>
-        <p:nvSpPr>
-          <p:cNvPr id="11" name="Rectangle 10"/>
-          <p:cNvSpPr/>
-          <p:nvPr/>
-        </p:nvSpPr>
-        <p:spPr>
-          <a:xfrm>
-            <a:off x="9509760" y="2423160"/>
-            <a:ext cx="475488" cy="475488"/>
-          </a:xfrm>
-          <a:prstGeom prst="rect">
-            <a:avLst/>
-          </a:prstGeom>
-          <a:solidFill>
-            <a:srgbClr val="285942"/>
-          </a:solidFill>
-          <a:ln>
-            <a:noFill/>
-          </a:ln>
-          <a:effectLst/>
-        </p:spPr>
-        <p:style>
-          <a:lnRef idx="1">
-            <a:schemeClr val="accent1"/>
-          </a:lnRef>
-          <a:fillRef idx="3">
-            <a:schemeClr val="accent1"/>
-          </a:fillRef>
-          <a:effectRef idx="0">
-            <a:schemeClr val="accent1"/>
-          </a:effectRef>
-          <a:fontRef idx="minor">
-            <a:schemeClr val="lt1"/>
-          </a:fontRef>
-        </p:style>
-        <p:txBody>
-          <a:bodyPr rtlCol="0" anchor="ctr"/>
-          <a:lstStyle/>
-          <a:p>
-            <a:pPr algn="ctr"/>
-          </a:p>
-        </p:txBody>
-      </p:sp>
-      <p:sp>
-        <p:nvSpPr>
-          <p:cNvPr id="12" name="Rectangle 11"/>
-          <p:cNvSpPr/>
-          <p:nvPr/>
-        </p:nvSpPr>
-        <p:spPr>
-          <a:xfrm>
-            <a:off x="9985248" y="2423160"/>
-            <a:ext cx="475488" cy="475488"/>
-          </a:xfrm>
-          <a:prstGeom prst="rect">
-            <a:avLst/>
-          </a:prstGeom>
-          <a:solidFill>
-            <a:srgbClr val="E8F0E7"/>
-          </a:solidFill>
-          <a:ln>
-            <a:noFill/>
-          </a:ln>
-          <a:effectLst/>
-        </p:spPr>
-        <p:style>
-          <a:lnRef idx="1">
-            <a:schemeClr val="accent1"/>
-          </a:lnRef>
-          <a:fillRef idx="3">
-            <a:schemeClr val="accent1"/>
-          </a:fillRef>
-          <a:effectRef idx="0">
-            <a:schemeClr val="accent1"/>
-          </a:effectRef>
-          <a:fontRef idx="minor">
-            <a:schemeClr val="lt1"/>
-          </a:fontRef>
-        </p:style>
-        <p:txBody>
-          <a:bodyPr rtlCol="0" anchor="ctr"/>
-          <a:lstStyle/>
-          <a:p>
-            <a:pPr algn="ctr"/>
-          </a:p>
-        </p:txBody>
-      </p:sp>
-      <p:sp>
-        <p:nvSpPr>
-          <p:cNvPr id="13" name="Rectangle 12"/>
-          <p:cNvSpPr/>
-          <p:nvPr/>
-        </p:nvSpPr>
-        <p:spPr>
-          <a:xfrm>
-            <a:off x="10460736" y="2423160"/>
-            <a:ext cx="475488" cy="475488"/>
-          </a:xfrm>
-          <a:prstGeom prst="rect">
-            <a:avLst/>
-          </a:prstGeom>
-          <a:solidFill>
-            <a:srgbClr val="285942"/>
-          </a:solidFill>
-          <a:ln>
-            <a:noFill/>
-          </a:ln>
-          <a:effectLst/>
-        </p:spPr>
-        <p:style>
-          <a:lnRef idx="1">
-            <a:schemeClr val="accent1"/>
-          </a:lnRef>
-          <a:fillRef idx="3">
-            <a:schemeClr val="accent1"/>
-          </a:fillRef>
-          <a:effectRef idx="0">
-            <a:schemeClr val="accent1"/>
-          </a:effectRef>
-          <a:fontRef idx="minor">
-            <a:schemeClr val="lt1"/>
-          </a:fontRef>
-        </p:style>
-        <p:txBody>
-          <a:bodyPr rtlCol="0" anchor="ctr"/>
-          <a:lstStyle/>
-          <a:p>
-            <a:pPr algn="ctr"/>
-          </a:p>
-        </p:txBody>
-      </p:sp>
-      <p:sp>
-        <p:nvSpPr>
-          <p:cNvPr id="14" name="Rectangle 13"/>
-          <p:cNvSpPr/>
-          <p:nvPr/>
-        </p:nvSpPr>
-        <p:spPr>
-          <a:xfrm>
-            <a:off x="9034272" y="2898648"/>
-            <a:ext cx="475488" cy="475488"/>
-          </a:xfrm>
-          <a:prstGeom prst="rect">
-            <a:avLst/>
-          </a:prstGeom>
-          <a:solidFill>
-            <a:srgbClr val="285942"/>
-          </a:solidFill>
-          <a:ln>
-            <a:noFill/>
-          </a:ln>
-          <a:effectLst/>
-        </p:spPr>
-        <p:style>
-          <a:lnRef idx="1">
-            <a:schemeClr val="accent1"/>
-          </a:lnRef>
-          <a:fillRef idx="3">
-            <a:schemeClr val="accent1"/>
-          </a:fillRef>
-          <a:effectRef idx="0">
-            <a:schemeClr val="accent1"/>
-          </a:effectRef>
-          <a:fontRef idx="minor">
-            <a:schemeClr val="lt1"/>
-          </a:fontRef>
-        </p:style>
-        <p:txBody>
-          <a:bodyPr rtlCol="0" anchor="ctr"/>
-          <a:lstStyle/>
-          <a:p>
-            <a:pPr algn="ctr"/>
-          </a:p>
-        </p:txBody>
-      </p:sp>
-      <p:sp>
-        <p:nvSpPr>
-          <p:cNvPr id="15" name="Rectangle 14"/>
-          <p:cNvSpPr/>
-          <p:nvPr/>
-        </p:nvSpPr>
-        <p:spPr>
-          <a:xfrm>
-            <a:off x="9509760" y="2898648"/>
-            <a:ext cx="475488" cy="475488"/>
-          </a:xfrm>
-          <a:prstGeom prst="rect">
-            <a:avLst/>
-          </a:prstGeom>
-          <a:solidFill>
-            <a:srgbClr val="E8F0E7"/>
-          </a:solidFill>
-          <a:ln>
-            <a:noFill/>
-          </a:ln>
-          <a:effectLst/>
-        </p:spPr>
-        <p:style>
-          <a:lnRef idx="1">
-            <a:schemeClr val="accent1"/>
-          </a:lnRef>
-          <a:fillRef idx="3">
-            <a:schemeClr val="accent1"/>
-          </a:fillRef>
-          <a:effectRef idx="0">
-            <a:schemeClr val="accent1"/>
-          </a:effectRef>
-          <a:fontRef idx="minor">
-            <a:schemeClr val="lt1"/>
-          </a:fontRef>
-        </p:style>
-        <p:txBody>
-          <a:bodyPr rtlCol="0" anchor="ctr"/>
-          <a:lstStyle/>
-          <a:p>
-            <a:pPr algn="ctr"/>
-          </a:p>
-        </p:txBody>
-      </p:sp>
-      <p:sp>
-        <p:nvSpPr>
-          <p:cNvPr id="16" name="Rectangle 15"/>
-          <p:cNvSpPr/>
-          <p:nvPr/>
-        </p:nvSpPr>
-        <p:spPr>
-          <a:xfrm>
-            <a:off x="9985248" y="2898648"/>
-            <a:ext cx="475488" cy="475488"/>
-          </a:xfrm>
-          <a:prstGeom prst="rect">
-            <a:avLst/>
-          </a:prstGeom>
-          <a:solidFill>
-            <a:srgbClr val="285942"/>
-          </a:solidFill>
-          <a:ln>
-            <a:noFill/>
-          </a:ln>
-          <a:effectLst/>
-        </p:spPr>
-        <p:style>
-          <a:lnRef idx="1">
-            <a:schemeClr val="accent1"/>
-          </a:lnRef>
-          <a:fillRef idx="3">
-            <a:schemeClr val="accent1"/>
-          </a:fillRef>
-          <a:effectRef idx="0">
-            <a:schemeClr val="accent1"/>
-          </a:effectRef>
-          <a:fontRef idx="minor">
-            <a:schemeClr val="lt1"/>
-          </a:fontRef>
-        </p:style>
-        <p:txBody>
-          <a:bodyPr rtlCol="0" anchor="ctr"/>
-          <a:lstStyle/>
-          <a:p>
-            <a:pPr algn="ctr"/>
-          </a:p>
-        </p:txBody>
-      </p:sp>
-      <p:sp>
-        <p:nvSpPr>
-          <p:cNvPr id="17" name="Rectangle 16"/>
-          <p:cNvSpPr/>
-          <p:nvPr/>
-        </p:nvSpPr>
-        <p:spPr>
-          <a:xfrm>
-            <a:off x="10460736" y="2898648"/>
-            <a:ext cx="475488" cy="475488"/>
-          </a:xfrm>
-          <a:prstGeom prst="rect">
-            <a:avLst/>
-          </a:prstGeom>
-          <a:solidFill>
-            <a:srgbClr val="E8F0E7"/>
-          </a:solidFill>
-          <a:ln>
-            <a:noFill/>
-          </a:ln>
-          <a:effectLst/>
-        </p:spPr>
-        <p:style>
-          <a:lnRef idx="1">
-            <a:schemeClr val="accent1"/>
-          </a:lnRef>
-          <a:fillRef idx="3">
-            <a:schemeClr val="accent1"/>
-          </a:fillRef>
-          <a:effectRef idx="0">
-            <a:schemeClr val="accent1"/>
-          </a:effectRef>
-          <a:fontRef idx="minor">
-            <a:schemeClr val="lt1"/>
-          </a:fontRef>
-        </p:style>
-        <p:txBody>
-          <a:bodyPr rtlCol="0" anchor="ctr"/>
-          <a:lstStyle/>
-          <a:p>
-            <a:pPr algn="ctr"/>
-          </a:p>
-        </p:txBody>
-      </p:sp>
-      <p:sp>
-        <p:nvSpPr>
-          <p:cNvPr id="18" name="Rectangle 17"/>
-          <p:cNvSpPr/>
-          <p:nvPr/>
-        </p:nvSpPr>
-        <p:spPr>
-          <a:xfrm>
-            <a:off x="9034272" y="3374136"/>
-            <a:ext cx="475488" cy="475488"/>
-          </a:xfrm>
-          <a:prstGeom prst="rect">
-            <a:avLst/>
-          </a:prstGeom>
-          <a:solidFill>
-            <a:srgbClr val="E8F0E7"/>
-          </a:solidFill>
-          <a:ln>
-            <a:noFill/>
-          </a:ln>
-          <a:effectLst/>
-        </p:spPr>
-        <p:style>
-          <a:lnRef idx="1">
-            <a:schemeClr val="accent1"/>
-          </a:lnRef>
-          <a:fillRef idx="3">
-            <a:schemeClr val="accent1"/>
-          </a:fillRef>
-          <a:effectRef idx="0">
-            <a:schemeClr val="accent1"/>
-          </a:effectRef>
-          <a:fontRef idx="minor">
-            <a:schemeClr val="lt1"/>
-          </a:fontRef>
-        </p:style>
-        <p:txBody>
-          <a:bodyPr rtlCol="0" anchor="ctr"/>
-          <a:lstStyle/>
-          <a:p>
-            <a:pPr algn="ctr"/>
-          </a:p>
-        </p:txBody>
-      </p:sp>
-      <p:sp>
-        <p:nvSpPr>
-          <p:cNvPr id="19" name="Rectangle 18"/>
-          <p:cNvSpPr/>
-          <p:nvPr/>
-        </p:nvSpPr>
-        <p:spPr>
-          <a:xfrm>
-            <a:off x="9509760" y="3374136"/>
-            <a:ext cx="475488" cy="475488"/>
-          </a:xfrm>
-          <a:prstGeom prst="rect">
-            <a:avLst/>
-          </a:prstGeom>
-          <a:solidFill>
-            <a:srgbClr val="285942"/>
-          </a:solidFill>
-          <a:ln>
-            <a:noFill/>
-          </a:ln>
-          <a:effectLst/>
-        </p:spPr>
-        <p:style>
-          <a:lnRef idx="1">
-            <a:schemeClr val="accent1"/>
-          </a:lnRef>
-          <a:fillRef idx="3">
-            <a:schemeClr val="accent1"/>
-          </a:fillRef>
-          <a:effectRef idx="0">
-            <a:schemeClr val="accent1"/>
-          </a:effectRef>
-          <a:fontRef idx="minor">
-            <a:schemeClr val="lt1"/>
-          </a:fontRef>
-        </p:style>
-        <p:txBody>
-          <a:bodyPr rtlCol="0" anchor="ctr"/>
-          <a:lstStyle/>
-          <a:p>
-            <a:pPr algn="ctr"/>
-          </a:p>
-        </p:txBody>
-      </p:sp>
-      <p:sp>
-        <p:nvSpPr>
-          <p:cNvPr id="20" name="Rectangle 19"/>
-          <p:cNvSpPr/>
-          <p:nvPr/>
-        </p:nvSpPr>
-        <p:spPr>
-          <a:xfrm>
-            <a:off x="9985248" y="3374136"/>
-            <a:ext cx="475488" cy="475488"/>
-          </a:xfrm>
-          <a:prstGeom prst="rect">
-            <a:avLst/>
-          </a:prstGeom>
-          <a:solidFill>
-            <a:srgbClr val="E8F0E7"/>
-          </a:solidFill>
-          <a:ln>
-            <a:noFill/>
-          </a:ln>
-          <a:effectLst/>
-        </p:spPr>
-        <p:style>
-          <a:lnRef idx="1">
-            <a:schemeClr val="accent1"/>
-          </a:lnRef>
-          <a:fillRef idx="3">
-            <a:schemeClr val="accent1"/>
-          </a:fillRef>
-          <a:effectRef idx="0">
-            <a:schemeClr val="accent1"/>
-          </a:effectRef>
-          <a:fontRef idx="minor">
-            <a:schemeClr val="lt1"/>
-          </a:fontRef>
-        </p:style>
-        <p:txBody>
-          <a:bodyPr rtlCol="0" anchor="ctr"/>
-          <a:lstStyle/>
-          <a:p>
-            <a:pPr algn="ctr"/>
-          </a:p>
-        </p:txBody>
-      </p:sp>
-      <p:sp>
-        <p:nvSpPr>
-          <p:cNvPr id="21" name="Rectangle 20"/>
-          <p:cNvSpPr/>
-          <p:nvPr/>
-        </p:nvSpPr>
-        <p:spPr>
-          <a:xfrm>
-            <a:off x="10460736" y="3374136"/>
-            <a:ext cx="475488" cy="475488"/>
-          </a:xfrm>
-          <a:prstGeom prst="rect">
-            <a:avLst/>
-          </a:prstGeom>
-          <a:solidFill>
-            <a:srgbClr val="285942"/>
-          </a:solidFill>
-          <a:ln>
-            <a:noFill/>
-          </a:ln>
-          <a:effectLst/>
-        </p:spPr>
-        <p:style>
-          <a:lnRef idx="1">
-            <a:schemeClr val="accent1"/>
-          </a:lnRef>
-          <a:fillRef idx="3">
-            <a:schemeClr val="accent1"/>
-          </a:fillRef>
-          <a:effectRef idx="0">
-            <a:schemeClr val="accent1"/>
-          </a:effectRef>
-          <a:fontRef idx="minor">
-            <a:schemeClr val="lt1"/>
-          </a:fontRef>
-        </p:style>
-        <p:txBody>
-          <a:bodyPr rtlCol="0" anchor="ctr"/>
-          <a:lstStyle/>
-          <a:p>
-            <a:pPr algn="ctr"/>
-          </a:p>
-        </p:txBody>
-      </p:sp>
-      <p:sp>
-        <p:nvSpPr>
-          <p:cNvPr id="22" name="Rectangle 21"/>
-          <p:cNvSpPr/>
-          <p:nvPr/>
-        </p:nvSpPr>
-        <p:spPr>
-          <a:xfrm>
-            <a:off x="9034272" y="3849624"/>
-            <a:ext cx="475488" cy="475488"/>
-          </a:xfrm>
-          <a:prstGeom prst="rect">
-            <a:avLst/>
-          </a:prstGeom>
-          <a:solidFill>
-            <a:srgbClr val="285942"/>
-          </a:solidFill>
-          <a:ln>
-            <a:noFill/>
-          </a:ln>
-          <a:effectLst/>
-        </p:spPr>
-        <p:style>
-          <a:lnRef idx="1">
-            <a:schemeClr val="accent1"/>
-          </a:lnRef>
-          <a:fillRef idx="3">
-            <a:schemeClr val="accent1"/>
-          </a:fillRef>
-          <a:effectRef idx="0">
-            <a:schemeClr val="accent1"/>
-          </a:effectRef>
-          <a:fontRef idx="minor">
-            <a:schemeClr val="lt1"/>
-          </a:fontRef>
-        </p:style>
-        <p:txBody>
-          <a:bodyPr rtlCol="0" anchor="ctr"/>
-          <a:lstStyle/>
-          <a:p>
-            <a:pPr algn="ctr"/>
-          </a:p>
-        </p:txBody>
-      </p:sp>
-      <p:sp>
-        <p:nvSpPr>
-          <p:cNvPr id="23" name="Rectangle 22"/>
-          <p:cNvSpPr/>
-          <p:nvPr/>
-        </p:nvSpPr>
-        <p:spPr>
-          <a:xfrm>
-            <a:off x="9509760" y="3849624"/>
-            <a:ext cx="475488" cy="475488"/>
-          </a:xfrm>
-          <a:prstGeom prst="rect">
-            <a:avLst/>
-          </a:prstGeom>
-          <a:solidFill>
-            <a:srgbClr val="E8F0E7"/>
-          </a:solidFill>
-          <a:ln>
-            <a:noFill/>
-          </a:ln>
-          <a:effectLst/>
-        </p:spPr>
-        <p:style>
-          <a:lnRef idx="1">
-            <a:schemeClr val="accent1"/>
-          </a:lnRef>
-          <a:fillRef idx="3">
-            <a:schemeClr val="accent1"/>
-          </a:fillRef>
-          <a:effectRef idx="0">
-            <a:schemeClr val="accent1"/>
-          </a:effectRef>
-          <a:fontRef idx="minor">
-            <a:schemeClr val="lt1"/>
-          </a:fontRef>
-        </p:style>
-        <p:txBody>
-          <a:bodyPr rtlCol="0" anchor="ctr"/>
-          <a:lstStyle/>
-          <a:p>
-            <a:pPr algn="ctr"/>
-          </a:p>
-        </p:txBody>
-      </p:sp>
-      <p:sp>
-        <p:nvSpPr>
-          <p:cNvPr id="24" name="Rectangle 23"/>
-          <p:cNvSpPr/>
-          <p:nvPr/>
-        </p:nvSpPr>
-        <p:spPr>
-          <a:xfrm>
-            <a:off x="9985248" y="3849624"/>
-            <a:ext cx="475488" cy="475488"/>
-          </a:xfrm>
-          <a:prstGeom prst="rect">
-            <a:avLst/>
-          </a:prstGeom>
-          <a:solidFill>
-            <a:srgbClr val="285942"/>
-          </a:solidFill>
-          <a:ln>
-            <a:noFill/>
-          </a:ln>
-          <a:effectLst/>
-        </p:spPr>
-        <p:style>
-          <a:lnRef idx="1">
-            <a:schemeClr val="accent1"/>
-          </a:lnRef>
-          <a:fillRef idx="3">
-            <a:schemeClr val="accent1"/>
-          </a:fillRef>
-          <a:effectRef idx="0">
-            <a:schemeClr val="accent1"/>
-          </a:effectRef>
-          <a:fontRef idx="minor">
-            <a:schemeClr val="lt1"/>
-          </a:fontRef>
-        </p:style>
-        <p:txBody>
-          <a:bodyPr rtlCol="0" anchor="ctr"/>
-          <a:lstStyle/>
-          <a:p>
-            <a:pPr algn="ctr"/>
-          </a:p>
-        </p:txBody>
-      </p:sp>
-      <p:sp>
-        <p:nvSpPr>
-          <p:cNvPr id="25" name="Rectangle 24"/>
-          <p:cNvSpPr/>
-          <p:nvPr/>
-        </p:nvSpPr>
-        <p:spPr>
-          <a:xfrm>
-            <a:off x="10460736" y="3849624"/>
-            <a:ext cx="475488" cy="475488"/>
-          </a:xfrm>
-          <a:prstGeom prst="rect">
-            <a:avLst/>
-          </a:prstGeom>
-          <a:solidFill>
-            <a:srgbClr val="E8F0E7"/>
-          </a:solidFill>
-          <a:ln>
-            <a:noFill/>
-          </a:ln>
-          <a:effectLst/>
-        </p:spPr>
-        <p:style>
-          <a:lnRef idx="1">
-            <a:schemeClr val="accent1"/>
-          </a:lnRef>
-          <a:fillRef idx="3">
-            <a:schemeClr val="accent1"/>
-          </a:fillRef>
-          <a:effectRef idx="0">
-            <a:schemeClr val="accent1"/>
-          </a:effectRef>
-          <a:fontRef idx="minor">
-            <a:schemeClr val="lt1"/>
-          </a:fontRef>
-        </p:style>
-        <p:txBody>
-          <a:bodyPr rtlCol="0" anchor="ctr"/>
-          <a:lstStyle/>
-          <a:p>
-            <a:pPr algn="ctr"/>
-          </a:p>
-        </p:txBody>
-      </p:sp>
-      <p:sp>
-        <p:nvSpPr>
-          <p:cNvPr id="26" name="Oval 25"/>
-          <p:cNvSpPr/>
-          <p:nvPr/>
-        </p:nvSpPr>
-        <p:spPr>
-          <a:xfrm>
-            <a:off x="9134856" y="2999232"/>
-            <a:ext cx="274320" cy="274320"/>
-          </a:xfrm>
-          <a:prstGeom prst="ellipse">
-            <a:avLst/>
-          </a:prstGeom>
-          <a:solidFill>
-            <a:srgbClr val="BD614A"/>
-          </a:solidFill>
-          <a:ln>
-            <a:noFill/>
-          </a:ln>
-          <a:effectLst/>
-        </p:spPr>
-        <p:style>
-          <a:lnRef idx="1">
-            <a:schemeClr val="accent1"/>
-          </a:lnRef>
-          <a:fillRef idx="3">
-            <a:schemeClr val="accent1"/>
-          </a:fillRef>
-          <a:effectRef idx="0">
-            <a:schemeClr val="accent1"/>
-          </a:effectRef>
-          <a:fontRef idx="minor">
-            <a:schemeClr val="lt1"/>
-          </a:fontRef>
-        </p:style>
-        <p:txBody>
-          <a:bodyPr rtlCol="0" anchor="ctr"/>
-          <a:lstStyle/>
-          <a:p>
-            <a:pPr algn="ctr"/>
-          </a:p>
-        </p:txBody>
-      </p:sp>
-      <p:sp>
-        <p:nvSpPr>
-          <p:cNvPr id="27" name="Oval 26"/>
-          <p:cNvSpPr/>
-          <p:nvPr/>
-        </p:nvSpPr>
-        <p:spPr>
-          <a:xfrm>
-            <a:off x="10085832" y="2999232"/>
-            <a:ext cx="274320" cy="274320"/>
-          </a:xfrm>
-          <a:prstGeom prst="ellipse">
-            <a:avLst/>
-          </a:prstGeom>
-          <a:solidFill>
-            <a:srgbClr val="BD614A"/>
-          </a:solidFill>
-          <a:ln>
-            <a:noFill/>
-          </a:ln>
-          <a:effectLst/>
-        </p:spPr>
-        <p:style>
-          <a:lnRef idx="1">
-            <a:schemeClr val="accent1"/>
-          </a:lnRef>
-          <a:fillRef idx="3">
-            <a:schemeClr val="accent1"/>
-          </a:fillRef>
-          <a:effectRef idx="0">
-            <a:schemeClr val="accent1"/>
-          </a:effectRef>
-          <a:fontRef idx="minor">
-            <a:schemeClr val="lt1"/>
-          </a:fontRef>
-        </p:style>
-        <p:txBody>
-          <a:bodyPr rtlCol="0" anchor="ctr"/>
-          <a:lstStyle/>
-          <a:p>
-            <a:pPr algn="ctr"/>
-          </a:p>
-        </p:txBody>
-      </p:sp>
-      <p:sp>
-        <p:nvSpPr>
-          <p:cNvPr id="28" name="Oval 27"/>
-          <p:cNvSpPr/>
-          <p:nvPr/>
-        </p:nvSpPr>
-        <p:spPr>
-          <a:xfrm>
-            <a:off x="9134856" y="3950207"/>
-            <a:ext cx="274320" cy="274320"/>
-          </a:xfrm>
-          <a:prstGeom prst="ellipse">
-            <a:avLst/>
-          </a:prstGeom>
-          <a:solidFill>
-            <a:srgbClr val="9F7624"/>
-          </a:solidFill>
-          <a:ln>
-            <a:noFill/>
-          </a:ln>
-          <a:effectLst/>
-        </p:spPr>
-        <p:style>
-          <a:lnRef idx="1">
-            <a:schemeClr val="accent1"/>
-          </a:lnRef>
-          <a:fillRef idx="3">
-            <a:schemeClr val="accent1"/>
-          </a:fillRef>
-          <a:effectRef idx="0">
-            <a:schemeClr val="accent1"/>
-          </a:effectRef>
-          <a:fontRef idx="minor">
-            <a:schemeClr val="lt1"/>
-          </a:fontRef>
-        </p:style>
-        <p:txBody>
-          <a:bodyPr rtlCol="0" anchor="ctr"/>
-          <a:lstStyle/>
-          <a:p>
-            <a:pPr algn="ctr"/>
-          </a:p>
-        </p:txBody>
-      </p:sp>
-      <p:sp>
-        <p:nvSpPr>
-          <p:cNvPr id="29" name="TextBox 28"/>
-          <p:cNvSpPr txBox="1"/>
-          <p:nvPr/>
-        </p:nvSpPr>
-        <p:spPr>
-          <a:xfrm>
-            <a:off x="685800" y="2148840"/>
-            <a:ext cx="7955279" cy="1051560"/>
-          </a:xfrm>
-          <a:prstGeom prst="rect">
-            <a:avLst/>
-          </a:prstGeom>
-          <a:noFill/>
-        </p:spPr>
-        <p:txBody>
-          <a:bodyPr wrap="square" lIns="0" rIns="0" tIns="0" bIns="0">
-            <a:noAutofit/>
-          </a:bodyPr>
-          <a:lstStyle/>
-          <a:p>
-            <a:pPr algn="l">
-              <a:lnSpc>
-                <a:spcPct val="106000"/>
-              </a:lnSpc>
-              <a:spcBef>
-                <a:spcPts val="0"/>
-              </a:spcBef>
-              <a:spcAft>
-                <a:spcPts val="400"/>
-              </a:spcAft>
-              <a:defRPr sz="6100" b="1">
-                <a:solidFill>
-                  <a:srgbClr val="153B2D"/>
-                </a:solidFill>
-                <a:latin typeface="Arial"/>
-              </a:defRPr>
-            </a:pPr>
-            <a:r>
-              <a:t>THANK YOU</a:t>
-            </a:r>
-          </a:p>
-        </p:txBody>
-      </p:sp>
-      <p:sp>
-        <p:nvSpPr>
-          <p:cNvPr id="30" name="Rectangle 29"/>
-          <p:cNvSpPr/>
-          <p:nvPr/>
-        </p:nvSpPr>
-        <p:spPr>
-          <a:xfrm>
-            <a:off x="713232" y="3557016"/>
-            <a:ext cx="1143000" cy="59436"/>
-          </a:xfrm>
-          <a:prstGeom prst="rect">
-            <a:avLst/>
-          </a:prstGeom>
-          <a:solidFill>
-            <a:srgbClr val="9F7624"/>
-          </a:solidFill>
-          <a:ln>
-            <a:noFill/>
-          </a:ln>
-          <a:effectLst/>
-        </p:spPr>
-        <p:style>
-          <a:lnRef idx="1">
-            <a:schemeClr val="accent1"/>
-          </a:lnRef>
-          <a:fillRef idx="3">
-            <a:schemeClr val="accent1"/>
-          </a:fillRef>
-          <a:effectRef idx="0">
-            <a:schemeClr val="accent1"/>
-          </a:effectRef>
-          <a:fontRef idx="minor">
-            <a:schemeClr val="lt1"/>
-          </a:fontRef>
-        </p:style>
-        <p:txBody>
-          <a:bodyPr rtlCol="0" anchor="ctr"/>
-          <a:lstStyle/>
-          <a:p>
-            <a:pPr algn="ctr"/>
-          </a:p>
-        </p:txBody>
-      </p:sp>
-      <p:sp>
-        <p:nvSpPr>
-          <p:cNvPr id="31" name="TextBox 30"/>
-          <p:cNvSpPr txBox="1"/>
-          <p:nvPr/>
-        </p:nvSpPr>
-        <p:spPr>
-          <a:xfrm>
-            <a:off x="713232" y="3931920"/>
-            <a:ext cx="7772400" cy="658368"/>
-          </a:xfrm>
-          <a:prstGeom prst="rect">
-            <a:avLst/>
-          </a:prstGeom>
-          <a:noFill/>
-        </p:spPr>
-        <p:txBody>
-          <a:bodyPr wrap="square" lIns="0" rIns="0" tIns="0" bIns="0">
-            <a:noAutofit/>
-          </a:bodyPr>
-          <a:lstStyle/>
-          <a:p>
-            <a:pPr algn="l">
-              <a:lnSpc>
-                <a:spcPct val="106000"/>
-              </a:lnSpc>
-              <a:spcBef>
-                <a:spcPts val="0"/>
-              </a:spcBef>
-              <a:spcAft>
-                <a:spcPts val="400"/>
-              </a:spcAft>
-              <a:defRPr sz="2900" b="0">
-                <a:solidFill>
-                  <a:srgbClr val="425D50"/>
-                </a:solidFill>
-                <a:latin typeface="Arial"/>
-              </a:defRPr>
-            </a:pPr>
-            <a:r>
-              <a:t>Questions &amp; discussion</a:t>
-            </a:r>
-          </a:p>
-        </p:txBody>
-      </p:sp>
-      <p:sp>
-        <p:nvSpPr>
-          <p:cNvPr id="32" name="TextBox 31"/>
-          <p:cNvSpPr txBox="1"/>
-          <p:nvPr/>
-        </p:nvSpPr>
-        <p:spPr>
-          <a:xfrm>
-            <a:off x="713232" y="5715000"/>
-            <a:ext cx="10789920" cy="438912"/>
-          </a:xfrm>
-          <a:prstGeom prst="rect">
-            <a:avLst/>
-          </a:prstGeom>
-          <a:noFill/>
-        </p:spPr>
-        <p:txBody>
-          <a:bodyPr wrap="square" lIns="0" rIns="0" tIns="0" bIns="0">
-            <a:noAutofit/>
-          </a:bodyPr>
-          <a:lstStyle/>
-          <a:p>
-            <a:pPr algn="l">
-              <a:lnSpc>
-                <a:spcPct val="106000"/>
-              </a:lnSpc>
-              <a:spcBef>
-                <a:spcPts val="0"/>
-              </a:spcBef>
-              <a:spcAft>
-                <a:spcPts val="400"/>
-              </a:spcAft>
-              <a:defRPr sz="2300" b="0">
-                <a:solidFill>
-                  <a:srgbClr val="285942"/>
-                </a:solidFill>
-                <a:latin typeface="Arial"/>
-              </a:defRPr>
-            </a:pPr>
-            <a:r>
-              <a:rPr>
-                <a:hlinkClick r:id="rId2"/>
-              </a:rPr>
-              <a:t>github.com/MuthannaFrhat/damka-game</a:t>
             </a:r>
           </a:p>
         </p:txBody>
@@ -7028,7 +5550,7 @@
               </a:defRPr>
             </a:pPr>
             <a:r>
-              <a:t>02 / 10</a:t>
+              <a:t>02 / 09</a:t>
             </a:r>
           </a:p>
         </p:txBody>
@@ -8143,7 +6665,7 @@
               </a:defRPr>
             </a:pPr>
             <a:r>
-              <a:t>03 / 10</a:t>
+              <a:t>03 / 09</a:t>
             </a:r>
           </a:p>
         </p:txBody>
@@ -9536,7 +8058,7 @@
               </a:defRPr>
             </a:pPr>
             <a:r>
-              <a:t>04 / 10</a:t>
+              <a:t>04 / 09</a:t>
             </a:r>
           </a:p>
         </p:txBody>
@@ -10818,7 +9340,7 @@
               </a:defRPr>
             </a:pPr>
             <a:r>
-              <a:t>05 / 10</a:t>
+              <a:t>05 / 09</a:t>
             </a:r>
           </a:p>
         </p:txBody>
@@ -12362,7 +10884,7 @@
               </a:defRPr>
             </a:pPr>
             <a:r>
-              <a:t>06 / 10</a:t>
+              <a:t>06 / 09</a:t>
             </a:r>
           </a:p>
         </p:txBody>
@@ -13676,7 +12198,7 @@
               </a:defRPr>
             </a:pPr>
             <a:r>
-              <a:t>07 / 10</a:t>
+              <a:t>07 / 09</a:t>
             </a:r>
           </a:p>
         </p:txBody>
@@ -14269,7 +12791,7 @@
               </a:defRPr>
             </a:pPr>
             <a:r>
-              <a:t>SCOPE</a:t>
+              <a:t>CONCLUSIONS</a:t>
             </a:r>
           </a:p>
         </p:txBody>
@@ -14394,7 +12916,7 @@
               </a:defRPr>
             </a:pPr>
             <a:r>
-              <a:t>Current limits and next step</a:t>
+              <a:t>What we built and learned</a:t>
             </a:r>
           </a:p>
         </p:txBody>
@@ -14520,113 +13042,21 @@
               </a:defRPr>
             </a:pPr>
             <a:r>
-              <a:t>08 / 10</a:t>
-            </a:r>
-          </a:p>
-        </p:txBody>
-      </p:sp>
-      <p:sp>
-        <p:nvSpPr>
-          <p:cNvPr id="10" name="Rounded Rectangle 9"/>
-          <p:cNvSpPr/>
-          <p:nvPr/>
-        </p:nvSpPr>
-        <p:spPr>
-          <a:xfrm>
-            <a:off x="548640" y="1938528"/>
-            <a:ext cx="5367528" cy="2423160"/>
-          </a:xfrm>
-          <a:prstGeom prst="roundRect">
-            <a:avLst>
-              <a:gd name="adj" fmla="val 12000"/>
-            </a:avLst>
-          </a:prstGeom>
-          <a:solidFill>
-            <a:srgbClr val="FFFFFF"/>
-          </a:solidFill>
-          <a:ln w="12700">
-            <a:solidFill>
-              <a:srgbClr val="CBD8CF"/>
-            </a:solidFill>
-          </a:ln>
-          <a:effectLst/>
-        </p:spPr>
-        <p:style>
-          <a:lnRef idx="1">
-            <a:schemeClr val="accent1"/>
-          </a:lnRef>
-          <a:fillRef idx="3">
-            <a:schemeClr val="accent1"/>
-          </a:fillRef>
-          <a:effectRef idx="0">
-            <a:schemeClr val="accent1"/>
-          </a:effectRef>
-          <a:fontRef idx="minor">
-            <a:schemeClr val="lt1"/>
-          </a:fontRef>
-        </p:style>
-        <p:txBody>
-          <a:bodyPr rtlCol="0" anchor="ctr"/>
-          <a:lstStyle/>
-          <a:p>
-            <a:pPr algn="ctr"/>
-          </a:p>
-        </p:txBody>
-      </p:sp>
-      <p:sp>
-        <p:nvSpPr>
-          <p:cNvPr id="11" name="Rectangle 10"/>
-          <p:cNvSpPr/>
-          <p:nvPr/>
-        </p:nvSpPr>
-        <p:spPr>
-          <a:xfrm>
-            <a:off x="566928" y="2139696"/>
-            <a:ext cx="41148" cy="2020824"/>
-          </a:xfrm>
-          <a:prstGeom prst="rect">
-            <a:avLst/>
-          </a:prstGeom>
-          <a:solidFill>
-            <a:srgbClr val="285942"/>
-          </a:solidFill>
-          <a:ln>
-            <a:noFill/>
-          </a:ln>
-          <a:effectLst/>
-        </p:spPr>
-        <p:style>
-          <a:lnRef idx="1">
-            <a:schemeClr val="accent1"/>
-          </a:lnRef>
-          <a:fillRef idx="3">
-            <a:schemeClr val="accent1"/>
-          </a:fillRef>
-          <a:effectRef idx="0">
-            <a:schemeClr val="accent1"/>
-          </a:effectRef>
-          <a:fontRef idx="minor">
-            <a:schemeClr val="lt1"/>
-          </a:fontRef>
-        </p:style>
-        <p:txBody>
-          <a:bodyPr rtlCol="0" anchor="ctr"/>
-          <a:lstStyle/>
-          <a:p>
-            <a:pPr algn="ctr"/>
-          </a:p>
-        </p:txBody>
-      </p:sp>
-      <p:sp>
-        <p:nvSpPr>
-          <p:cNvPr id="12" name="TextBox 11"/>
+              <a:t>08 / 09</a:t>
+            </a:r>
+          </a:p>
+        </p:txBody>
+      </p:sp>
+      <p:sp>
+        <p:nvSpPr>
+          <p:cNvPr id="10" name="TextBox 9"/>
           <p:cNvSpPr txBox="1"/>
           <p:nvPr/>
         </p:nvSpPr>
         <p:spPr>
           <a:xfrm>
-            <a:off x="777240" y="2157984"/>
-            <a:ext cx="4910328" cy="594360"/>
+            <a:off x="594360" y="1901952"/>
+            <a:ext cx="7040880" cy="2148840"/>
           </a:xfrm>
           <a:prstGeom prst="rect">
             <a:avLst/>
@@ -14649,7 +13079,7 @@
               <a:spcAft>
                 <a:spcPts val="400"/>
               </a:spcAft>
-              <a:defRPr sz="2700" b="1">
+              <a:defRPr sz="3300" b="1">
                 <a:solidFill>
                   <a:srgbClr val="153B2D"/>
                 </a:solidFill>
@@ -14657,32 +13087,9 @@
               </a:defRPr>
             </a:pPr>
             <a:r>
-              <a:t>No match resume</a:t>
-            </a:r>
-          </a:p>
-        </p:txBody>
-      </p:sp>
-      <p:sp>
-        <p:nvSpPr>
-          <p:cNvPr id="13" name="TextBox 12"/>
-          <p:cNvSpPr txBox="1"/>
-          <p:nvPr/>
-        </p:nvSpPr>
-        <p:spPr>
-          <a:xfrm>
-            <a:off x="777240" y="2898648"/>
-            <a:ext cx="4910328" cy="1307592"/>
-          </a:xfrm>
-          <a:prstGeom prst="rect">
-            <a:avLst/>
-          </a:prstGeom>
-          <a:noFill/>
-        </p:spPr>
-        <p:txBody>
-          <a:bodyPr wrap="square" lIns="0" rIns="0" tIns="0" bIns="0">
-            <a:noAutofit/>
-          </a:bodyPr>
-          <a:lstStyle/>
+              <a:t>One authoritative game.</a:t>
+            </a:r>
+          </a:p>
           <a:p>
             <a:pPr algn="l">
               <a:lnSpc>
@@ -14694,15 +13101,15 @@
               <a:spcAft>
                 <a:spcPts val="400"/>
               </a:spcAft>
-              <a:defRPr sz="2400" b="0">
-                <a:solidFill>
-                  <a:srgbClr val="425D50"/>
+              <a:defRPr sz="3300" b="1">
+                <a:solidFill>
+                  <a:srgbClr val="153B2D"/>
                 </a:solidFill>
                 <a:latin typeface="Arial"/>
               </a:defRPr>
             </a:pPr>
             <a:r>
-              <a:t>A detected disconnect</a:t>
+              <a:t>Two synchronized clients.</a:t>
             </a:r>
           </a:p>
           <a:p>
@@ -14716,29 +13123,29 @@
               <a:spcAft>
                 <a:spcPts val="400"/>
               </a:spcAft>
-              <a:defRPr sz="2400" b="0">
-                <a:solidFill>
-                  <a:srgbClr val="425D50"/>
+              <a:defRPr sz="3300" b="1">
+                <a:solidFill>
+                  <a:srgbClr val="153B2D"/>
                 </a:solidFill>
                 <a:latin typeface="Arial"/>
               </a:defRPr>
             </a:pPr>
             <a:r>
-              <a:t>ends the active match</a:t>
-            </a:r>
-          </a:p>
-        </p:txBody>
-      </p:sp>
-      <p:sp>
-        <p:nvSpPr>
-          <p:cNvPr id="14" name="Rounded Rectangle 13"/>
+              <a:t>Persistent player results.</a:t>
+            </a:r>
+          </a:p>
+        </p:txBody>
+      </p:sp>
+      <p:sp>
+        <p:nvSpPr>
+          <p:cNvPr id="11" name="Rounded Rectangle 10"/>
           <p:cNvSpPr/>
           <p:nvPr/>
         </p:nvSpPr>
         <p:spPr>
           <a:xfrm>
-            <a:off x="6281928" y="1938528"/>
-            <a:ext cx="5367528" cy="2423160"/>
+            <a:off x="8321040" y="1874519"/>
+            <a:ext cx="3291840" cy="2761488"/>
           </a:xfrm>
           <a:prstGeom prst="roundRect">
             <a:avLst>
@@ -14746,7 +13153,7 @@
             </a:avLst>
           </a:prstGeom>
           <a:solidFill>
-            <a:srgbClr val="FFFFFF"/>
+            <a:srgbClr val="E8F0E7"/>
           </a:solidFill>
           <a:ln w="12700">
             <a:solidFill>
@@ -14779,58 +13186,162 @@
       </p:sp>
       <p:sp>
         <p:nvSpPr>
-          <p:cNvPr id="15" name="Rectangle 14"/>
-          <p:cNvSpPr/>
-          <p:nvPr/>
-        </p:nvSpPr>
-        <p:spPr>
-          <a:xfrm>
-            <a:off x="6300216" y="2139696"/>
-            <a:ext cx="41148" cy="2020824"/>
-          </a:xfrm>
-          <a:prstGeom prst="rect">
-            <a:avLst/>
-          </a:prstGeom>
-          <a:solidFill>
-            <a:srgbClr val="BD614A"/>
-          </a:solidFill>
-          <a:ln>
-            <a:noFill/>
+          <p:cNvPr id="12" name="TextBox 11"/>
+          <p:cNvSpPr txBox="1"/>
+          <p:nvPr/>
+        </p:nvSpPr>
+        <p:spPr>
+          <a:xfrm>
+            <a:off x="8549640" y="2523744"/>
+            <a:ext cx="2834640" cy="640080"/>
+          </a:xfrm>
+          <a:prstGeom prst="rect">
+            <a:avLst/>
+          </a:prstGeom>
+          <a:noFill/>
+        </p:spPr>
+        <p:txBody>
+          <a:bodyPr wrap="square" lIns="0" rIns="0" tIns="0" bIns="0">
+            <a:noAutofit/>
+          </a:bodyPr>
+          <a:lstStyle/>
+          <a:p>
+            <a:pPr algn="ctr">
+              <a:lnSpc>
+                <a:spcPct val="106000"/>
+              </a:lnSpc>
+              <a:spcBef>
+                <a:spcPts val="0"/>
+              </a:spcBef>
+              <a:spcAft>
+                <a:spcPts val="400"/>
+              </a:spcAft>
+              <a:defRPr sz="2900" b="1">
+                <a:solidFill>
+                  <a:srgbClr val="153B2D"/>
+                </a:solidFill>
+                <a:latin typeface="Arial"/>
+              </a:defRPr>
+            </a:pPr>
+            <a:r>
+              <a:t>Next: chat</a:t>
+            </a:r>
+          </a:p>
+        </p:txBody>
+      </p:sp>
+      <p:sp>
+        <p:nvSpPr>
+          <p:cNvPr id="13" name="TextBox 12"/>
+          <p:cNvSpPr txBox="1"/>
+          <p:nvPr/>
+        </p:nvSpPr>
+        <p:spPr>
+          <a:xfrm>
+            <a:off x="8549640" y="3429000"/>
+            <a:ext cx="2834640" cy="932688"/>
+          </a:xfrm>
+          <a:prstGeom prst="rect">
+            <a:avLst/>
+          </a:prstGeom>
+          <a:noFill/>
+        </p:spPr>
+        <p:txBody>
+          <a:bodyPr wrap="square" lIns="0" rIns="0" tIns="0" bIns="0">
+            <a:noAutofit/>
+          </a:bodyPr>
+          <a:lstStyle/>
+          <a:p>
+            <a:pPr algn="ctr">
+              <a:lnSpc>
+                <a:spcPct val="106000"/>
+              </a:lnSpc>
+              <a:spcBef>
+                <a:spcPts val="0"/>
+              </a:spcBef>
+              <a:spcAft>
+                <a:spcPts val="400"/>
+              </a:spcAft>
+              <a:defRPr sz="2200" b="0">
+                <a:solidFill>
+                  <a:srgbClr val="425D50"/>
+                </a:solidFill>
+                <a:latin typeface="Arial"/>
+              </a:defRPr>
+            </a:pPr>
+            <a:r>
+              <a:t>Inside the room</a:t>
+            </a:r>
+          </a:p>
+          <a:p>
+            <a:pPr algn="ctr">
+              <a:lnSpc>
+                <a:spcPct val="106000"/>
+              </a:lnSpc>
+              <a:spcBef>
+                <a:spcPts val="0"/>
+              </a:spcBef>
+              <a:spcAft>
+                <a:spcPts val="400"/>
+              </a:spcAft>
+              <a:defRPr sz="2200" b="0">
+                <a:solidFill>
+                  <a:srgbClr val="425D50"/>
+                </a:solidFill>
+                <a:latin typeface="Arial"/>
+              </a:defRPr>
+            </a:pPr>
+            <a:r>
+              <a:t>Over existing TCP</a:t>
+            </a:r>
+          </a:p>
+        </p:txBody>
+      </p:sp>
+      <p:cxnSp>
+        <p:nvCxnSpPr>
+          <p:cNvPr id="14" name="Connector 13"/>
+          <p:cNvCxnSpPr/>
+          <p:nvPr/>
+        </p:nvCxnSpPr>
+        <p:spPr>
+          <a:xfrm>
+            <a:off x="594360" y="4507992"/>
+            <a:ext cx="6720840" cy="0"/>
+          </a:xfrm>
+          <a:prstGeom prst="line">
+            <a:avLst/>
+          </a:prstGeom>
+          <a:ln w="17780">
+            <a:solidFill>
+              <a:srgbClr val="CBD8CF"/>
+            </a:solidFill>
           </a:ln>
           <a:effectLst/>
         </p:spPr>
         <p:style>
-          <a:lnRef idx="1">
+          <a:lnRef idx="2">
             <a:schemeClr val="accent1"/>
           </a:lnRef>
-          <a:fillRef idx="3">
+          <a:fillRef idx="0">
             <a:schemeClr val="accent1"/>
           </a:fillRef>
           <a:effectRef idx="0">
             <a:schemeClr val="accent1"/>
           </a:effectRef>
           <a:fontRef idx="minor">
-            <a:schemeClr val="lt1"/>
+            <a:schemeClr val="tx1"/>
           </a:fontRef>
         </p:style>
-        <p:txBody>
-          <a:bodyPr rtlCol="0" anchor="ctr"/>
-          <a:lstStyle/>
-          <a:p>
-            <a:pPr algn="ctr"/>
-          </a:p>
-        </p:txBody>
-      </p:sp>
-      <p:sp>
-        <p:nvSpPr>
-          <p:cNvPr id="16" name="TextBox 15"/>
+      </p:cxnSp>
+      <p:sp>
+        <p:nvSpPr>
+          <p:cNvPr id="15" name="TextBox 14"/>
           <p:cNvSpPr txBox="1"/>
           <p:nvPr/>
         </p:nvSpPr>
         <p:spPr>
           <a:xfrm>
-            <a:off x="6510528" y="2157984"/>
-            <a:ext cx="4910328" cy="594360"/>
+            <a:off x="594360" y="4773168"/>
+            <a:ext cx="7315200" cy="914400"/>
           </a:xfrm>
           <a:prstGeom prst="rect">
             <a:avLst/>
@@ -14853,7 +13364,7 @@
               <a:spcAft>
                 <a:spcPts val="400"/>
               </a:spcAft>
-              <a:defRPr sz="2700" b="1">
+              <a:defRPr sz="2300" b="0">
                 <a:solidFill>
                   <a:srgbClr val="153B2D"/>
                 </a:solidFill>
@@ -14861,32 +13372,9 @@
               </a:defRPr>
             </a:pPr>
             <a:r>
-              <a:t>Local BOT results</a:t>
-            </a:r>
-          </a:p>
-        </p:txBody>
-      </p:sp>
-      <p:sp>
-        <p:nvSpPr>
-          <p:cNvPr id="17" name="TextBox 16"/>
-          <p:cNvSpPr txBox="1"/>
-          <p:nvPr/>
-        </p:nvSpPr>
-        <p:spPr>
-          <a:xfrm>
-            <a:off x="6510528" y="2898648"/>
-            <a:ext cx="4910328" cy="1307592"/>
-          </a:xfrm>
-          <a:prstGeom prst="rect">
-            <a:avLst/>
-          </a:prstGeom>
-          <a:noFill/>
-        </p:spPr>
-        <p:txBody>
-          <a:bodyPr wrap="square" lIns="0" rIns="0" tIns="0" bIns="0">
-            <a:noAutofit/>
-          </a:bodyPr>
-          <a:lstStyle/>
+              <a:t>Rabea Abu Aad — Game Logic</a:t>
+            </a:r>
+          </a:p>
           <a:p>
             <a:pPr algn="l">
               <a:lnSpc>
@@ -14898,17 +13386,40 @@
               <a:spcAft>
                 <a:spcPts val="400"/>
               </a:spcAft>
-              <a:defRPr sz="2400" b="0">
-                <a:solidFill>
-                  <a:srgbClr val="425D50"/>
+              <a:defRPr sz="2300" b="0">
+                <a:solidFill>
+                  <a:srgbClr val="153B2D"/>
                 </a:solidFill>
                 <a:latin typeface="Arial"/>
               </a:defRPr>
             </a:pPr>
             <a:r>
-              <a:t>Client-reported</a:t>
-            </a:r>
-          </a:p>
+              <a:t>Muthanna Farhat — TCP Communication</a:t>
+            </a:r>
+          </a:p>
+        </p:txBody>
+      </p:sp>
+      <p:sp>
+        <p:nvSpPr>
+          <p:cNvPr id="16" name="TextBox 15"/>
+          <p:cNvSpPr txBox="1"/>
+          <p:nvPr/>
+        </p:nvSpPr>
+        <p:spPr>
+          <a:xfrm>
+            <a:off x="594360" y="5888736"/>
+            <a:ext cx="9966960" cy="384048"/>
+          </a:xfrm>
+          <a:prstGeom prst="rect">
+            <a:avLst/>
+          </a:prstGeom>
+          <a:noFill/>
+        </p:spPr>
+        <p:txBody>
+          <a:bodyPr wrap="square" lIns="0" rIns="0" tIns="0" bIns="0">
+            <a:noAutofit/>
+          </a:bodyPr>
+          <a:lstStyle/>
           <a:p>
             <a:pPr algn="l">
               <a:lnSpc>
@@ -14920,153 +13431,18 @@
               <a:spcAft>
                 <a:spcPts val="400"/>
               </a:spcAft>
-              <a:defRPr sz="2400" b="0">
-                <a:solidFill>
-                  <a:srgbClr val="425D50"/>
+              <a:defRPr sz="2200" b="0">
+                <a:solidFill>
+                  <a:srgbClr val="285942"/>
                 </a:solidFill>
                 <a:latin typeface="Arial"/>
               </a:defRPr>
             </a:pPr>
             <a:r>
-              <a:t>No offline upload queue</a:t>
-            </a:r>
-          </a:p>
-        </p:txBody>
-      </p:sp>
-      <p:sp>
-        <p:nvSpPr>
-          <p:cNvPr id="18" name="Rounded Rectangle 17"/>
-          <p:cNvSpPr/>
-          <p:nvPr/>
-        </p:nvSpPr>
-        <p:spPr>
-          <a:xfrm>
-            <a:off x="548640" y="4800600"/>
-            <a:ext cx="11091672" cy="1234440"/>
-          </a:xfrm>
-          <a:prstGeom prst="roundRect">
-            <a:avLst>
-              <a:gd name="adj" fmla="val 12000"/>
-            </a:avLst>
-          </a:prstGeom>
-          <a:solidFill>
-            <a:srgbClr val="E8F0E7"/>
-          </a:solidFill>
-          <a:ln w="12700">
-            <a:solidFill>
-              <a:srgbClr val="CBD8CF"/>
-            </a:solidFill>
-          </a:ln>
-          <a:effectLst/>
-        </p:spPr>
-        <p:style>
-          <a:lnRef idx="1">
-            <a:schemeClr val="accent1"/>
-          </a:lnRef>
-          <a:fillRef idx="3">
-            <a:schemeClr val="accent1"/>
-          </a:fillRef>
-          <a:effectRef idx="0">
-            <a:schemeClr val="accent1"/>
-          </a:effectRef>
-          <a:fontRef idx="minor">
-            <a:schemeClr val="lt1"/>
-          </a:fontRef>
-        </p:style>
-        <p:txBody>
-          <a:bodyPr rtlCol="0" anchor="ctr"/>
-          <a:lstStyle/>
-          <a:p>
-            <a:pPr algn="ctr"/>
-          </a:p>
-        </p:txBody>
-      </p:sp>
-      <p:sp>
-        <p:nvSpPr>
-          <p:cNvPr id="19" name="TextBox 18"/>
-          <p:cNvSpPr txBox="1"/>
-          <p:nvPr/>
-        </p:nvSpPr>
-        <p:spPr>
-          <a:xfrm>
-            <a:off x="822960" y="5120640"/>
-            <a:ext cx="1188720" cy="457200"/>
-          </a:xfrm>
-          <a:prstGeom prst="rect">
-            <a:avLst/>
-          </a:prstGeom>
-          <a:noFill/>
-        </p:spPr>
-        <p:txBody>
-          <a:bodyPr wrap="square" lIns="0" rIns="0" tIns="0" bIns="0">
-            <a:noAutofit/>
-          </a:bodyPr>
-          <a:lstStyle/>
-          <a:p>
-            <a:pPr algn="l">
-              <a:lnSpc>
-                <a:spcPct val="106000"/>
-              </a:lnSpc>
-              <a:spcBef>
-                <a:spcPts val="0"/>
-              </a:spcBef>
-              <a:spcAft>
-                <a:spcPts val="400"/>
-              </a:spcAft>
-              <a:defRPr sz="2100" b="1">
-                <a:solidFill>
-                  <a:srgbClr val="285942"/>
-                </a:solidFill>
-                <a:latin typeface="Arial"/>
-              </a:defRPr>
-            </a:pPr>
-            <a:r>
-              <a:t>NEXT</a:t>
-            </a:r>
-          </a:p>
-        </p:txBody>
-      </p:sp>
-      <p:sp>
-        <p:nvSpPr>
-          <p:cNvPr id="20" name="TextBox 19"/>
-          <p:cNvSpPr txBox="1"/>
-          <p:nvPr/>
-        </p:nvSpPr>
-        <p:spPr>
-          <a:xfrm>
-            <a:off x="2148840" y="5093208"/>
-            <a:ext cx="9144000" cy="694944"/>
-          </a:xfrm>
-          <a:prstGeom prst="rect">
-            <a:avLst/>
-          </a:prstGeom>
-          <a:noFill/>
-        </p:spPr>
-        <p:txBody>
-          <a:bodyPr wrap="square" lIns="0" rIns="0" tIns="0" bIns="0">
-            <a:noAutofit/>
-          </a:bodyPr>
-          <a:lstStyle/>
-          <a:p>
-            <a:pPr algn="l">
-              <a:lnSpc>
-                <a:spcPct val="106000"/>
-              </a:lnSpc>
-              <a:spcBef>
-                <a:spcPts val="0"/>
-              </a:spcBef>
-              <a:spcAft>
-                <a:spcPts val="400"/>
-              </a:spcAft>
-              <a:defRPr sz="2700" b="1">
-                <a:solidFill>
-                  <a:srgbClr val="153B2D"/>
-                </a:solidFill>
-                <a:latin typeface="Arial"/>
-              </a:defRPr>
-            </a:pPr>
-            <a:r>
-              <a:t>In-room chat over the existing TCP connection</a:t>
+              <a:rPr>
+                <a:hlinkClick r:id="rId2"/>
+              </a:rPr>
+              <a:t>github.com/MuthannaFrhat/damka-game</a:t>
             </a:r>
           </a:p>
         </p:txBody>
@@ -15182,7 +13558,7 @@
               </a:defRPr>
             </a:pPr>
             <a:r>
-              <a:t>CONCLUSIONS</a:t>
+              <a:t>THANK YOU</a:t>
             </a:r>
           </a:p>
         </p:txBody>
@@ -15306,9 +13682,6 @@
                 <a:latin typeface="Arial"/>
               </a:defRPr>
             </a:pPr>
-            <a:r>
-              <a:t>What we built and learned</a:t>
-            </a:r>
           </a:p>
         </p:txBody>
       </p:sp>
@@ -15433,21 +13806,857 @@
               </a:defRPr>
             </a:pPr>
             <a:r>
-              <a:t>09 / 10</a:t>
-            </a:r>
-          </a:p>
-        </p:txBody>
-      </p:sp>
-      <p:sp>
-        <p:nvSpPr>
-          <p:cNvPr id="10" name="TextBox 9"/>
+              <a:t>09 / 09</a:t>
+            </a:r>
+          </a:p>
+        </p:txBody>
+      </p:sp>
+      <p:sp>
+        <p:nvSpPr>
+          <p:cNvPr id="10" name="Rectangle 9"/>
+          <p:cNvSpPr/>
+          <p:nvPr/>
+        </p:nvSpPr>
+        <p:spPr>
+          <a:xfrm>
+            <a:off x="9034272" y="2423160"/>
+            <a:ext cx="475488" cy="475488"/>
+          </a:xfrm>
+          <a:prstGeom prst="rect">
+            <a:avLst/>
+          </a:prstGeom>
+          <a:solidFill>
+            <a:srgbClr val="E8F0E7"/>
+          </a:solidFill>
+          <a:ln>
+            <a:noFill/>
+          </a:ln>
+          <a:effectLst/>
+        </p:spPr>
+        <p:style>
+          <a:lnRef idx="1">
+            <a:schemeClr val="accent1"/>
+          </a:lnRef>
+          <a:fillRef idx="3">
+            <a:schemeClr val="accent1"/>
+          </a:fillRef>
+          <a:effectRef idx="0">
+            <a:schemeClr val="accent1"/>
+          </a:effectRef>
+          <a:fontRef idx="minor">
+            <a:schemeClr val="lt1"/>
+          </a:fontRef>
+        </p:style>
+        <p:txBody>
+          <a:bodyPr rtlCol="0" anchor="ctr"/>
+          <a:lstStyle/>
+          <a:p>
+            <a:pPr algn="ctr"/>
+          </a:p>
+        </p:txBody>
+      </p:sp>
+      <p:sp>
+        <p:nvSpPr>
+          <p:cNvPr id="11" name="Rectangle 10"/>
+          <p:cNvSpPr/>
+          <p:nvPr/>
+        </p:nvSpPr>
+        <p:spPr>
+          <a:xfrm>
+            <a:off x="9509760" y="2423160"/>
+            <a:ext cx="475488" cy="475488"/>
+          </a:xfrm>
+          <a:prstGeom prst="rect">
+            <a:avLst/>
+          </a:prstGeom>
+          <a:solidFill>
+            <a:srgbClr val="285942"/>
+          </a:solidFill>
+          <a:ln>
+            <a:noFill/>
+          </a:ln>
+          <a:effectLst/>
+        </p:spPr>
+        <p:style>
+          <a:lnRef idx="1">
+            <a:schemeClr val="accent1"/>
+          </a:lnRef>
+          <a:fillRef idx="3">
+            <a:schemeClr val="accent1"/>
+          </a:fillRef>
+          <a:effectRef idx="0">
+            <a:schemeClr val="accent1"/>
+          </a:effectRef>
+          <a:fontRef idx="minor">
+            <a:schemeClr val="lt1"/>
+          </a:fontRef>
+        </p:style>
+        <p:txBody>
+          <a:bodyPr rtlCol="0" anchor="ctr"/>
+          <a:lstStyle/>
+          <a:p>
+            <a:pPr algn="ctr"/>
+          </a:p>
+        </p:txBody>
+      </p:sp>
+      <p:sp>
+        <p:nvSpPr>
+          <p:cNvPr id="12" name="Rectangle 11"/>
+          <p:cNvSpPr/>
+          <p:nvPr/>
+        </p:nvSpPr>
+        <p:spPr>
+          <a:xfrm>
+            <a:off x="9985248" y="2423160"/>
+            <a:ext cx="475488" cy="475488"/>
+          </a:xfrm>
+          <a:prstGeom prst="rect">
+            <a:avLst/>
+          </a:prstGeom>
+          <a:solidFill>
+            <a:srgbClr val="E8F0E7"/>
+          </a:solidFill>
+          <a:ln>
+            <a:noFill/>
+          </a:ln>
+          <a:effectLst/>
+        </p:spPr>
+        <p:style>
+          <a:lnRef idx="1">
+            <a:schemeClr val="accent1"/>
+          </a:lnRef>
+          <a:fillRef idx="3">
+            <a:schemeClr val="accent1"/>
+          </a:fillRef>
+          <a:effectRef idx="0">
+            <a:schemeClr val="accent1"/>
+          </a:effectRef>
+          <a:fontRef idx="minor">
+            <a:schemeClr val="lt1"/>
+          </a:fontRef>
+        </p:style>
+        <p:txBody>
+          <a:bodyPr rtlCol="0" anchor="ctr"/>
+          <a:lstStyle/>
+          <a:p>
+            <a:pPr algn="ctr"/>
+          </a:p>
+        </p:txBody>
+      </p:sp>
+      <p:sp>
+        <p:nvSpPr>
+          <p:cNvPr id="13" name="Rectangle 12"/>
+          <p:cNvSpPr/>
+          <p:nvPr/>
+        </p:nvSpPr>
+        <p:spPr>
+          <a:xfrm>
+            <a:off x="10460736" y="2423160"/>
+            <a:ext cx="475488" cy="475488"/>
+          </a:xfrm>
+          <a:prstGeom prst="rect">
+            <a:avLst/>
+          </a:prstGeom>
+          <a:solidFill>
+            <a:srgbClr val="285942"/>
+          </a:solidFill>
+          <a:ln>
+            <a:noFill/>
+          </a:ln>
+          <a:effectLst/>
+        </p:spPr>
+        <p:style>
+          <a:lnRef idx="1">
+            <a:schemeClr val="accent1"/>
+          </a:lnRef>
+          <a:fillRef idx="3">
+            <a:schemeClr val="accent1"/>
+          </a:fillRef>
+          <a:effectRef idx="0">
+            <a:schemeClr val="accent1"/>
+          </a:effectRef>
+          <a:fontRef idx="minor">
+            <a:schemeClr val="lt1"/>
+          </a:fontRef>
+        </p:style>
+        <p:txBody>
+          <a:bodyPr rtlCol="0" anchor="ctr"/>
+          <a:lstStyle/>
+          <a:p>
+            <a:pPr algn="ctr"/>
+          </a:p>
+        </p:txBody>
+      </p:sp>
+      <p:sp>
+        <p:nvSpPr>
+          <p:cNvPr id="14" name="Rectangle 13"/>
+          <p:cNvSpPr/>
+          <p:nvPr/>
+        </p:nvSpPr>
+        <p:spPr>
+          <a:xfrm>
+            <a:off x="9034272" y="2898648"/>
+            <a:ext cx="475488" cy="475488"/>
+          </a:xfrm>
+          <a:prstGeom prst="rect">
+            <a:avLst/>
+          </a:prstGeom>
+          <a:solidFill>
+            <a:srgbClr val="285942"/>
+          </a:solidFill>
+          <a:ln>
+            <a:noFill/>
+          </a:ln>
+          <a:effectLst/>
+        </p:spPr>
+        <p:style>
+          <a:lnRef idx="1">
+            <a:schemeClr val="accent1"/>
+          </a:lnRef>
+          <a:fillRef idx="3">
+            <a:schemeClr val="accent1"/>
+          </a:fillRef>
+          <a:effectRef idx="0">
+            <a:schemeClr val="accent1"/>
+          </a:effectRef>
+          <a:fontRef idx="minor">
+            <a:schemeClr val="lt1"/>
+          </a:fontRef>
+        </p:style>
+        <p:txBody>
+          <a:bodyPr rtlCol="0" anchor="ctr"/>
+          <a:lstStyle/>
+          <a:p>
+            <a:pPr algn="ctr"/>
+          </a:p>
+        </p:txBody>
+      </p:sp>
+      <p:sp>
+        <p:nvSpPr>
+          <p:cNvPr id="15" name="Rectangle 14"/>
+          <p:cNvSpPr/>
+          <p:nvPr/>
+        </p:nvSpPr>
+        <p:spPr>
+          <a:xfrm>
+            <a:off x="9509760" y="2898648"/>
+            <a:ext cx="475488" cy="475488"/>
+          </a:xfrm>
+          <a:prstGeom prst="rect">
+            <a:avLst/>
+          </a:prstGeom>
+          <a:solidFill>
+            <a:srgbClr val="E8F0E7"/>
+          </a:solidFill>
+          <a:ln>
+            <a:noFill/>
+          </a:ln>
+          <a:effectLst/>
+        </p:spPr>
+        <p:style>
+          <a:lnRef idx="1">
+            <a:schemeClr val="accent1"/>
+          </a:lnRef>
+          <a:fillRef idx="3">
+            <a:schemeClr val="accent1"/>
+          </a:fillRef>
+          <a:effectRef idx="0">
+            <a:schemeClr val="accent1"/>
+          </a:effectRef>
+          <a:fontRef idx="minor">
+            <a:schemeClr val="lt1"/>
+          </a:fontRef>
+        </p:style>
+        <p:txBody>
+          <a:bodyPr rtlCol="0" anchor="ctr"/>
+          <a:lstStyle/>
+          <a:p>
+            <a:pPr algn="ctr"/>
+          </a:p>
+        </p:txBody>
+      </p:sp>
+      <p:sp>
+        <p:nvSpPr>
+          <p:cNvPr id="16" name="Rectangle 15"/>
+          <p:cNvSpPr/>
+          <p:nvPr/>
+        </p:nvSpPr>
+        <p:spPr>
+          <a:xfrm>
+            <a:off x="9985248" y="2898648"/>
+            <a:ext cx="475488" cy="475488"/>
+          </a:xfrm>
+          <a:prstGeom prst="rect">
+            <a:avLst/>
+          </a:prstGeom>
+          <a:solidFill>
+            <a:srgbClr val="285942"/>
+          </a:solidFill>
+          <a:ln>
+            <a:noFill/>
+          </a:ln>
+          <a:effectLst/>
+        </p:spPr>
+        <p:style>
+          <a:lnRef idx="1">
+            <a:schemeClr val="accent1"/>
+          </a:lnRef>
+          <a:fillRef idx="3">
+            <a:schemeClr val="accent1"/>
+          </a:fillRef>
+          <a:effectRef idx="0">
+            <a:schemeClr val="accent1"/>
+          </a:effectRef>
+          <a:fontRef idx="minor">
+            <a:schemeClr val="lt1"/>
+          </a:fontRef>
+        </p:style>
+        <p:txBody>
+          <a:bodyPr rtlCol="0" anchor="ctr"/>
+          <a:lstStyle/>
+          <a:p>
+            <a:pPr algn="ctr"/>
+          </a:p>
+        </p:txBody>
+      </p:sp>
+      <p:sp>
+        <p:nvSpPr>
+          <p:cNvPr id="17" name="Rectangle 16"/>
+          <p:cNvSpPr/>
+          <p:nvPr/>
+        </p:nvSpPr>
+        <p:spPr>
+          <a:xfrm>
+            <a:off x="10460736" y="2898648"/>
+            <a:ext cx="475488" cy="475488"/>
+          </a:xfrm>
+          <a:prstGeom prst="rect">
+            <a:avLst/>
+          </a:prstGeom>
+          <a:solidFill>
+            <a:srgbClr val="E8F0E7"/>
+          </a:solidFill>
+          <a:ln>
+            <a:noFill/>
+          </a:ln>
+          <a:effectLst/>
+        </p:spPr>
+        <p:style>
+          <a:lnRef idx="1">
+            <a:schemeClr val="accent1"/>
+          </a:lnRef>
+          <a:fillRef idx="3">
+            <a:schemeClr val="accent1"/>
+          </a:fillRef>
+          <a:effectRef idx="0">
+            <a:schemeClr val="accent1"/>
+          </a:effectRef>
+          <a:fontRef idx="minor">
+            <a:schemeClr val="lt1"/>
+          </a:fontRef>
+        </p:style>
+        <p:txBody>
+          <a:bodyPr rtlCol="0" anchor="ctr"/>
+          <a:lstStyle/>
+          <a:p>
+            <a:pPr algn="ctr"/>
+          </a:p>
+        </p:txBody>
+      </p:sp>
+      <p:sp>
+        <p:nvSpPr>
+          <p:cNvPr id="18" name="Rectangle 17"/>
+          <p:cNvSpPr/>
+          <p:nvPr/>
+        </p:nvSpPr>
+        <p:spPr>
+          <a:xfrm>
+            <a:off x="9034272" y="3374136"/>
+            <a:ext cx="475488" cy="475488"/>
+          </a:xfrm>
+          <a:prstGeom prst="rect">
+            <a:avLst/>
+          </a:prstGeom>
+          <a:solidFill>
+            <a:srgbClr val="E8F0E7"/>
+          </a:solidFill>
+          <a:ln>
+            <a:noFill/>
+          </a:ln>
+          <a:effectLst/>
+        </p:spPr>
+        <p:style>
+          <a:lnRef idx="1">
+            <a:schemeClr val="accent1"/>
+          </a:lnRef>
+          <a:fillRef idx="3">
+            <a:schemeClr val="accent1"/>
+          </a:fillRef>
+          <a:effectRef idx="0">
+            <a:schemeClr val="accent1"/>
+          </a:effectRef>
+          <a:fontRef idx="minor">
+            <a:schemeClr val="lt1"/>
+          </a:fontRef>
+        </p:style>
+        <p:txBody>
+          <a:bodyPr rtlCol="0" anchor="ctr"/>
+          <a:lstStyle/>
+          <a:p>
+            <a:pPr algn="ctr"/>
+          </a:p>
+        </p:txBody>
+      </p:sp>
+      <p:sp>
+        <p:nvSpPr>
+          <p:cNvPr id="19" name="Rectangle 18"/>
+          <p:cNvSpPr/>
+          <p:nvPr/>
+        </p:nvSpPr>
+        <p:spPr>
+          <a:xfrm>
+            <a:off x="9509760" y="3374136"/>
+            <a:ext cx="475488" cy="475488"/>
+          </a:xfrm>
+          <a:prstGeom prst="rect">
+            <a:avLst/>
+          </a:prstGeom>
+          <a:solidFill>
+            <a:srgbClr val="285942"/>
+          </a:solidFill>
+          <a:ln>
+            <a:noFill/>
+          </a:ln>
+          <a:effectLst/>
+        </p:spPr>
+        <p:style>
+          <a:lnRef idx="1">
+            <a:schemeClr val="accent1"/>
+          </a:lnRef>
+          <a:fillRef idx="3">
+            <a:schemeClr val="accent1"/>
+          </a:fillRef>
+          <a:effectRef idx="0">
+            <a:schemeClr val="accent1"/>
+          </a:effectRef>
+          <a:fontRef idx="minor">
+            <a:schemeClr val="lt1"/>
+          </a:fontRef>
+        </p:style>
+        <p:txBody>
+          <a:bodyPr rtlCol="0" anchor="ctr"/>
+          <a:lstStyle/>
+          <a:p>
+            <a:pPr algn="ctr"/>
+          </a:p>
+        </p:txBody>
+      </p:sp>
+      <p:sp>
+        <p:nvSpPr>
+          <p:cNvPr id="20" name="Rectangle 19"/>
+          <p:cNvSpPr/>
+          <p:nvPr/>
+        </p:nvSpPr>
+        <p:spPr>
+          <a:xfrm>
+            <a:off x="9985248" y="3374136"/>
+            <a:ext cx="475488" cy="475488"/>
+          </a:xfrm>
+          <a:prstGeom prst="rect">
+            <a:avLst/>
+          </a:prstGeom>
+          <a:solidFill>
+            <a:srgbClr val="E8F0E7"/>
+          </a:solidFill>
+          <a:ln>
+            <a:noFill/>
+          </a:ln>
+          <a:effectLst/>
+        </p:spPr>
+        <p:style>
+          <a:lnRef idx="1">
+            <a:schemeClr val="accent1"/>
+          </a:lnRef>
+          <a:fillRef idx="3">
+            <a:schemeClr val="accent1"/>
+          </a:fillRef>
+          <a:effectRef idx="0">
+            <a:schemeClr val="accent1"/>
+          </a:effectRef>
+          <a:fontRef idx="minor">
+            <a:schemeClr val="lt1"/>
+          </a:fontRef>
+        </p:style>
+        <p:txBody>
+          <a:bodyPr rtlCol="0" anchor="ctr"/>
+          <a:lstStyle/>
+          <a:p>
+            <a:pPr algn="ctr"/>
+          </a:p>
+        </p:txBody>
+      </p:sp>
+      <p:sp>
+        <p:nvSpPr>
+          <p:cNvPr id="21" name="Rectangle 20"/>
+          <p:cNvSpPr/>
+          <p:nvPr/>
+        </p:nvSpPr>
+        <p:spPr>
+          <a:xfrm>
+            <a:off x="10460736" y="3374136"/>
+            <a:ext cx="475488" cy="475488"/>
+          </a:xfrm>
+          <a:prstGeom prst="rect">
+            <a:avLst/>
+          </a:prstGeom>
+          <a:solidFill>
+            <a:srgbClr val="285942"/>
+          </a:solidFill>
+          <a:ln>
+            <a:noFill/>
+          </a:ln>
+          <a:effectLst/>
+        </p:spPr>
+        <p:style>
+          <a:lnRef idx="1">
+            <a:schemeClr val="accent1"/>
+          </a:lnRef>
+          <a:fillRef idx="3">
+            <a:schemeClr val="accent1"/>
+          </a:fillRef>
+          <a:effectRef idx="0">
+            <a:schemeClr val="accent1"/>
+          </a:effectRef>
+          <a:fontRef idx="minor">
+            <a:schemeClr val="lt1"/>
+          </a:fontRef>
+        </p:style>
+        <p:txBody>
+          <a:bodyPr rtlCol="0" anchor="ctr"/>
+          <a:lstStyle/>
+          <a:p>
+            <a:pPr algn="ctr"/>
+          </a:p>
+        </p:txBody>
+      </p:sp>
+      <p:sp>
+        <p:nvSpPr>
+          <p:cNvPr id="22" name="Rectangle 21"/>
+          <p:cNvSpPr/>
+          <p:nvPr/>
+        </p:nvSpPr>
+        <p:spPr>
+          <a:xfrm>
+            <a:off x="9034272" y="3849624"/>
+            <a:ext cx="475488" cy="475488"/>
+          </a:xfrm>
+          <a:prstGeom prst="rect">
+            <a:avLst/>
+          </a:prstGeom>
+          <a:solidFill>
+            <a:srgbClr val="285942"/>
+          </a:solidFill>
+          <a:ln>
+            <a:noFill/>
+          </a:ln>
+          <a:effectLst/>
+        </p:spPr>
+        <p:style>
+          <a:lnRef idx="1">
+            <a:schemeClr val="accent1"/>
+          </a:lnRef>
+          <a:fillRef idx="3">
+            <a:schemeClr val="accent1"/>
+          </a:fillRef>
+          <a:effectRef idx="0">
+            <a:schemeClr val="accent1"/>
+          </a:effectRef>
+          <a:fontRef idx="minor">
+            <a:schemeClr val="lt1"/>
+          </a:fontRef>
+        </p:style>
+        <p:txBody>
+          <a:bodyPr rtlCol="0" anchor="ctr"/>
+          <a:lstStyle/>
+          <a:p>
+            <a:pPr algn="ctr"/>
+          </a:p>
+        </p:txBody>
+      </p:sp>
+      <p:sp>
+        <p:nvSpPr>
+          <p:cNvPr id="23" name="Rectangle 22"/>
+          <p:cNvSpPr/>
+          <p:nvPr/>
+        </p:nvSpPr>
+        <p:spPr>
+          <a:xfrm>
+            <a:off x="9509760" y="3849624"/>
+            <a:ext cx="475488" cy="475488"/>
+          </a:xfrm>
+          <a:prstGeom prst="rect">
+            <a:avLst/>
+          </a:prstGeom>
+          <a:solidFill>
+            <a:srgbClr val="E8F0E7"/>
+          </a:solidFill>
+          <a:ln>
+            <a:noFill/>
+          </a:ln>
+          <a:effectLst/>
+        </p:spPr>
+        <p:style>
+          <a:lnRef idx="1">
+            <a:schemeClr val="accent1"/>
+          </a:lnRef>
+          <a:fillRef idx="3">
+            <a:schemeClr val="accent1"/>
+          </a:fillRef>
+          <a:effectRef idx="0">
+            <a:schemeClr val="accent1"/>
+          </a:effectRef>
+          <a:fontRef idx="minor">
+            <a:schemeClr val="lt1"/>
+          </a:fontRef>
+        </p:style>
+        <p:txBody>
+          <a:bodyPr rtlCol="0" anchor="ctr"/>
+          <a:lstStyle/>
+          <a:p>
+            <a:pPr algn="ctr"/>
+          </a:p>
+        </p:txBody>
+      </p:sp>
+      <p:sp>
+        <p:nvSpPr>
+          <p:cNvPr id="24" name="Rectangle 23"/>
+          <p:cNvSpPr/>
+          <p:nvPr/>
+        </p:nvSpPr>
+        <p:spPr>
+          <a:xfrm>
+            <a:off x="9985248" y="3849624"/>
+            <a:ext cx="475488" cy="475488"/>
+          </a:xfrm>
+          <a:prstGeom prst="rect">
+            <a:avLst/>
+          </a:prstGeom>
+          <a:solidFill>
+            <a:srgbClr val="285942"/>
+          </a:solidFill>
+          <a:ln>
+            <a:noFill/>
+          </a:ln>
+          <a:effectLst/>
+        </p:spPr>
+        <p:style>
+          <a:lnRef idx="1">
+            <a:schemeClr val="accent1"/>
+          </a:lnRef>
+          <a:fillRef idx="3">
+            <a:schemeClr val="accent1"/>
+          </a:fillRef>
+          <a:effectRef idx="0">
+            <a:schemeClr val="accent1"/>
+          </a:effectRef>
+          <a:fontRef idx="minor">
+            <a:schemeClr val="lt1"/>
+          </a:fontRef>
+        </p:style>
+        <p:txBody>
+          <a:bodyPr rtlCol="0" anchor="ctr"/>
+          <a:lstStyle/>
+          <a:p>
+            <a:pPr algn="ctr"/>
+          </a:p>
+        </p:txBody>
+      </p:sp>
+      <p:sp>
+        <p:nvSpPr>
+          <p:cNvPr id="25" name="Rectangle 24"/>
+          <p:cNvSpPr/>
+          <p:nvPr/>
+        </p:nvSpPr>
+        <p:spPr>
+          <a:xfrm>
+            <a:off x="10460736" y="3849624"/>
+            <a:ext cx="475488" cy="475488"/>
+          </a:xfrm>
+          <a:prstGeom prst="rect">
+            <a:avLst/>
+          </a:prstGeom>
+          <a:solidFill>
+            <a:srgbClr val="E8F0E7"/>
+          </a:solidFill>
+          <a:ln>
+            <a:noFill/>
+          </a:ln>
+          <a:effectLst/>
+        </p:spPr>
+        <p:style>
+          <a:lnRef idx="1">
+            <a:schemeClr val="accent1"/>
+          </a:lnRef>
+          <a:fillRef idx="3">
+            <a:schemeClr val="accent1"/>
+          </a:fillRef>
+          <a:effectRef idx="0">
+            <a:schemeClr val="accent1"/>
+          </a:effectRef>
+          <a:fontRef idx="minor">
+            <a:schemeClr val="lt1"/>
+          </a:fontRef>
+        </p:style>
+        <p:txBody>
+          <a:bodyPr rtlCol="0" anchor="ctr"/>
+          <a:lstStyle/>
+          <a:p>
+            <a:pPr algn="ctr"/>
+          </a:p>
+        </p:txBody>
+      </p:sp>
+      <p:sp>
+        <p:nvSpPr>
+          <p:cNvPr id="26" name="Oval 25"/>
+          <p:cNvSpPr/>
+          <p:nvPr/>
+        </p:nvSpPr>
+        <p:spPr>
+          <a:xfrm>
+            <a:off x="9134856" y="2999232"/>
+            <a:ext cx="274320" cy="274320"/>
+          </a:xfrm>
+          <a:prstGeom prst="ellipse">
+            <a:avLst/>
+          </a:prstGeom>
+          <a:solidFill>
+            <a:srgbClr val="BD614A"/>
+          </a:solidFill>
+          <a:ln>
+            <a:noFill/>
+          </a:ln>
+          <a:effectLst/>
+        </p:spPr>
+        <p:style>
+          <a:lnRef idx="1">
+            <a:schemeClr val="accent1"/>
+          </a:lnRef>
+          <a:fillRef idx="3">
+            <a:schemeClr val="accent1"/>
+          </a:fillRef>
+          <a:effectRef idx="0">
+            <a:schemeClr val="accent1"/>
+          </a:effectRef>
+          <a:fontRef idx="minor">
+            <a:schemeClr val="lt1"/>
+          </a:fontRef>
+        </p:style>
+        <p:txBody>
+          <a:bodyPr rtlCol="0" anchor="ctr"/>
+          <a:lstStyle/>
+          <a:p>
+            <a:pPr algn="ctr"/>
+          </a:p>
+        </p:txBody>
+      </p:sp>
+      <p:sp>
+        <p:nvSpPr>
+          <p:cNvPr id="27" name="Oval 26"/>
+          <p:cNvSpPr/>
+          <p:nvPr/>
+        </p:nvSpPr>
+        <p:spPr>
+          <a:xfrm>
+            <a:off x="10085832" y="2999232"/>
+            <a:ext cx="274320" cy="274320"/>
+          </a:xfrm>
+          <a:prstGeom prst="ellipse">
+            <a:avLst/>
+          </a:prstGeom>
+          <a:solidFill>
+            <a:srgbClr val="BD614A"/>
+          </a:solidFill>
+          <a:ln>
+            <a:noFill/>
+          </a:ln>
+          <a:effectLst/>
+        </p:spPr>
+        <p:style>
+          <a:lnRef idx="1">
+            <a:schemeClr val="accent1"/>
+          </a:lnRef>
+          <a:fillRef idx="3">
+            <a:schemeClr val="accent1"/>
+          </a:fillRef>
+          <a:effectRef idx="0">
+            <a:schemeClr val="accent1"/>
+          </a:effectRef>
+          <a:fontRef idx="minor">
+            <a:schemeClr val="lt1"/>
+          </a:fontRef>
+        </p:style>
+        <p:txBody>
+          <a:bodyPr rtlCol="0" anchor="ctr"/>
+          <a:lstStyle/>
+          <a:p>
+            <a:pPr algn="ctr"/>
+          </a:p>
+        </p:txBody>
+      </p:sp>
+      <p:sp>
+        <p:nvSpPr>
+          <p:cNvPr id="28" name="Oval 27"/>
+          <p:cNvSpPr/>
+          <p:nvPr/>
+        </p:nvSpPr>
+        <p:spPr>
+          <a:xfrm>
+            <a:off x="9134856" y="3950207"/>
+            <a:ext cx="274320" cy="274320"/>
+          </a:xfrm>
+          <a:prstGeom prst="ellipse">
+            <a:avLst/>
+          </a:prstGeom>
+          <a:solidFill>
+            <a:srgbClr val="9F7624"/>
+          </a:solidFill>
+          <a:ln>
+            <a:noFill/>
+          </a:ln>
+          <a:effectLst/>
+        </p:spPr>
+        <p:style>
+          <a:lnRef idx="1">
+            <a:schemeClr val="accent1"/>
+          </a:lnRef>
+          <a:fillRef idx="3">
+            <a:schemeClr val="accent1"/>
+          </a:fillRef>
+          <a:effectRef idx="0">
+            <a:schemeClr val="accent1"/>
+          </a:effectRef>
+          <a:fontRef idx="minor">
+            <a:schemeClr val="lt1"/>
+          </a:fontRef>
+        </p:style>
+        <p:txBody>
+          <a:bodyPr rtlCol="0" anchor="ctr"/>
+          <a:lstStyle/>
+          <a:p>
+            <a:pPr algn="ctr"/>
+          </a:p>
+        </p:txBody>
+      </p:sp>
+      <p:sp>
+        <p:nvSpPr>
+          <p:cNvPr id="29" name="TextBox 28"/>
           <p:cNvSpPr txBox="1"/>
           <p:nvPr/>
         </p:nvSpPr>
         <p:spPr>
           <a:xfrm>
-            <a:off x="594360" y="1901952"/>
-            <a:ext cx="7040880" cy="2148840"/>
+            <a:off x="685800" y="2148840"/>
+            <a:ext cx="7955279" cy="1051560"/>
           </a:xfrm>
           <a:prstGeom prst="rect">
             <a:avLst/>
@@ -15470,7 +14679,7 @@
               <a:spcAft>
                 <a:spcPts val="400"/>
               </a:spcAft>
-              <a:defRPr sz="3300" b="1">
+              <a:defRPr sz="6100" b="1">
                 <a:solidFill>
                   <a:srgbClr val="153B2D"/>
                 </a:solidFill>
@@ -15478,9 +14687,76 @@
               </a:defRPr>
             </a:pPr>
             <a:r>
-              <a:t>One authoritative game.</a:t>
-            </a:r>
-          </a:p>
+              <a:t>THANK YOU</a:t>
+            </a:r>
+          </a:p>
+        </p:txBody>
+      </p:sp>
+      <p:sp>
+        <p:nvSpPr>
+          <p:cNvPr id="30" name="Rectangle 29"/>
+          <p:cNvSpPr/>
+          <p:nvPr/>
+        </p:nvSpPr>
+        <p:spPr>
+          <a:xfrm>
+            <a:off x="713232" y="3557016"/>
+            <a:ext cx="1143000" cy="59436"/>
+          </a:xfrm>
+          <a:prstGeom prst="rect">
+            <a:avLst/>
+          </a:prstGeom>
+          <a:solidFill>
+            <a:srgbClr val="9F7624"/>
+          </a:solidFill>
+          <a:ln>
+            <a:noFill/>
+          </a:ln>
+          <a:effectLst/>
+        </p:spPr>
+        <p:style>
+          <a:lnRef idx="1">
+            <a:schemeClr val="accent1"/>
+          </a:lnRef>
+          <a:fillRef idx="3">
+            <a:schemeClr val="accent1"/>
+          </a:fillRef>
+          <a:effectRef idx="0">
+            <a:schemeClr val="accent1"/>
+          </a:effectRef>
+          <a:fontRef idx="minor">
+            <a:schemeClr val="lt1"/>
+          </a:fontRef>
+        </p:style>
+        <p:txBody>
+          <a:bodyPr rtlCol="0" anchor="ctr"/>
+          <a:lstStyle/>
+          <a:p>
+            <a:pPr algn="ctr"/>
+          </a:p>
+        </p:txBody>
+      </p:sp>
+      <p:sp>
+        <p:nvSpPr>
+          <p:cNvPr id="31" name="TextBox 30"/>
+          <p:cNvSpPr txBox="1"/>
+          <p:nvPr/>
+        </p:nvSpPr>
+        <p:spPr>
+          <a:xfrm>
+            <a:off x="713232" y="3931920"/>
+            <a:ext cx="7772400" cy="658368"/>
+          </a:xfrm>
+          <a:prstGeom prst="rect">
+            <a:avLst/>
+          </a:prstGeom>
+          <a:noFill/>
+        </p:spPr>
+        <p:txBody>
+          <a:bodyPr wrap="square" lIns="0" rIns="0" tIns="0" bIns="0">
+            <a:noAutofit/>
+          </a:bodyPr>
+          <a:lstStyle/>
           <a:p>
             <a:pPr algn="l">
               <a:lnSpc>
@@ -15492,247 +14768,29 @@
               <a:spcAft>
                 <a:spcPts val="400"/>
               </a:spcAft>
-              <a:defRPr sz="3300" b="1">
-                <a:solidFill>
-                  <a:srgbClr val="153B2D"/>
+              <a:defRPr sz="2900" b="0">
+                <a:solidFill>
+                  <a:srgbClr val="425D50"/>
                 </a:solidFill>
                 <a:latin typeface="Arial"/>
               </a:defRPr>
             </a:pPr>
             <a:r>
-              <a:t>Two synchronized clients.</a:t>
-            </a:r>
-          </a:p>
-          <a:p>
-            <a:pPr algn="l">
-              <a:lnSpc>
-                <a:spcPct val="106000"/>
-              </a:lnSpc>
-              <a:spcBef>
-                <a:spcPts val="0"/>
-              </a:spcBef>
-              <a:spcAft>
-                <a:spcPts val="400"/>
-              </a:spcAft>
-              <a:defRPr sz="3300" b="1">
-                <a:solidFill>
-                  <a:srgbClr val="153B2D"/>
-                </a:solidFill>
-                <a:latin typeface="Arial"/>
-              </a:defRPr>
-            </a:pPr>
-            <a:r>
-              <a:t>Persistent player results.</a:t>
-            </a:r>
-          </a:p>
-        </p:txBody>
-      </p:sp>
-      <p:sp>
-        <p:nvSpPr>
-          <p:cNvPr id="11" name="Rounded Rectangle 10"/>
-          <p:cNvSpPr/>
-          <p:nvPr/>
-        </p:nvSpPr>
-        <p:spPr>
-          <a:xfrm>
-            <a:off x="8321040" y="1874519"/>
-            <a:ext cx="3291840" cy="2761488"/>
-          </a:xfrm>
-          <a:prstGeom prst="roundRect">
-            <a:avLst>
-              <a:gd name="adj" fmla="val 12000"/>
-            </a:avLst>
-          </a:prstGeom>
-          <a:solidFill>
-            <a:srgbClr val="E8F0E7"/>
-          </a:solidFill>
-          <a:ln w="12700">
-            <a:solidFill>
-              <a:srgbClr val="CBD8CF"/>
-            </a:solidFill>
-          </a:ln>
-          <a:effectLst/>
-        </p:spPr>
-        <p:style>
-          <a:lnRef idx="1">
-            <a:schemeClr val="accent1"/>
-          </a:lnRef>
-          <a:fillRef idx="3">
-            <a:schemeClr val="accent1"/>
-          </a:fillRef>
-          <a:effectRef idx="0">
-            <a:schemeClr val="accent1"/>
-          </a:effectRef>
-          <a:fontRef idx="minor">
-            <a:schemeClr val="lt1"/>
-          </a:fontRef>
-        </p:style>
-        <p:txBody>
-          <a:bodyPr rtlCol="0" anchor="ctr"/>
-          <a:lstStyle/>
-          <a:p>
-            <a:pPr algn="ctr"/>
-          </a:p>
-        </p:txBody>
-      </p:sp>
-      <p:sp>
-        <p:nvSpPr>
-          <p:cNvPr id="12" name="TextBox 11"/>
+              <a:t>Questions &amp; discussion</a:t>
+            </a:r>
+          </a:p>
+        </p:txBody>
+      </p:sp>
+      <p:sp>
+        <p:nvSpPr>
+          <p:cNvPr id="32" name="TextBox 31"/>
           <p:cNvSpPr txBox="1"/>
           <p:nvPr/>
         </p:nvSpPr>
         <p:spPr>
           <a:xfrm>
-            <a:off x="8549640" y="2651760"/>
-            <a:ext cx="2834640" cy="640080"/>
-          </a:xfrm>
-          <a:prstGeom prst="rect">
-            <a:avLst/>
-          </a:prstGeom>
-          <a:noFill/>
-        </p:spPr>
-        <p:txBody>
-          <a:bodyPr wrap="square" lIns="0" rIns="0" tIns="0" bIns="0">
-            <a:noAutofit/>
-          </a:bodyPr>
-          <a:lstStyle/>
-          <a:p>
-            <a:pPr algn="ctr">
-              <a:lnSpc>
-                <a:spcPct val="106000"/>
-              </a:lnSpc>
-              <a:spcBef>
-                <a:spcPts val="0"/>
-              </a:spcBef>
-              <a:spcAft>
-                <a:spcPts val="400"/>
-              </a:spcAft>
-              <a:defRPr sz="2900" b="1">
-                <a:solidFill>
-                  <a:srgbClr val="153B2D"/>
-                </a:solidFill>
-                <a:latin typeface="Arial"/>
-              </a:defRPr>
-            </a:pPr>
-            <a:r>
-              <a:t>Built to play.</a:t>
-            </a:r>
-          </a:p>
-        </p:txBody>
-      </p:sp>
-      <p:sp>
-        <p:nvSpPr>
-          <p:cNvPr id="13" name="TextBox 12"/>
-          <p:cNvSpPr txBox="1"/>
-          <p:nvPr/>
-        </p:nvSpPr>
-        <p:spPr>
-          <a:xfrm>
-            <a:off x="8549640" y="3639312"/>
-            <a:ext cx="2834640" cy="731520"/>
-          </a:xfrm>
-          <a:prstGeom prst="rect">
-            <a:avLst/>
-          </a:prstGeom>
-          <a:noFill/>
-        </p:spPr>
-        <p:txBody>
-          <a:bodyPr wrap="square" lIns="0" rIns="0" tIns="0" bIns="0">
-            <a:noAutofit/>
-          </a:bodyPr>
-          <a:lstStyle/>
-          <a:p>
-            <a:pPr algn="ctr">
-              <a:lnSpc>
-                <a:spcPct val="106000"/>
-              </a:lnSpc>
-              <a:spcBef>
-                <a:spcPts val="0"/>
-              </a:spcBef>
-              <a:spcAft>
-                <a:spcPts val="400"/>
-              </a:spcAft>
-              <a:defRPr sz="2200" b="0">
-                <a:solidFill>
-                  <a:srgbClr val="425D50"/>
-                </a:solidFill>
-                <a:latin typeface="Arial"/>
-              </a:defRPr>
-            </a:pPr>
-            <a:r>
-              <a:t>Rules · Networking</a:t>
-            </a:r>
-          </a:p>
-          <a:p>
-            <a:pPr algn="ctr">
-              <a:lnSpc>
-                <a:spcPct val="106000"/>
-              </a:lnSpc>
-              <a:spcBef>
-                <a:spcPts val="0"/>
-              </a:spcBef>
-              <a:spcAft>
-                <a:spcPts val="400"/>
-              </a:spcAft>
-              <a:defRPr sz="2200" b="0">
-                <a:solidFill>
-                  <a:srgbClr val="425D50"/>
-                </a:solidFill>
-                <a:latin typeface="Arial"/>
-              </a:defRPr>
-            </a:pPr>
-            <a:r>
-              <a:t>BOT · Profiles</a:t>
-            </a:r>
-          </a:p>
-        </p:txBody>
-      </p:sp>
-      <p:cxnSp>
-        <p:nvCxnSpPr>
-          <p:cNvPr id="14" name="Connector 13"/>
-          <p:cNvCxnSpPr/>
-          <p:nvPr/>
-        </p:nvCxnSpPr>
-        <p:spPr>
-          <a:xfrm>
-            <a:off x="594360" y="4507992"/>
-            <a:ext cx="6720840" cy="0"/>
-          </a:xfrm>
-          <a:prstGeom prst="line">
-            <a:avLst/>
-          </a:prstGeom>
-          <a:ln w="17780">
-            <a:solidFill>
-              <a:srgbClr val="CBD8CF"/>
-            </a:solidFill>
-          </a:ln>
-          <a:effectLst/>
-        </p:spPr>
-        <p:style>
-          <a:lnRef idx="2">
-            <a:schemeClr val="accent1"/>
-          </a:lnRef>
-          <a:fillRef idx="0">
-            <a:schemeClr val="accent1"/>
-          </a:fillRef>
-          <a:effectRef idx="0">
-            <a:schemeClr val="accent1"/>
-          </a:effectRef>
-          <a:fontRef idx="minor">
-            <a:schemeClr val="tx1"/>
-          </a:fontRef>
-        </p:style>
-      </p:cxnSp>
-      <p:sp>
-        <p:nvSpPr>
-          <p:cNvPr id="15" name="TextBox 14"/>
-          <p:cNvSpPr txBox="1"/>
-          <p:nvPr/>
-        </p:nvSpPr>
-        <p:spPr>
-          <a:xfrm>
-            <a:off x="594360" y="4773168"/>
-            <a:ext cx="7315200" cy="914400"/>
+            <a:off x="713232" y="5715000"/>
+            <a:ext cx="10789920" cy="438912"/>
           </a:xfrm>
           <a:prstGeom prst="rect">
             <a:avLst/>
@@ -15756,73 +14814,6 @@
                 <a:spcPts val="400"/>
               </a:spcAft>
               <a:defRPr sz="2300" b="0">
-                <a:solidFill>
-                  <a:srgbClr val="153B2D"/>
-                </a:solidFill>
-                <a:latin typeface="Arial"/>
-              </a:defRPr>
-            </a:pPr>
-            <a:r>
-              <a:t>Rabea Abu Aad — Game Logic</a:t>
-            </a:r>
-          </a:p>
-          <a:p>
-            <a:pPr algn="l">
-              <a:lnSpc>
-                <a:spcPct val="106000"/>
-              </a:lnSpc>
-              <a:spcBef>
-                <a:spcPts val="0"/>
-              </a:spcBef>
-              <a:spcAft>
-                <a:spcPts val="400"/>
-              </a:spcAft>
-              <a:defRPr sz="2300" b="0">
-                <a:solidFill>
-                  <a:srgbClr val="153B2D"/>
-                </a:solidFill>
-                <a:latin typeface="Arial"/>
-              </a:defRPr>
-            </a:pPr>
-            <a:r>
-              <a:t>Muthanna Farhat — TCP Communication</a:t>
-            </a:r>
-          </a:p>
-        </p:txBody>
-      </p:sp>
-      <p:sp>
-        <p:nvSpPr>
-          <p:cNvPr id="16" name="TextBox 15"/>
-          <p:cNvSpPr txBox="1"/>
-          <p:nvPr/>
-        </p:nvSpPr>
-        <p:spPr>
-          <a:xfrm>
-            <a:off x="594360" y="5888736"/>
-            <a:ext cx="9966960" cy="384048"/>
-          </a:xfrm>
-          <a:prstGeom prst="rect">
-            <a:avLst/>
-          </a:prstGeom>
-          <a:noFill/>
-        </p:spPr>
-        <p:txBody>
-          <a:bodyPr wrap="square" lIns="0" rIns="0" tIns="0" bIns="0">
-            <a:noAutofit/>
-          </a:bodyPr>
-          <a:lstStyle/>
-          <a:p>
-            <a:pPr algn="l">
-              <a:lnSpc>
-                <a:spcPct val="106000"/>
-              </a:lnSpc>
-              <a:spcBef>
-                <a:spcPts val="0"/>
-              </a:spcBef>
-              <a:spcAft>
-                <a:spcPts val="400"/>
-              </a:spcAft>
-              <a:defRPr sz="2200" b="0">
                 <a:solidFill>
                   <a:srgbClr val="285942"/>
                 </a:solidFill>

</xml_diff>

<commit_message>
Align presentation with project book and clarify technical terms
</commit_message>
<xml_diff>
--- a/docs/presentation/Damka_Presentation.pptx
+++ b/docs/presentation/Damka_Presentation.pptx
@@ -634,7 +634,7 @@
               <a:rPr sz="1200">
                 <a:latin typeface="Arial"/>
               </a:rPr>
-              <a:t>בחרנו להציג אתגרים ולצדם החלטות מימוש, כדי להראות את שיקול הדעת בתהליך. האתגר הראשון הוא לשמור ששני משתמשים יראו אותו משחק: השרת מאשר מהלך באמצעות Game ואז משדר לשניהם את אותה תמונת לוח ותור. כך הלקוח אינו קובע לבדו את המצב המקוון.</a:t>
+              <a:t>האתגרים תואמים לפרק 12.2 בספר הפרויקט. תחילה נדרש ללמוד את כללי הדמקה: תנועה, אכילה מחייבת, רצף אכילות והכתרה, ולהגדיר מצבי משחק לבדיקת המימוש. JavaFX הייתה ספריית ממשק חדשה, ולכן היה צורך ללמוד איך לארגן רכיבים בחלון ואיך לחבר כפתורים ולחיצות על הלוח לפעולות.</a:t>
             </a:r>
           </a:p>
           <a:p>
@@ -646,19 +646,7 @@
               <a:rPr sz="1200">
                 <a:latin typeface="Arial"/>
               </a:rPr>
-              <a:t>האתגר השני הוא תיאום בין רשת לבין JavaFX ואנימציה. RoomConnection קוראת ברקע ושולחת לפי סדר, Platform.runLater מעבירה עדכוני מסך לחוט JavaFX, ותור ההודעות ב־DamkaFX ממתין לסיום האנימציה לפני החלת BOARD ו־TURN. אין לטעון שכל החישובים נעשים ברקע: חיפוש BOT במימוש הנוכחי מופעל מחוט הממשק.</a:t>
-            </a:r>
-          </a:p>
-          <a:p>
-            <a:pPr algn="r" rtl="1"/>
-          </a:p>
-          <a:p>
-            <a:pPr algn="r" rtl="1"/>
-            <a:r>
-              <a:rPr sz="1200">
-                <a:latin typeface="Arial"/>
-              </a:rPr>
-              <a:t>האתגר השלישי הוא התאמה בין חוקי המשחק האמיתי לבין מה שה־BOT מדמה. הפתרון הוא שימוש באותן פונקציות של Game, ובעותקים עצמאיים בזמן החיפוש. לאורך הדרך היה צורך ללמוד את כללי הדמקה, להכיר את JavaFX אחרי ניסיון בממשקי HTML, ולהפוך ידע תאורטי ב־TCP לחיבורי Socket ולפרוטוקול הודעות מעשי.</a:t>
+              <a:t>ב־TCP יושם לראשונה בפועל הידע התאורטי מקורס רשתות תקשורת, באמצעות חיבורים בין לקוחות לשרת והעברת הודעות משחק. בנוסף, המעבר מהניסיון המוכר בממשקי HTML ל־JavaFX דרש ללמוד דרך שונה לארגון הממשק ולטיפול באירועי המשתמש.</a:t>
             </a:r>
           </a:p>
         </p:txBody>
@@ -753,7 +741,7 @@
               <a:rPr sz="1200">
                 <a:latin typeface="Arial"/>
               </a:rPr>
-              <a:t>התרומה בפרויקט כוללת הגדרת דרישות, בחירת התנהגות המערכת, החלטות תכנון, שילוב הרכיבים, בדיקות ולמידת הזרימה בקוד. אפשר להצביע על שלוש החלטות מוחשיות שנדונו לאורך העבודה: השרת הוא שמאשר מצב מקוון; חוקי המשחק מרוכזים ב־Game; תוצאות והיסטוריה נשמרות רק למשחק מזוהה בהתאם לתנאי החיבור. לצד זאת בוצעו הרצות עם שני לקוחות, זוהו בעיות של הודעת מהלך לא תקין שנשארת ושל אנימציה במיקום שגוי, ונדרשו שינויים לפישוט הקוד והממשק.</a:t>
+              <a:t>השקף מציג את תחומי האחריות שהוגדרו בפרויקט, בהתאם לפרק 11 בספר. תחום האחריות של רביע הוא לוגיקת המשחק: תנועה ואכילה, ניהול תורות והכתרה, וקביעת סיום המשחק והמנצח. תחום האחריות של מותנא הוא חיבור TCP בין לקוחות JavaFX לשרת: פתיחת חיבורים והעברת בקשות ותשובות לשמירת מצב משחק מסונכרן.</a:t>
             </a:r>
           </a:p>
           <a:p>
@@ -765,19 +753,7 @@
               <a:rPr sz="1200">
                 <a:latin typeface="Arial"/>
               </a:rPr>
-              <a:t>נעשה שימוש נרחב ב־Codex וב־GitHub Copilot לתכנון, ליצירת קוד ולשינויו, להסברים, לבדיקות ולתיעוד. התהליך כלל הגדרת הדרישה, בחינת התוצר, הרצה, דיווח על בעיה ותיקון. לכן מציגים גם את ההחלטות ואת האימות של התוצאה, לצד העזרה בכתיבה.</a:t>
-            </a:r>
-          </a:p>
-          <a:p>
-            <a:pPr algn="r" rtl="1"/>
-          </a:p>
-          <a:p>
-            <a:pPr algn="r" rtl="1"/>
-            <a:r>
-              <a:rPr sz="1200">
-                <a:latin typeface="Arial"/>
-              </a:rPr>
-              <a:t>תחומי האחריות שהוגדרו בפרויקט: רביע — לוגיקת המשחק; מותנא — חיבור TCP. אין צורך להעריך אחוזי קוד. אם נשאלים על פונקציה, להסביר את האחריות שלה ואת מסלול הקריאה ולא להסתפק באמירה שכלי AI כתב אותה.</a:t>
+              <a:t>בהתאם לפרק 10, נעשה שימוש נרחב ב־Codex וב־GitHub Copilot ללמידה ולתכנון, לכתיבת הקוד ולשינויו, לעיצוב הממשק ולהכנת בדיקות ותיעוד. תהליך העבודה כלל הגדרת דרישות, קבלת הצעות, קריאת הקוד וההסברים, הרצה ובדיקות והתאמות בהתאם לתוצאות. תחומי האחריות מתארים את חלוקת הנושאים; הם אינם טענה שכל הקוד בתחום נכתב באופן עצמאי ללא סיוע.</a:t>
             </a:r>
           </a:p>
         </p:txBody>
@@ -1205,6 +1181,18 @@
               <a:rPr sz="1200">
                 <a:latin typeface="Arial"/>
               </a:rPr>
+              <a:t>JDBC הוא קיצור של Java Database Connectivity. זהו המנגנון שבו קוד Java עובד מול מסד הנתונים. בפרויקט, ProfileDatabase משתמשת בו כדי לפתוח חיבור ל־SQLite, לשלוח שאילתות SQL ולקרוא או לשמור נתונים. למשל, כשנשמר חשבון חדש, הקוד שולח את פעולת ההוספה דרך JDBC אל קובץ מסד הנתונים. זהו חיבור למסד הנתונים, בנפרד מחיבור ה־TCP שבין יישום השחקן לשרת.</a:t>
+            </a:r>
+          </a:p>
+          <a:p>
+            <a:pPr algn="r" rtl="1"/>
+          </a:p>
+          <a:p>
+            <a:pPr algn="r" rtl="1"/>
+            <a:r>
+              <a:rPr sz="1200">
+                <a:latin typeface="Arial"/>
+              </a:rPr>
               <a:t>כלי הבנייה הוא Gradle, והבדיקות נכתבו באמצעות JUnit 5. Git ו־GitHub שימשו לניהול גרסאות. גרסאות שמופיעות בקובצי הפרויקט: JavaFX 17.0.6, Gradle 8.8, sqlite-jdbc 3.50.3.0 ו־JUnit 5.10.2. אין צורך להקריא את כל המספרים; העיקר הוא להסביר את התפקיד של כל טכנולוגיה.</a:t>
             </a:r>
           </a:p>
@@ -1699,7 +1687,7 @@
               <a:rPr sz="1200">
                 <a:latin typeface="Arial"/>
               </a:rPr>
-              <a:t>להצביע על העץ: בתור ה־BOT מחפשים ציון גבוה; בתור היריב מניחים שהוא יבחר ציון נמוך מבחינת ה־BOT. בענף השמאלי היריב יכול לכפות מינוס 3, ובימני 0, ולכן ה־BOT מעדיף את הימני. הציונים בשקף הם המחשה, לא עקבה של משחק מסוים.</a:t>
+              <a:t>להסביר את המספרים מלמטה למעלה. כל ציון הוא מנקודת המבט של ה־BOT. במהלך A, היריב יכול לבחור בין ציון 3 לבין מינוס 3, ולכן MIN מחזירה מינוס 3. במהלך B, היריב יכול לבחור בין 0 לבין 3, ולכן MIN מחזירה 0. בשורש, ה־BOT משווה MAX בין מינוס 3 לבין 0 ובוחר במהלך B. התוצאה המספרית היא 0, והמהלך שנבחר הוא B, המסומן בירוק. 0 הוא ציון הערכה של מצב הלוח בעומק שנבדק; הוא אינו הודעה שהמשחק הסתיים בתיקו. הציונים בשקף הם המחשה קצרה, לא עקבה של משחק מסוים.</a:t>
             </a:r>
           </a:p>
           <a:p>
@@ -5880,7 +5868,7 @@
               </a:defRPr>
             </a:pPr>
             <a:r>
-              <a:t>Engineering challenges and our solutions</a:t>
+              <a:t>Challenges and what we learned</a:t>
             </a:r>
           </a:p>
         </p:txBody>
@@ -6019,8 +6007,8 @@
         </p:nvSpPr>
         <p:spPr>
           <a:xfrm>
-            <a:off x="548640" y="1965960"/>
-            <a:ext cx="3538728" cy="3703320"/>
+            <a:off x="548640" y="1938528"/>
+            <a:ext cx="5431536" cy="1874519"/>
           </a:xfrm>
           <a:prstGeom prst="roundRect">
             <a:avLst>
@@ -6067,8 +6055,8 @@
         </p:nvSpPr>
         <p:spPr>
           <a:xfrm>
-            <a:off x="566928" y="2167128"/>
-            <a:ext cx="41148" cy="3300984"/>
+            <a:off x="566928" y="2139696"/>
+            <a:ext cx="41148" cy="1472184"/>
           </a:xfrm>
           <a:prstGeom prst="rect">
             <a:avLst/>
@@ -6111,8 +6099,8 @@
         </p:nvSpPr>
         <p:spPr>
           <a:xfrm>
-            <a:off x="777240" y="2185415"/>
-            <a:ext cx="3081528" cy="594360"/>
+            <a:off x="777240" y="2157984"/>
+            <a:ext cx="4974336" cy="594360"/>
           </a:xfrm>
           <a:prstGeom prst="rect">
             <a:avLst/>
@@ -6135,7 +6123,7 @@
               <a:spcAft>
                 <a:spcPts val="400"/>
               </a:spcAft>
-              <a:defRPr sz="2200" b="1">
+              <a:defRPr sz="2500" b="1">
                 <a:solidFill>
                   <a:srgbClr val="153B2D"/>
                 </a:solidFill>
@@ -6143,7 +6131,7 @@
               </a:defRPr>
             </a:pPr>
             <a:r>
-              <a:t>Online consistency</a:t>
+              <a:t>Learning checkers rules</a:t>
             </a:r>
           </a:p>
         </p:txBody>
@@ -6156,8 +6144,8 @@
         </p:nvSpPr>
         <p:spPr>
           <a:xfrm>
-            <a:off x="777240" y="2926080"/>
-            <a:ext cx="3081528" cy="2587752"/>
+            <a:off x="777240" y="2898648"/>
+            <a:ext cx="4974336" cy="758951"/>
           </a:xfrm>
           <a:prstGeom prst="rect">
             <a:avLst/>
@@ -6188,7 +6176,7 @@
               </a:defRPr>
             </a:pPr>
             <a:r>
-              <a:t>Challenge</a:t>
+              <a:t>Movement, mandatory captures,</a:t>
             </a:r>
           </a:p>
           <a:p>
@@ -6210,92 +6198,7 @@
               </a:defRPr>
             </a:pPr>
             <a:r>
-              <a:t>Two screens, one game</a:t>
-            </a:r>
-          </a:p>
-          <a:p>
-            <a:pPr algn="l">
-              <a:lnSpc>
-                <a:spcPct val="106000"/>
-              </a:lnSpc>
-              <a:spcBef>
-                <a:spcPts val="0"/>
-              </a:spcBef>
-              <a:spcAft>
-                <a:spcPts val="400"/>
-              </a:spcAft>
-              <a:defRPr sz="2100" b="0">
-                <a:solidFill>
-                  <a:srgbClr val="425D50"/>
-                </a:solidFill>
-                <a:latin typeface="Arial"/>
-              </a:defRPr>
-            </a:pPr>
-          </a:p>
-          <a:p>
-            <a:pPr algn="l">
-              <a:lnSpc>
-                <a:spcPct val="106000"/>
-              </a:lnSpc>
-              <a:spcBef>
-                <a:spcPts val="0"/>
-              </a:spcBef>
-              <a:spcAft>
-                <a:spcPts val="400"/>
-              </a:spcAft>
-              <a:defRPr sz="2100" b="0">
-                <a:solidFill>
-                  <a:srgbClr val="425D50"/>
-                </a:solidFill>
-                <a:latin typeface="Arial"/>
-              </a:defRPr>
-            </a:pPr>
-            <a:r>
-              <a:t>Solution</a:t>
-            </a:r>
-          </a:p>
-          <a:p>
-            <a:pPr algn="l">
-              <a:lnSpc>
-                <a:spcPct val="106000"/>
-              </a:lnSpc>
-              <a:spcBef>
-                <a:spcPts val="0"/>
-              </a:spcBef>
-              <a:spcAft>
-                <a:spcPts val="400"/>
-              </a:spcAft>
-              <a:defRPr sz="2100" b="0">
-                <a:solidFill>
-                  <a:srgbClr val="425D50"/>
-                </a:solidFill>
-                <a:latin typeface="Arial"/>
-              </a:defRPr>
-            </a:pPr>
-            <a:r>
-              <a:t>Server validates moves</a:t>
-            </a:r>
-          </a:p>
-          <a:p>
-            <a:pPr algn="l">
-              <a:lnSpc>
-                <a:spcPct val="106000"/>
-              </a:lnSpc>
-              <a:spcBef>
-                <a:spcPts val="0"/>
-              </a:spcBef>
-              <a:spcAft>
-                <a:spcPts val="400"/>
-              </a:spcAft>
-              <a:defRPr sz="2100" b="0">
-                <a:solidFill>
-                  <a:srgbClr val="425D50"/>
-                </a:solidFill>
-                <a:latin typeface="Arial"/>
-              </a:defRPr>
-            </a:pPr>
-            <a:r>
-              <a:t>Both clients update</a:t>
+              <a:t>capture chains and promotion.</a:t>
             </a:r>
           </a:p>
         </p:txBody>
@@ -6308,8 +6211,8 @@
         </p:nvSpPr>
         <p:spPr>
           <a:xfrm>
-            <a:off x="4325112" y="1965960"/>
-            <a:ext cx="3538728" cy="3703320"/>
+            <a:off x="6217920" y="1938528"/>
+            <a:ext cx="5431536" cy="1874519"/>
           </a:xfrm>
           <a:prstGeom prst="roundRect">
             <a:avLst>
@@ -6356,8 +6259,8 @@
         </p:nvSpPr>
         <p:spPr>
           <a:xfrm>
-            <a:off x="4343400" y="2167128"/>
-            <a:ext cx="41148" cy="3300984"/>
+            <a:off x="6236207" y="2139696"/>
+            <a:ext cx="41148" cy="1472184"/>
           </a:xfrm>
           <a:prstGeom prst="rect">
             <a:avLst/>
@@ -6400,8 +6303,8 @@
         </p:nvSpPr>
         <p:spPr>
           <a:xfrm>
-            <a:off x="4553712" y="2185415"/>
-            <a:ext cx="3081528" cy="594360"/>
+            <a:off x="6446520" y="2157984"/>
+            <a:ext cx="4974336" cy="594360"/>
           </a:xfrm>
           <a:prstGeom prst="rect">
             <a:avLst/>
@@ -6424,7 +6327,7 @@
               <a:spcAft>
                 <a:spcPts val="400"/>
               </a:spcAft>
-              <a:defRPr sz="2200" b="1">
+              <a:defRPr sz="2500" b="1">
                 <a:solidFill>
                   <a:srgbClr val="153B2D"/>
                 </a:solidFill>
@@ -6432,7 +6335,7 @@
               </a:defRPr>
             </a:pPr>
             <a:r>
-              <a:t>Network + UI timing</a:t>
+              <a:t>Learning JavaFX</a:t>
             </a:r>
           </a:p>
         </p:txBody>
@@ -6445,8 +6348,8 @@
         </p:nvSpPr>
         <p:spPr>
           <a:xfrm>
-            <a:off x="4553712" y="2926080"/>
-            <a:ext cx="3081528" cy="2587752"/>
+            <a:off x="6446520" y="2898648"/>
+            <a:ext cx="4974336" cy="758951"/>
           </a:xfrm>
           <a:prstGeom prst="rect">
             <a:avLst/>
@@ -6477,7 +6380,7 @@
               </a:defRPr>
             </a:pPr>
             <a:r>
-              <a:t>Challenge</a:t>
+              <a:t>Learn a new UI library and connect</a:t>
             </a:r>
           </a:p>
           <a:p>
@@ -6499,92 +6402,7 @@
               </a:defRPr>
             </a:pPr>
             <a:r>
-              <a:t>Updates during animation</a:t>
-            </a:r>
-          </a:p>
-          <a:p>
-            <a:pPr algn="l">
-              <a:lnSpc>
-                <a:spcPct val="106000"/>
-              </a:lnSpc>
-              <a:spcBef>
-                <a:spcPts val="0"/>
-              </a:spcBef>
-              <a:spcAft>
-                <a:spcPts val="400"/>
-              </a:spcAft>
-              <a:defRPr sz="2100" b="0">
-                <a:solidFill>
-                  <a:srgbClr val="425D50"/>
-                </a:solidFill>
-                <a:latin typeface="Arial"/>
-              </a:defRPr>
-            </a:pPr>
-          </a:p>
-          <a:p>
-            <a:pPr algn="l">
-              <a:lnSpc>
-                <a:spcPct val="106000"/>
-              </a:lnSpc>
-              <a:spcBef>
-                <a:spcPts val="0"/>
-              </a:spcBef>
-              <a:spcAft>
-                <a:spcPts val="400"/>
-              </a:spcAft>
-              <a:defRPr sz="2100" b="0">
-                <a:solidFill>
-                  <a:srgbClr val="425D50"/>
-                </a:solidFill>
-                <a:latin typeface="Arial"/>
-              </a:defRPr>
-            </a:pPr>
-            <a:r>
-              <a:t>Solution</a:t>
-            </a:r>
-          </a:p>
-          <a:p>
-            <a:pPr algn="l">
-              <a:lnSpc>
-                <a:spcPct val="106000"/>
-              </a:lnSpc>
-              <a:spcBef>
-                <a:spcPts val="0"/>
-              </a:spcBef>
-              <a:spcAft>
-                <a:spcPts val="400"/>
-              </a:spcAft>
-              <a:defRPr sz="2100" b="0">
-                <a:solidFill>
-                  <a:srgbClr val="425D50"/>
-                </a:solidFill>
-                <a:latin typeface="Arial"/>
-              </a:defRPr>
-            </a:pPr>
-            <a:r>
-              <a:t>Background network I/O</a:t>
-            </a:r>
-          </a:p>
-          <a:p>
-            <a:pPr algn="l">
-              <a:lnSpc>
-                <a:spcPct val="106000"/>
-              </a:lnSpc>
-              <a:spcBef>
-                <a:spcPts val="0"/>
-              </a:spcBef>
-              <a:spcAft>
-                <a:spcPts val="400"/>
-              </a:spcAft>
-              <a:defRPr sz="2100" b="0">
-                <a:solidFill>
-                  <a:srgbClr val="425D50"/>
-                </a:solidFill>
-                <a:latin typeface="Arial"/>
-              </a:defRPr>
-            </a:pPr>
-            <a:r>
-              <a:t>Queued UI updates</a:t>
+              <a:t>buttons and board clicks to actions.</a:t>
             </a:r>
           </a:p>
         </p:txBody>
@@ -6597,8 +6415,8 @@
         </p:nvSpPr>
         <p:spPr>
           <a:xfrm>
-            <a:off x="8110727" y="1965960"/>
-            <a:ext cx="3538728" cy="3703320"/>
+            <a:off x="548640" y="4023360"/>
+            <a:ext cx="5431536" cy="1874519"/>
           </a:xfrm>
           <a:prstGeom prst="roundRect">
             <a:avLst>
@@ -6645,8 +6463,212 @@
         </p:nvSpPr>
         <p:spPr>
           <a:xfrm>
-            <a:off x="8129015" y="2167128"/>
-            <a:ext cx="41148" cy="3300984"/>
+            <a:off x="566928" y="4224528"/>
+            <a:ext cx="41148" cy="1472184"/>
+          </a:xfrm>
+          <a:prstGeom prst="rect">
+            <a:avLst/>
+          </a:prstGeom>
+          <a:solidFill>
+            <a:srgbClr val="285942"/>
+          </a:solidFill>
+          <a:ln>
+            <a:noFill/>
+          </a:ln>
+          <a:effectLst/>
+        </p:spPr>
+        <p:style>
+          <a:lnRef idx="1">
+            <a:schemeClr val="accent1"/>
+          </a:lnRef>
+          <a:fillRef idx="3">
+            <a:schemeClr val="accent1"/>
+          </a:fillRef>
+          <a:effectRef idx="0">
+            <a:schemeClr val="accent1"/>
+          </a:effectRef>
+          <a:fontRef idx="minor">
+            <a:schemeClr val="lt1"/>
+          </a:fontRef>
+        </p:style>
+        <p:txBody>
+          <a:bodyPr rtlCol="0" anchor="ctr"/>
+          <a:lstStyle/>
+          <a:p>
+            <a:pPr algn="ctr"/>
+          </a:p>
+        </p:txBody>
+      </p:sp>
+      <p:sp>
+        <p:nvSpPr>
+          <p:cNvPr id="20" name="TextBox 19"/>
+          <p:cNvSpPr txBox="1"/>
+          <p:nvPr/>
+        </p:nvSpPr>
+        <p:spPr>
+          <a:xfrm>
+            <a:off x="777240" y="4242816"/>
+            <a:ext cx="4974336" cy="594360"/>
+          </a:xfrm>
+          <a:prstGeom prst="rect">
+            <a:avLst/>
+          </a:prstGeom>
+          <a:noFill/>
+        </p:spPr>
+        <p:txBody>
+          <a:bodyPr wrap="square" lIns="0" rIns="0" tIns="0" bIns="0">
+            <a:noAutofit/>
+          </a:bodyPr>
+          <a:lstStyle/>
+          <a:p>
+            <a:pPr algn="l">
+              <a:lnSpc>
+                <a:spcPct val="106000"/>
+              </a:lnSpc>
+              <a:spcBef>
+                <a:spcPts val="0"/>
+              </a:spcBef>
+              <a:spcAft>
+                <a:spcPts val="400"/>
+              </a:spcAft>
+              <a:defRPr sz="2500" b="1">
+                <a:solidFill>
+                  <a:srgbClr val="153B2D"/>
+                </a:solidFill>
+                <a:latin typeface="Arial"/>
+              </a:defRPr>
+            </a:pPr>
+            <a:r>
+              <a:t>TCP in practice</a:t>
+            </a:r>
+          </a:p>
+        </p:txBody>
+      </p:sp>
+      <p:sp>
+        <p:nvSpPr>
+          <p:cNvPr id="21" name="TextBox 20"/>
+          <p:cNvSpPr txBox="1"/>
+          <p:nvPr/>
+        </p:nvSpPr>
+        <p:spPr>
+          <a:xfrm>
+            <a:off x="777240" y="4983480"/>
+            <a:ext cx="4974336" cy="758951"/>
+          </a:xfrm>
+          <a:prstGeom prst="rect">
+            <a:avLst/>
+          </a:prstGeom>
+          <a:noFill/>
+        </p:spPr>
+        <p:txBody>
+          <a:bodyPr wrap="square" lIns="0" rIns="0" tIns="0" bIns="0">
+            <a:noAutofit/>
+          </a:bodyPr>
+          <a:lstStyle/>
+          <a:p>
+            <a:pPr algn="l">
+              <a:lnSpc>
+                <a:spcPct val="106000"/>
+              </a:lnSpc>
+              <a:spcBef>
+                <a:spcPts val="0"/>
+              </a:spcBef>
+              <a:spcAft>
+                <a:spcPts val="400"/>
+              </a:spcAft>
+              <a:defRPr sz="2100" b="0">
+                <a:solidFill>
+                  <a:srgbClr val="425D50"/>
+                </a:solidFill>
+                <a:latin typeface="Arial"/>
+              </a:defRPr>
+            </a:pPr>
+            <a:r>
+              <a:t>Apply course theory to real</a:t>
+            </a:r>
+          </a:p>
+          <a:p>
+            <a:pPr algn="l">
+              <a:lnSpc>
+                <a:spcPct val="106000"/>
+              </a:lnSpc>
+              <a:spcBef>
+                <a:spcPts val="0"/>
+              </a:spcBef>
+              <a:spcAft>
+                <a:spcPts val="400"/>
+              </a:spcAft>
+              <a:defRPr sz="2100" b="0">
+                <a:solidFill>
+                  <a:srgbClr val="425D50"/>
+                </a:solidFill>
+                <a:latin typeface="Arial"/>
+              </a:defRPr>
+            </a:pPr>
+            <a:r>
+              <a:t>client–server connections and messages.</a:t>
+            </a:r>
+          </a:p>
+        </p:txBody>
+      </p:sp>
+      <p:sp>
+        <p:nvSpPr>
+          <p:cNvPr id="22" name="Rounded Rectangle 21"/>
+          <p:cNvSpPr/>
+          <p:nvPr/>
+        </p:nvSpPr>
+        <p:spPr>
+          <a:xfrm>
+            <a:off x="6217920" y="4023360"/>
+            <a:ext cx="5431536" cy="1874519"/>
+          </a:xfrm>
+          <a:prstGeom prst="roundRect">
+            <a:avLst>
+              <a:gd name="adj" fmla="val 12000"/>
+            </a:avLst>
+          </a:prstGeom>
+          <a:solidFill>
+            <a:srgbClr val="FFFFFF"/>
+          </a:solidFill>
+          <a:ln w="12700">
+            <a:solidFill>
+              <a:srgbClr val="CBD8CF"/>
+            </a:solidFill>
+          </a:ln>
+          <a:effectLst/>
+        </p:spPr>
+        <p:style>
+          <a:lnRef idx="1">
+            <a:schemeClr val="accent1"/>
+          </a:lnRef>
+          <a:fillRef idx="3">
+            <a:schemeClr val="accent1"/>
+          </a:fillRef>
+          <a:effectRef idx="0">
+            <a:schemeClr val="accent1"/>
+          </a:effectRef>
+          <a:fontRef idx="minor">
+            <a:schemeClr val="lt1"/>
+          </a:fontRef>
+        </p:style>
+        <p:txBody>
+          <a:bodyPr rtlCol="0" anchor="ctr"/>
+          <a:lstStyle/>
+          <a:p>
+            <a:pPr algn="ctr"/>
+          </a:p>
+        </p:txBody>
+      </p:sp>
+      <p:sp>
+        <p:nvSpPr>
+          <p:cNvPr id="23" name="Rectangle 22"/>
+          <p:cNvSpPr/>
+          <p:nvPr/>
+        </p:nvSpPr>
+        <p:spPr>
+          <a:xfrm>
+            <a:off x="6236207" y="4224528"/>
+            <a:ext cx="41148" cy="1472184"/>
           </a:xfrm>
           <a:prstGeom prst="rect">
             <a:avLst/>
@@ -6683,14 +6705,14 @@
       </p:sp>
       <p:sp>
         <p:nvSpPr>
-          <p:cNvPr id="20" name="TextBox 19"/>
+          <p:cNvPr id="24" name="TextBox 23"/>
           <p:cNvSpPr txBox="1"/>
           <p:nvPr/>
         </p:nvSpPr>
         <p:spPr>
           <a:xfrm>
-            <a:off x="8339327" y="2185415"/>
-            <a:ext cx="3081528" cy="594360"/>
+            <a:off x="6446520" y="4242816"/>
+            <a:ext cx="4974336" cy="594360"/>
           </a:xfrm>
           <a:prstGeom prst="rect">
             <a:avLst/>
@@ -6713,7 +6735,7 @@
               <a:spcAft>
                 <a:spcPts val="400"/>
               </a:spcAft>
-              <a:defRPr sz="2200" b="1">
+              <a:defRPr sz="2500" b="1">
                 <a:solidFill>
                   <a:srgbClr val="153B2D"/>
                 </a:solidFill>
@@ -6721,21 +6743,21 @@
               </a:defRPr>
             </a:pPr>
             <a:r>
-              <a:t>Rules + BOT search</a:t>
-            </a:r>
-          </a:p>
-        </p:txBody>
-      </p:sp>
-      <p:sp>
-        <p:nvSpPr>
-          <p:cNvPr id="21" name="TextBox 20"/>
+              <a:t>From HTML to JavaFX</a:t>
+            </a:r>
+          </a:p>
+        </p:txBody>
+      </p:sp>
+      <p:sp>
+        <p:nvSpPr>
+          <p:cNvPr id="25" name="TextBox 24"/>
           <p:cNvSpPr txBox="1"/>
           <p:nvPr/>
         </p:nvSpPr>
         <p:spPr>
           <a:xfrm>
-            <a:off x="8339327" y="2926080"/>
-            <a:ext cx="3081528" cy="2587752"/>
+            <a:off x="6446520" y="4983480"/>
+            <a:ext cx="4974336" cy="758951"/>
           </a:xfrm>
           <a:prstGeom prst="rect">
             <a:avLst/>
@@ -6766,7 +6788,7 @@
               </a:defRPr>
             </a:pPr>
             <a:r>
-              <a:t>Challenge</a:t>
+              <a:t>Adapt familiar web layouts to</a:t>
             </a:r>
           </a:p>
           <a:p>
@@ -6788,137 +6810,7 @@
               </a:defRPr>
             </a:pPr>
             <a:r>
-              <a:t>Consistent move rules</a:t>
-            </a:r>
-          </a:p>
-          <a:p>
-            <a:pPr algn="l">
-              <a:lnSpc>
-                <a:spcPct val="106000"/>
-              </a:lnSpc>
-              <a:spcBef>
-                <a:spcPts val="0"/>
-              </a:spcBef>
-              <a:spcAft>
-                <a:spcPts val="400"/>
-              </a:spcAft>
-              <a:defRPr sz="2100" b="0">
-                <a:solidFill>
-                  <a:srgbClr val="425D50"/>
-                </a:solidFill>
-                <a:latin typeface="Arial"/>
-              </a:defRPr>
-            </a:pPr>
-          </a:p>
-          <a:p>
-            <a:pPr algn="l">
-              <a:lnSpc>
-                <a:spcPct val="106000"/>
-              </a:lnSpc>
-              <a:spcBef>
-                <a:spcPts val="0"/>
-              </a:spcBef>
-              <a:spcAft>
-                <a:spcPts val="400"/>
-              </a:spcAft>
-              <a:defRPr sz="2100" b="0">
-                <a:solidFill>
-                  <a:srgbClr val="425D50"/>
-                </a:solidFill>
-                <a:latin typeface="Arial"/>
-              </a:defRPr>
-            </a:pPr>
-            <a:r>
-              <a:t>Solution</a:t>
-            </a:r>
-          </a:p>
-          <a:p>
-            <a:pPr algn="l">
-              <a:lnSpc>
-                <a:spcPct val="106000"/>
-              </a:lnSpc>
-              <a:spcBef>
-                <a:spcPts val="0"/>
-              </a:spcBef>
-              <a:spcAft>
-                <a:spcPts val="400"/>
-              </a:spcAft>
-              <a:defRPr sz="2100" b="0">
-                <a:solidFill>
-                  <a:srgbClr val="425D50"/>
-                </a:solidFill>
-                <a:latin typeface="Arial"/>
-              </a:defRPr>
-            </a:pPr>
-            <a:r>
-              <a:t>One Game rules engine</a:t>
-            </a:r>
-          </a:p>
-          <a:p>
-            <a:pPr algn="l">
-              <a:lnSpc>
-                <a:spcPct val="106000"/>
-              </a:lnSpc>
-              <a:spcBef>
-                <a:spcPts val="0"/>
-              </a:spcBef>
-              <a:spcAft>
-                <a:spcPts val="400"/>
-              </a:spcAft>
-              <a:defRPr sz="2100" b="0">
-                <a:solidFill>
-                  <a:srgbClr val="425D50"/>
-                </a:solidFill>
-                <a:latin typeface="Arial"/>
-              </a:defRPr>
-            </a:pPr>
-            <a:r>
-              <a:t>Copies for BOT search</a:t>
-            </a:r>
-          </a:p>
-        </p:txBody>
-      </p:sp>
-      <p:sp>
-        <p:nvSpPr>
-          <p:cNvPr id="22" name="TextBox 21"/>
-          <p:cNvSpPr txBox="1"/>
-          <p:nvPr/>
-        </p:nvSpPr>
-        <p:spPr>
-          <a:xfrm>
-            <a:off x="594360" y="5852160"/>
-            <a:ext cx="10972800" cy="438912"/>
-          </a:xfrm>
-          <a:prstGeom prst="rect">
-            <a:avLst/>
-          </a:prstGeom>
-          <a:noFill/>
-        </p:spPr>
-        <p:txBody>
-          <a:bodyPr wrap="square" lIns="0" rIns="0" tIns="0" bIns="0">
-            <a:noAutofit/>
-          </a:bodyPr>
-          <a:lstStyle/>
-          <a:p>
-            <a:pPr algn="l">
-              <a:lnSpc>
-                <a:spcPct val="106000"/>
-              </a:lnSpc>
-              <a:spcBef>
-                <a:spcPts val="0"/>
-              </a:spcBef>
-              <a:spcAft>
-                <a:spcPts val="400"/>
-              </a:spcAft>
-              <a:defRPr sz="2100" b="1">
-                <a:solidFill>
-                  <a:srgbClr val="285942"/>
-                </a:solidFill>
-                <a:latin typeface="Arial"/>
-              </a:defRPr>
-            </a:pPr>
-            <a:r>
-              <a:t>Learning curve: JavaFX after HTML · practical sockets after network theory</a:t>
+              <a:t>JavaFX components and user events.</a:t>
             </a:r>
           </a:p>
         </p:txBody>
@@ -7034,7 +6926,7 @@
               </a:defRPr>
             </a:pPr>
             <a:r>
-              <a:t>ENGINEERING WORK AND OWNERSHIP</a:t>
+              <a:t>DEFINED RESPONSIBILITY AREAS</a:t>
             </a:r>
           </a:p>
         </p:txBody>
@@ -7159,7 +7051,7 @@
               </a:defRPr>
             </a:pPr>
             <a:r>
-              <a:t>Our contribution — with AI assistance</a:t>
+              <a:t>Responsibilities and AI support</a:t>
             </a:r>
           </a:p>
         </p:txBody>
@@ -7298,8 +7190,8 @@
         </p:nvSpPr>
         <p:spPr>
           <a:xfrm>
-            <a:off x="548640" y="1920240"/>
-            <a:ext cx="3538728" cy="3182112"/>
+            <a:off x="548640" y="1901952"/>
+            <a:ext cx="5431536" cy="2542032"/>
           </a:xfrm>
           <a:prstGeom prst="roundRect">
             <a:avLst>
@@ -7340,58 +7232,14 @@
       </p:sp>
       <p:sp>
         <p:nvSpPr>
-          <p:cNvPr id="11" name="Rectangle 10"/>
-          <p:cNvSpPr/>
-          <p:nvPr/>
-        </p:nvSpPr>
-        <p:spPr>
-          <a:xfrm>
-            <a:off x="566928" y="2121408"/>
-            <a:ext cx="41148" cy="2779776"/>
-          </a:xfrm>
-          <a:prstGeom prst="rect">
-            <a:avLst/>
-          </a:prstGeom>
-          <a:solidFill>
-            <a:srgbClr val="285942"/>
-          </a:solidFill>
-          <a:ln>
-            <a:noFill/>
-          </a:ln>
-          <a:effectLst/>
-        </p:spPr>
-        <p:style>
-          <a:lnRef idx="1">
-            <a:schemeClr val="accent1"/>
-          </a:lnRef>
-          <a:fillRef idx="3">
-            <a:schemeClr val="accent1"/>
-          </a:fillRef>
-          <a:effectRef idx="0">
-            <a:schemeClr val="accent1"/>
-          </a:effectRef>
-          <a:fontRef idx="minor">
-            <a:schemeClr val="lt1"/>
-          </a:fontRef>
-        </p:style>
-        <p:txBody>
-          <a:bodyPr rtlCol="0" anchor="ctr"/>
-          <a:lstStyle/>
-          <a:p>
-            <a:pPr algn="ctr"/>
-          </a:p>
-        </p:txBody>
-      </p:sp>
-      <p:sp>
-        <p:nvSpPr>
-          <p:cNvPr id="12" name="TextBox 11"/>
+          <p:cNvPr id="11" name="TextBox 10"/>
           <p:cNvSpPr txBox="1"/>
           <p:nvPr/>
         </p:nvSpPr>
         <p:spPr>
           <a:xfrm>
             <a:off x="777240" y="2139696"/>
-            <a:ext cx="3081528" cy="594360"/>
+            <a:ext cx="4974336" cy="457200"/>
           </a:xfrm>
           <a:prstGeom prst="rect">
             <a:avLst/>
@@ -7414,29 +7262,29 @@
               <a:spcAft>
                 <a:spcPts val="400"/>
               </a:spcAft>
-              <a:defRPr sz="2500" b="1">
-                <a:solidFill>
-                  <a:srgbClr val="153B2D"/>
-                </a:solidFill>
-                <a:latin typeface="Arial"/>
-              </a:defRPr>
-            </a:pPr>
-            <a:r>
-              <a:t>Our decisions</a:t>
-            </a:r>
-          </a:p>
-        </p:txBody>
-      </p:sp>
-      <p:sp>
-        <p:nvSpPr>
-          <p:cNvPr id="13" name="TextBox 12"/>
+              <a:defRPr sz="2700" b="1">
+                <a:solidFill>
+                  <a:srgbClr val="285942"/>
+                </a:solidFill>
+                <a:latin typeface="Arial"/>
+              </a:defRPr>
+            </a:pPr>
+            <a:r>
+              <a:t>Rabea Abu Aad</a:t>
+            </a:r>
+          </a:p>
+        </p:txBody>
+      </p:sp>
+      <p:sp>
+        <p:nvSpPr>
+          <p:cNvPr id="12" name="TextBox 11"/>
           <p:cNvSpPr txBox="1"/>
           <p:nvPr/>
         </p:nvSpPr>
         <p:spPr>
           <a:xfrm>
-            <a:off x="777240" y="2880360"/>
-            <a:ext cx="3081528" cy="2066543"/>
+            <a:off x="777240" y="2743200"/>
+            <a:ext cx="4974336" cy="365760"/>
           </a:xfrm>
           <a:prstGeom prst="rect">
             <a:avLst/>
@@ -7459,6 +7307,51 @@
               <a:spcAft>
                 <a:spcPts val="400"/>
               </a:spcAft>
+              <a:defRPr sz="2200" b="1">
+                <a:solidFill>
+                  <a:srgbClr val="153B2D"/>
+                </a:solidFill>
+                <a:latin typeface="Arial"/>
+              </a:defRPr>
+            </a:pPr>
+            <a:r>
+              <a:t>Game logic</a:t>
+            </a:r>
+          </a:p>
+        </p:txBody>
+      </p:sp>
+      <p:sp>
+        <p:nvSpPr>
+          <p:cNvPr id="13" name="TextBox 12"/>
+          <p:cNvSpPr txBox="1"/>
+          <p:nvPr/>
+        </p:nvSpPr>
+        <p:spPr>
+          <a:xfrm>
+            <a:off x="777240" y="3182112"/>
+            <a:ext cx="4974336" cy="1042415"/>
+          </a:xfrm>
+          <a:prstGeom prst="rect">
+            <a:avLst/>
+          </a:prstGeom>
+          <a:noFill/>
+        </p:spPr>
+        <p:txBody>
+          <a:bodyPr wrap="square" lIns="0" rIns="0" tIns="0" bIns="0">
+            <a:noAutofit/>
+          </a:bodyPr>
+          <a:lstStyle/>
+          <a:p>
+            <a:pPr algn="l">
+              <a:lnSpc>
+                <a:spcPct val="106000"/>
+              </a:lnSpc>
+              <a:spcBef>
+                <a:spcPts val="0"/>
+              </a:spcBef>
+              <a:spcAft>
+                <a:spcPts val="400"/>
+              </a:spcAft>
               <a:defRPr sz="2200" b="0">
                 <a:solidFill>
                   <a:srgbClr val="425D50"/>
@@ -7467,7 +7360,7 @@
               </a:defRPr>
             </a:pPr>
             <a:r>
-              <a:t>Server owns online state</a:t>
+              <a:t>Movement and captures,</a:t>
             </a:r>
           </a:p>
           <a:p>
@@ -7489,7 +7382,7 @@
               </a:defRPr>
             </a:pPr>
             <a:r>
-              <a:t>Shared Game rules</a:t>
+              <a:t>turns and promotion,</a:t>
             </a:r>
           </a:p>
           <a:p>
@@ -7511,7 +7404,7 @@
               </a:defRPr>
             </a:pPr>
             <a:r>
-              <a:t>Authenticated result saving</a:t>
+              <a:t>game ending and winner.</a:t>
             </a:r>
           </a:p>
         </p:txBody>
@@ -7524,8 +7417,8 @@
         </p:nvSpPr>
         <p:spPr>
           <a:xfrm>
-            <a:off x="4325112" y="1920240"/>
-            <a:ext cx="3538728" cy="3182112"/>
+            <a:off x="6217920" y="1901952"/>
+            <a:ext cx="5431536" cy="2542032"/>
           </a:xfrm>
           <a:prstGeom prst="roundRect">
             <a:avLst>
@@ -7566,58 +7459,14 @@
       </p:sp>
       <p:sp>
         <p:nvSpPr>
-          <p:cNvPr id="15" name="Rectangle 14"/>
-          <p:cNvSpPr/>
-          <p:nvPr/>
-        </p:nvSpPr>
-        <p:spPr>
-          <a:xfrm>
-            <a:off x="4343400" y="2121408"/>
-            <a:ext cx="41148" cy="2779776"/>
-          </a:xfrm>
-          <a:prstGeom prst="rect">
-            <a:avLst/>
-          </a:prstGeom>
-          <a:solidFill>
-            <a:srgbClr val="9F7624"/>
-          </a:solidFill>
-          <a:ln>
-            <a:noFill/>
-          </a:ln>
-          <a:effectLst/>
-        </p:spPr>
-        <p:style>
-          <a:lnRef idx="1">
-            <a:schemeClr val="accent1"/>
-          </a:lnRef>
-          <a:fillRef idx="3">
-            <a:schemeClr val="accent1"/>
-          </a:fillRef>
-          <a:effectRef idx="0">
-            <a:schemeClr val="accent1"/>
-          </a:effectRef>
-          <a:fontRef idx="minor">
-            <a:schemeClr val="lt1"/>
-          </a:fontRef>
-        </p:style>
-        <p:txBody>
-          <a:bodyPr rtlCol="0" anchor="ctr"/>
-          <a:lstStyle/>
-          <a:p>
-            <a:pPr algn="ctr"/>
-          </a:p>
-        </p:txBody>
-      </p:sp>
-      <p:sp>
-        <p:nvSpPr>
-          <p:cNvPr id="16" name="TextBox 15"/>
+          <p:cNvPr id="15" name="TextBox 14"/>
           <p:cNvSpPr txBox="1"/>
           <p:nvPr/>
         </p:nvSpPr>
         <p:spPr>
           <a:xfrm>
-            <a:off x="4553712" y="2139696"/>
-            <a:ext cx="3081528" cy="594360"/>
+            <a:off x="6446520" y="2139696"/>
+            <a:ext cx="4974336" cy="457200"/>
           </a:xfrm>
           <a:prstGeom prst="rect">
             <a:avLst/>
@@ -7640,29 +7489,29 @@
               <a:spcAft>
                 <a:spcPts val="400"/>
               </a:spcAft>
-              <a:defRPr sz="2500" b="1">
-                <a:solidFill>
-                  <a:srgbClr val="153B2D"/>
-                </a:solidFill>
-                <a:latin typeface="Arial"/>
-              </a:defRPr>
-            </a:pPr>
-            <a:r>
-              <a:t>Our validation</a:t>
-            </a:r>
-          </a:p>
-        </p:txBody>
-      </p:sp>
-      <p:sp>
-        <p:nvSpPr>
-          <p:cNvPr id="17" name="TextBox 16"/>
+              <a:defRPr sz="2700" b="1">
+                <a:solidFill>
+                  <a:srgbClr val="BD614A"/>
+                </a:solidFill>
+                <a:latin typeface="Arial"/>
+              </a:defRPr>
+            </a:pPr>
+            <a:r>
+              <a:t>Muthanna Farhat</a:t>
+            </a:r>
+          </a:p>
+        </p:txBody>
+      </p:sp>
+      <p:sp>
+        <p:nvSpPr>
+          <p:cNvPr id="16" name="TextBox 15"/>
           <p:cNvSpPr txBox="1"/>
           <p:nvPr/>
         </p:nvSpPr>
         <p:spPr>
           <a:xfrm>
-            <a:off x="4553712" y="2880360"/>
-            <a:ext cx="3081528" cy="2066543"/>
+            <a:off x="6446520" y="2743200"/>
+            <a:ext cx="4974336" cy="365760"/>
           </a:xfrm>
           <a:prstGeom prst="rect">
             <a:avLst/>
@@ -7685,6 +7534,51 @@
               <a:spcAft>
                 <a:spcPts val="400"/>
               </a:spcAft>
+              <a:defRPr sz="2200" b="1">
+                <a:solidFill>
+                  <a:srgbClr val="153B2D"/>
+                </a:solidFill>
+                <a:latin typeface="Arial"/>
+              </a:defRPr>
+            </a:pPr>
+            <a:r>
+              <a:t>TCP communication</a:t>
+            </a:r>
+          </a:p>
+        </p:txBody>
+      </p:sp>
+      <p:sp>
+        <p:nvSpPr>
+          <p:cNvPr id="17" name="TextBox 16"/>
+          <p:cNvSpPr txBox="1"/>
+          <p:nvPr/>
+        </p:nvSpPr>
+        <p:spPr>
+          <a:xfrm>
+            <a:off x="6446520" y="3182112"/>
+            <a:ext cx="4974336" cy="1042415"/>
+          </a:xfrm>
+          <a:prstGeom prst="rect">
+            <a:avLst/>
+          </a:prstGeom>
+          <a:noFill/>
+        </p:spPr>
+        <p:txBody>
+          <a:bodyPr wrap="square" lIns="0" rIns="0" tIns="0" bIns="0">
+            <a:noAutofit/>
+          </a:bodyPr>
+          <a:lstStyle/>
+          <a:p>
+            <a:pPr algn="l">
+              <a:lnSpc>
+                <a:spcPct val="106000"/>
+              </a:lnSpc>
+              <a:spcBef>
+                <a:spcPts val="0"/>
+              </a:spcBef>
+              <a:spcAft>
+                <a:spcPts val="400"/>
+              </a:spcAft>
               <a:defRPr sz="2200" b="0">
                 <a:solidFill>
                   <a:srgbClr val="425D50"/>
@@ -7693,7 +7587,7 @@
               </a:defRPr>
             </a:pPr>
             <a:r>
-              <a:t>Run two clients</a:t>
+              <a:t>Client–server connections,</a:t>
             </a:r>
           </a:p>
           <a:p>
@@ -7715,7 +7609,7 @@
               </a:defRPr>
             </a:pPr>
             <a:r>
-              <a:t>Identify UI + animation issues</a:t>
+              <a:t>requests and replies,</a:t>
             </a:r>
           </a:p>
           <a:p>
@@ -7737,7 +7631,7 @@
               </a:defRPr>
             </a:pPr>
             <a:r>
-              <a:t>Review and trace the flow</a:t>
+              <a:t>synchronized game state.</a:t>
             </a:r>
           </a:p>
         </p:txBody>
@@ -7750,8 +7644,8 @@
         </p:nvSpPr>
         <p:spPr>
           <a:xfrm>
-            <a:off x="8110727" y="1920240"/>
-            <a:ext cx="3538728" cy="3182112"/>
+            <a:off x="548640" y="4700016"/>
+            <a:ext cx="11100816" cy="1444752"/>
           </a:xfrm>
           <a:prstGeom prst="roundRect">
             <a:avLst>
@@ -7759,7 +7653,7 @@
             </a:avLst>
           </a:prstGeom>
           <a:solidFill>
-            <a:srgbClr val="FFFFFF"/>
+            <a:srgbClr val="E8F0E7"/>
           </a:solidFill>
           <a:ln w="12700">
             <a:solidFill>
@@ -7792,58 +7686,14 @@
       </p:sp>
       <p:sp>
         <p:nvSpPr>
-          <p:cNvPr id="19" name="Rectangle 18"/>
-          <p:cNvSpPr/>
-          <p:nvPr/>
-        </p:nvSpPr>
-        <p:spPr>
-          <a:xfrm>
-            <a:off x="8129015" y="2121408"/>
-            <a:ext cx="41148" cy="2779776"/>
-          </a:xfrm>
-          <a:prstGeom prst="rect">
-            <a:avLst/>
-          </a:prstGeom>
-          <a:solidFill>
-            <a:srgbClr val="BD614A"/>
-          </a:solidFill>
-          <a:ln>
-            <a:noFill/>
-          </a:ln>
-          <a:effectLst/>
-        </p:spPr>
-        <p:style>
-          <a:lnRef idx="1">
-            <a:schemeClr val="accent1"/>
-          </a:lnRef>
-          <a:fillRef idx="3">
-            <a:schemeClr val="accent1"/>
-          </a:fillRef>
-          <a:effectRef idx="0">
-            <a:schemeClr val="accent1"/>
-          </a:effectRef>
-          <a:fontRef idx="minor">
-            <a:schemeClr val="lt1"/>
-          </a:fontRef>
-        </p:style>
-        <p:txBody>
-          <a:bodyPr rtlCol="0" anchor="ctr"/>
-          <a:lstStyle/>
-          <a:p>
-            <a:pPr algn="ctr"/>
-          </a:p>
-        </p:txBody>
-      </p:sp>
-      <p:sp>
-        <p:nvSpPr>
-          <p:cNvPr id="20" name="TextBox 19"/>
+          <p:cNvPr id="19" name="TextBox 18"/>
           <p:cNvSpPr txBox="1"/>
           <p:nvPr/>
         </p:nvSpPr>
         <p:spPr>
           <a:xfrm>
-            <a:off x="8339327" y="2139696"/>
-            <a:ext cx="3081528" cy="594360"/>
+            <a:off x="777240" y="4892040"/>
+            <a:ext cx="10643616" cy="393192"/>
           </a:xfrm>
           <a:prstGeom prst="rect">
             <a:avLst/>
@@ -7866,29 +7716,29 @@
               <a:spcAft>
                 <a:spcPts val="400"/>
               </a:spcAft>
-              <a:defRPr sz="2500" b="1">
-                <a:solidFill>
-                  <a:srgbClr val="153B2D"/>
-                </a:solidFill>
-                <a:latin typeface="Arial"/>
-              </a:defRPr>
-            </a:pPr>
-            <a:r>
-              <a:t>AI assistance</a:t>
-            </a:r>
-          </a:p>
-        </p:txBody>
-      </p:sp>
-      <p:sp>
-        <p:nvSpPr>
-          <p:cNvPr id="21" name="TextBox 20"/>
+              <a:defRPr sz="2300" b="1">
+                <a:solidFill>
+                  <a:srgbClr val="285942"/>
+                </a:solidFill>
+                <a:latin typeface="Arial"/>
+              </a:defRPr>
+            </a:pPr>
+            <a:r>
+              <a:t>Extensive AI support: Codex + GitHub Copilot</a:t>
+            </a:r>
+          </a:p>
+        </p:txBody>
+      </p:sp>
+      <p:sp>
+        <p:nvSpPr>
+          <p:cNvPr id="20" name="TextBox 19"/>
           <p:cNvSpPr txBox="1"/>
           <p:nvPr/>
         </p:nvSpPr>
         <p:spPr>
           <a:xfrm>
-            <a:off x="8339327" y="2880360"/>
-            <a:ext cx="3081528" cy="2066543"/>
+            <a:off x="777240" y="5413248"/>
+            <a:ext cx="10643616" cy="365760"/>
           </a:xfrm>
           <a:prstGeom prst="rect">
             <a:avLst/>
@@ -7911,7 +7761,7 @@
               <a:spcAft>
                 <a:spcPts val="400"/>
               </a:spcAft>
-              <a:defRPr sz="2200" b="0">
+              <a:defRPr sz="2000" b="0">
                 <a:solidFill>
                   <a:srgbClr val="425D50"/>
                 </a:solidFill>
@@ -7919,65 +7769,21 @@
               </a:defRPr>
             </a:pPr>
             <a:r>
-              <a:t>Generate + revise code</a:t>
-            </a:r>
-          </a:p>
-          <a:p>
-            <a:pPr algn="l">
-              <a:lnSpc>
-                <a:spcPct val="106000"/>
-              </a:lnSpc>
-              <a:spcBef>
-                <a:spcPts val="0"/>
-              </a:spcBef>
-              <a:spcAft>
-                <a:spcPts val="400"/>
-              </a:spcAft>
-              <a:defRPr sz="2200" b="0">
-                <a:solidFill>
-                  <a:srgbClr val="425D50"/>
-                </a:solidFill>
-                <a:latin typeface="Arial"/>
-              </a:defRPr>
-            </a:pPr>
-            <a:r>
-              <a:t>Explain behavior</a:t>
-            </a:r>
-          </a:p>
-          <a:p>
-            <a:pPr algn="l">
-              <a:lnSpc>
-                <a:spcPct val="106000"/>
-              </a:lnSpc>
-              <a:spcBef>
-                <a:spcPts val="0"/>
-              </a:spcBef>
-              <a:spcAft>
-                <a:spcPts val="400"/>
-              </a:spcAft>
-              <a:defRPr sz="2200" b="0">
-                <a:solidFill>
-                  <a:srgbClr val="425D50"/>
-                </a:solidFill>
-                <a:latin typeface="Arial"/>
-              </a:defRPr>
-            </a:pPr>
-            <a:r>
-              <a:t>Help with tests + documents</a:t>
-            </a:r>
-          </a:p>
-        </p:txBody>
-      </p:sp>
-      <p:sp>
-        <p:nvSpPr>
-          <p:cNvPr id="22" name="TextBox 21"/>
+              <a:t>Learning, planning, writing and revising code, UI, tests and documentation.</a:t>
+            </a:r>
+          </a:p>
+        </p:txBody>
+      </p:sp>
+      <p:sp>
+        <p:nvSpPr>
+          <p:cNvPr id="21" name="TextBox 20"/>
           <p:cNvSpPr txBox="1"/>
           <p:nvPr/>
         </p:nvSpPr>
         <p:spPr>
           <a:xfrm>
-            <a:off x="594360" y="5385816"/>
-            <a:ext cx="10972800" cy="365760"/>
+            <a:off x="777240" y="5806440"/>
+            <a:ext cx="10643616" cy="256032"/>
           </a:xfrm>
           <a:prstGeom prst="rect">
             <a:avLst/>
@@ -8000,82 +7806,15 @@
               <a:spcAft>
                 <a:spcPts val="400"/>
               </a:spcAft>
-              <a:defRPr sz="1900" b="1">
-                <a:solidFill>
-                  <a:srgbClr val="425D50"/>
-                </a:solidFill>
-                <a:latin typeface="Arial"/>
-              </a:defRPr>
-            </a:pPr>
-            <a:r>
-              <a:t>Responsibility areas</a:t>
-            </a:r>
-          </a:p>
-        </p:txBody>
-      </p:sp>
-      <p:sp>
-        <p:nvSpPr>
-          <p:cNvPr id="23" name="TextBox 22"/>
-          <p:cNvSpPr txBox="1"/>
-          <p:nvPr/>
-        </p:nvSpPr>
-        <p:spPr>
-          <a:xfrm>
-            <a:off x="594360" y="5715000"/>
-            <a:ext cx="10972800" cy="658368"/>
-          </a:xfrm>
-          <a:prstGeom prst="rect">
-            <a:avLst/>
-          </a:prstGeom>
-          <a:noFill/>
-        </p:spPr>
-        <p:txBody>
-          <a:bodyPr wrap="square" lIns="0" rIns="0" tIns="0" bIns="0">
-            <a:noAutofit/>
-          </a:bodyPr>
-          <a:lstStyle/>
-          <a:p>
-            <a:pPr algn="l">
-              <a:lnSpc>
-                <a:spcPct val="106000"/>
-              </a:lnSpc>
-              <a:spcBef>
-                <a:spcPts val="0"/>
-              </a:spcBef>
-              <a:spcAft>
-                <a:spcPts val="400"/>
-              </a:spcAft>
-              <a:defRPr sz="2100" b="0">
-                <a:solidFill>
-                  <a:srgbClr val="153B2D"/>
-                </a:solidFill>
-                <a:latin typeface="Arial"/>
-              </a:defRPr>
-            </a:pPr>
-            <a:r>
-              <a:t>Rabea Abu Aad — Game Logic</a:t>
-            </a:r>
-          </a:p>
-          <a:p>
-            <a:pPr algn="l">
-              <a:lnSpc>
-                <a:spcPct val="106000"/>
-              </a:lnSpc>
-              <a:spcBef>
-                <a:spcPts val="0"/>
-              </a:spcBef>
-              <a:spcAft>
-                <a:spcPts val="400"/>
-              </a:spcAft>
-              <a:defRPr sz="2100" b="0">
-                <a:solidFill>
-                  <a:srgbClr val="153B2D"/>
-                </a:solidFill>
-                <a:latin typeface="Arial"/>
-              </a:defRPr>
-            </a:pPr>
-            <a:r>
-              <a:t>Muthanna Farhat — TCP Communication</a:t>
+              <a:defRPr sz="1600" b="0">
+                <a:solidFill>
+                  <a:srgbClr val="285942"/>
+                </a:solidFill>
+                <a:latin typeface="Arial"/>
+              </a:defRPr>
+            </a:pPr>
+            <a:r>
+              <a:t>Define requirements → review suggestions → run and test → adjust</a:t>
             </a:r>
           </a:p>
         </p:txBody>
@@ -12389,7 +12128,7 @@
               </a:defRPr>
             </a:pPr>
             <a:r>
-              <a:t>SQLite + JDBC</a:t>
+              <a:t>SQLite database</a:t>
             </a:r>
           </a:p>
         </p:txBody>
@@ -12434,20 +12173,65 @@
               </a:defRPr>
             </a:pPr>
             <a:r>
-              <a:t>Accounts, results, statistics and history</a:t>
-            </a:r>
-          </a:p>
-        </p:txBody>
-      </p:sp>
-      <p:sp>
-        <p:nvSpPr>
-          <p:cNvPr id="26" name="Rounded Rectangle 25"/>
+              <a:t>Accounts, results and history</a:t>
+            </a:r>
+          </a:p>
+        </p:txBody>
+      </p:sp>
+      <p:sp>
+        <p:nvSpPr>
+          <p:cNvPr id="26" name="TextBox 25"/>
+          <p:cNvSpPr txBox="1"/>
+          <p:nvPr/>
+        </p:nvSpPr>
+        <p:spPr>
+          <a:xfrm>
+            <a:off x="594360" y="5522976"/>
+            <a:ext cx="10972800" cy="365760"/>
+          </a:xfrm>
+          <a:prstGeom prst="rect">
+            <a:avLst/>
+          </a:prstGeom>
+          <a:noFill/>
+        </p:spPr>
+        <p:txBody>
+          <a:bodyPr wrap="square" lIns="0" rIns="0" tIns="0" bIns="0">
+            <a:noAutofit/>
+          </a:bodyPr>
+          <a:lstStyle/>
+          <a:p>
+            <a:pPr algn="l">
+              <a:lnSpc>
+                <a:spcPct val="106000"/>
+              </a:lnSpc>
+              <a:spcBef>
+                <a:spcPts val="0"/>
+              </a:spcBef>
+              <a:spcAft>
+                <a:spcPts val="400"/>
+              </a:spcAft>
+              <a:defRPr sz="2000" b="0">
+                <a:solidFill>
+                  <a:srgbClr val="425D50"/>
+                </a:solidFill>
+                <a:latin typeface="Arial"/>
+              </a:defRPr>
+            </a:pPr>
+            <a:r>
+              <a:t>JDBC lets the server’s Java code read and write SQLite.</a:t>
+            </a:r>
+          </a:p>
+        </p:txBody>
+      </p:sp>
+      <p:sp>
+        <p:nvSpPr>
+          <p:cNvPr id="27" name="Rounded Rectangle 26"/>
           <p:cNvSpPr/>
           <p:nvPr/>
         </p:nvSpPr>
         <p:spPr>
           <a:xfrm>
-            <a:off x="777240" y="5806440"/>
+            <a:off x="777240" y="6035040"/>
             <a:ext cx="10634472" cy="347472"/>
           </a:xfrm>
           <a:prstGeom prst="roundRect">
@@ -12487,13 +12271,13 @@
       </p:sp>
       <p:sp>
         <p:nvSpPr>
-          <p:cNvPr id="27" name="TextBox 26"/>
+          <p:cNvPr id="28" name="TextBox 27"/>
           <p:cNvSpPr txBox="1"/>
           <p:nvPr/>
         </p:nvSpPr>
         <p:spPr>
           <a:xfrm>
-            <a:off x="868680" y="5861303"/>
+            <a:off x="868680" y="6089903"/>
             <a:ext cx="10451592" cy="228600"/>
           </a:xfrm>
           <a:prstGeom prst="rect">
@@ -12517,7 +12301,7 @@
               <a:spcAft>
                 <a:spcPts val="400"/>
               </a:spcAft>
-              <a:defRPr sz="1700" b="1">
+              <a:defRPr sz="1600" b="1">
                 <a:solidFill>
                   <a:srgbClr val="285942"/>
                 </a:solidFill>
@@ -18065,7 +17849,7 @@
         </p:nvSpPr>
         <p:spPr>
           <a:xfrm>
-            <a:off x="804672" y="3108960"/>
+            <a:off x="804672" y="2971800"/>
             <a:ext cx="3611880" cy="2286000"/>
           </a:xfrm>
           <a:prstGeom prst="rect">
@@ -18184,42 +17968,73 @@
           </a:p>
         </p:txBody>
       </p:sp>
-      <p:cxnSp>
-        <p:nvCxnSpPr>
-          <p:cNvPr id="13" name="Connector 12"/>
-          <p:cNvCxnSpPr/>
-          <p:nvPr/>
-        </p:nvCxnSpPr>
-        <p:spPr>
-          <a:xfrm flipH="1">
-            <a:off x="6446520" y="2606040"/>
-            <a:ext cx="1691640" cy="914400"/>
-          </a:xfrm>
-          <a:prstGeom prst="line">
-            <a:avLst/>
-          </a:prstGeom>
-          <a:ln w="25400">
-            <a:solidFill>
-              <a:srgbClr val="CBD8CF"/>
-            </a:solidFill>
-          </a:ln>
-          <a:effectLst/>
-        </p:spPr>
-        <p:style>
-          <a:lnRef idx="2">
-            <a:schemeClr val="accent1"/>
-          </a:lnRef>
-          <a:fillRef idx="0">
-            <a:schemeClr val="accent1"/>
-          </a:fillRef>
-          <a:effectRef idx="0">
-            <a:schemeClr val="accent1"/>
-          </a:effectRef>
-          <a:fontRef idx="minor">
-            <a:schemeClr val="tx1"/>
-          </a:fontRef>
-        </p:style>
-      </p:cxnSp>
+      <p:sp>
+        <p:nvSpPr>
+          <p:cNvPr id="13" name="TextBox 12"/>
+          <p:cNvSpPr txBox="1"/>
+          <p:nvPr/>
+        </p:nvSpPr>
+        <p:spPr>
+          <a:xfrm>
+            <a:off x="804672" y="5285232"/>
+            <a:ext cx="3611880" cy="594360"/>
+          </a:xfrm>
+          <a:prstGeom prst="rect">
+            <a:avLst/>
+          </a:prstGeom>
+          <a:noFill/>
+        </p:spPr>
+        <p:txBody>
+          <a:bodyPr wrap="square" lIns="0" rIns="0" tIns="0" bIns="0">
+            <a:noAutofit/>
+          </a:bodyPr>
+          <a:lstStyle/>
+          <a:p>
+            <a:pPr algn="l">
+              <a:lnSpc>
+                <a:spcPct val="106000"/>
+              </a:lnSpc>
+              <a:spcBef>
+                <a:spcPts val="0"/>
+              </a:spcBef>
+              <a:spcAft>
+                <a:spcPts val="400"/>
+              </a:spcAft>
+              <a:defRPr sz="1700" b="0">
+                <a:solidFill>
+                  <a:srgbClr val="425D50"/>
+                </a:solidFill>
+                <a:latin typeface="Arial"/>
+              </a:defRPr>
+            </a:pPr>
+            <a:r>
+              <a:t>Alpha–Beta reduces</a:t>
+            </a:r>
+          </a:p>
+          <a:p>
+            <a:pPr algn="l">
+              <a:lnSpc>
+                <a:spcPct val="106000"/>
+              </a:lnSpc>
+              <a:spcBef>
+                <a:spcPts val="0"/>
+              </a:spcBef>
+              <a:spcAft>
+                <a:spcPts val="400"/>
+              </a:spcAft>
+              <a:defRPr sz="1700" b="0">
+                <a:solidFill>
+                  <a:srgbClr val="425D50"/>
+                </a:solidFill>
+                <a:latin typeface="Arial"/>
+              </a:defRPr>
+            </a:pPr>
+            <a:r>
+              <a:t>unnecessary search.</a:t>
+            </a:r>
+          </a:p>
+        </p:txBody>
+      </p:sp>
       <p:cxnSp>
         <p:nvCxnSpPr>
           <p:cNvPr id="14" name="Connector 13"/>
@@ -18227,16 +18042,16 @@
           <p:nvPr/>
         </p:nvCxnSpPr>
         <p:spPr>
-          <a:xfrm>
-            <a:off x="8138160" y="2606040"/>
+          <a:xfrm flipH="1">
+            <a:off x="6446520" y="2606040"/>
             <a:ext cx="1691640" cy="914400"/>
           </a:xfrm>
           <a:prstGeom prst="line">
             <a:avLst/>
           </a:prstGeom>
-          <a:ln w="38100">
+          <a:ln w="25400">
             <a:solidFill>
-              <a:srgbClr val="285942"/>
+              <a:srgbClr val="CBD8CF"/>
             </a:solidFill>
           </a:ln>
           <a:effectLst/>
@@ -18263,16 +18078,16 @@
           <p:nvPr/>
         </p:nvCxnSpPr>
         <p:spPr>
-          <a:xfrm flipH="1">
-            <a:off x="5715000" y="4041648"/>
-            <a:ext cx="731520" cy="850392"/>
+          <a:xfrm>
+            <a:off x="8138160" y="2606040"/>
+            <a:ext cx="1691640" cy="914400"/>
           </a:xfrm>
           <a:prstGeom prst="line">
             <a:avLst/>
           </a:prstGeom>
-          <a:ln w="25400">
+          <a:ln w="38100">
             <a:solidFill>
-              <a:srgbClr val="CBD8CF"/>
+              <a:srgbClr val="285942"/>
             </a:solidFill>
           </a:ln>
           <a:effectLst/>
@@ -18299,8 +18114,8 @@
           <p:nvPr/>
         </p:nvCxnSpPr>
         <p:spPr>
-          <a:xfrm>
-            <a:off x="6446520" y="4041648"/>
+          <a:xfrm flipH="1">
+            <a:off x="5715000" y="4041648"/>
             <a:ext cx="731520" cy="850392"/>
           </a:xfrm>
           <a:prstGeom prst="line">
@@ -18335,16 +18150,16 @@
           <p:nvPr/>
         </p:nvCxnSpPr>
         <p:spPr>
-          <a:xfrm flipH="1">
-            <a:off x="9098280" y="4041648"/>
+          <a:xfrm>
+            <a:off x="6446520" y="4041648"/>
             <a:ext cx="731520" cy="850392"/>
           </a:xfrm>
           <a:prstGeom prst="line">
             <a:avLst/>
           </a:prstGeom>
-          <a:ln w="38100">
+          <a:ln w="25400">
             <a:solidFill>
-              <a:srgbClr val="285942"/>
+              <a:srgbClr val="CBD8CF"/>
             </a:solidFill>
           </a:ln>
           <a:effectLst/>
@@ -18371,6 +18186,42 @@
           <p:nvPr/>
         </p:nvCxnSpPr>
         <p:spPr>
+          <a:xfrm flipH="1">
+            <a:off x="9098280" y="4041648"/>
+            <a:ext cx="731520" cy="850392"/>
+          </a:xfrm>
+          <a:prstGeom prst="line">
+            <a:avLst/>
+          </a:prstGeom>
+          <a:ln w="38100">
+            <a:solidFill>
+              <a:srgbClr val="285942"/>
+            </a:solidFill>
+          </a:ln>
+          <a:effectLst/>
+        </p:spPr>
+        <p:style>
+          <a:lnRef idx="2">
+            <a:schemeClr val="accent1"/>
+          </a:lnRef>
+          <a:fillRef idx="0">
+            <a:schemeClr val="accent1"/>
+          </a:fillRef>
+          <a:effectRef idx="0">
+            <a:schemeClr val="accent1"/>
+          </a:effectRef>
+          <a:fontRef idx="minor">
+            <a:schemeClr val="tx1"/>
+          </a:fontRef>
+        </p:style>
+      </p:cxnSp>
+      <p:cxnSp>
+        <p:nvCxnSpPr>
+          <p:cNvPr id="19" name="Connector 18"/>
+          <p:cNvCxnSpPr/>
+          <p:nvPr/>
+        </p:nvCxnSpPr>
+        <p:spPr>
           <a:xfrm>
             <a:off x="9829800" y="4041648"/>
             <a:ext cx="731520" cy="850392"/>
@@ -18402,7 +18253,7 @@
       </p:cxnSp>
       <p:sp>
         <p:nvSpPr>
-          <p:cNvPr id="19" name="Rounded Rectangle 18"/>
+          <p:cNvPr id="20" name="Rounded Rectangle 19"/>
           <p:cNvSpPr/>
           <p:nvPr/>
         </p:nvSpPr>
@@ -18450,7 +18301,7 @@
       </p:sp>
       <p:sp>
         <p:nvSpPr>
-          <p:cNvPr id="20" name="TextBox 19"/>
+          <p:cNvPr id="21" name="TextBox 20"/>
           <p:cNvSpPr txBox="1"/>
           <p:nvPr/>
         </p:nvSpPr>
@@ -18495,14 +18346,14 @@
       </p:sp>
       <p:sp>
         <p:nvSpPr>
-          <p:cNvPr id="21" name="Rounded Rectangle 20"/>
+          <p:cNvPr id="22" name="Rounded Rectangle 21"/>
           <p:cNvSpPr/>
           <p:nvPr/>
         </p:nvSpPr>
         <p:spPr>
           <a:xfrm>
-            <a:off x="5468112" y="3364992"/>
-            <a:ext cx="1965960" cy="731520"/>
+            <a:off x="5120640" y="3364992"/>
+            <a:ext cx="2651760" cy="731520"/>
           </a:xfrm>
           <a:prstGeom prst="roundRect">
             <a:avLst>
@@ -18543,14 +18394,14 @@
       </p:sp>
       <p:sp>
         <p:nvSpPr>
-          <p:cNvPr id="22" name="TextBox 21"/>
+          <p:cNvPr id="23" name="TextBox 22"/>
           <p:cNvSpPr txBox="1"/>
           <p:nvPr/>
         </p:nvSpPr>
         <p:spPr>
           <a:xfrm>
-            <a:off x="5541264" y="3621024"/>
-            <a:ext cx="1819656" cy="365760"/>
+            <a:off x="5193792" y="3621024"/>
+            <a:ext cx="2505456" cy="365760"/>
           </a:xfrm>
           <a:prstGeom prst="rect">
             <a:avLst/>
@@ -18573,7 +18424,7 @@
               <a:spcAft>
                 <a:spcPts val="400"/>
               </a:spcAft>
-              <a:defRPr sz="2200" b="1">
+              <a:defRPr sz="1800" b="1">
                 <a:solidFill>
                   <a:srgbClr val="153B2D"/>
                 </a:solidFill>
@@ -18581,21 +18432,21 @@
               </a:defRPr>
             </a:pPr>
             <a:r>
-              <a:t>MIN = −3</a:t>
-            </a:r>
-          </a:p>
-        </p:txBody>
-      </p:sp>
-      <p:sp>
-        <p:nvSpPr>
-          <p:cNvPr id="23" name="Rounded Rectangle 22"/>
+              <a:t>Move A · MIN = −3</a:t>
+            </a:r>
+          </a:p>
+        </p:txBody>
+      </p:sp>
+      <p:sp>
+        <p:nvSpPr>
+          <p:cNvPr id="24" name="Rounded Rectangle 23"/>
           <p:cNvSpPr/>
           <p:nvPr/>
         </p:nvSpPr>
         <p:spPr>
           <a:xfrm>
-            <a:off x="8851392" y="3364992"/>
-            <a:ext cx="1965960" cy="731520"/>
+            <a:off x="8503920" y="3364992"/>
+            <a:ext cx="2651760" cy="731520"/>
           </a:xfrm>
           <a:prstGeom prst="roundRect">
             <a:avLst>
@@ -18636,14 +18487,14 @@
       </p:sp>
       <p:sp>
         <p:nvSpPr>
-          <p:cNvPr id="24" name="TextBox 23"/>
+          <p:cNvPr id="25" name="TextBox 24"/>
           <p:cNvSpPr txBox="1"/>
           <p:nvPr/>
         </p:nvSpPr>
         <p:spPr>
           <a:xfrm>
-            <a:off x="8924544" y="3621024"/>
-            <a:ext cx="1819656" cy="365760"/>
+            <a:off x="8577072" y="3621024"/>
+            <a:ext cx="2505456" cy="365760"/>
           </a:xfrm>
           <a:prstGeom prst="rect">
             <a:avLst/>
@@ -18666,7 +18517,7 @@
               <a:spcAft>
                 <a:spcPts val="400"/>
               </a:spcAft>
-              <a:defRPr sz="2200" b="1">
+              <a:defRPr sz="1800" b="1">
                 <a:solidFill>
                   <a:srgbClr val="153B2D"/>
                 </a:solidFill>
@@ -18674,14 +18525,14 @@
               </a:defRPr>
             </a:pPr>
             <a:r>
-              <a:t>MIN = 0</a:t>
-            </a:r>
-          </a:p>
-        </p:txBody>
-      </p:sp>
-      <p:sp>
-        <p:nvSpPr>
-          <p:cNvPr id="25" name="Rounded Rectangle 24"/>
+              <a:t>Move B · MIN = 0</a:t>
+            </a:r>
+          </a:p>
+        </p:txBody>
+      </p:sp>
+      <p:sp>
+        <p:nvSpPr>
+          <p:cNvPr id="26" name="Rounded Rectangle 25"/>
           <p:cNvSpPr/>
           <p:nvPr/>
         </p:nvSpPr>
@@ -18729,7 +18580,7 @@
       </p:sp>
       <p:sp>
         <p:nvSpPr>
-          <p:cNvPr id="26" name="TextBox 25"/>
+          <p:cNvPr id="27" name="TextBox 26"/>
           <p:cNvSpPr txBox="1"/>
           <p:nvPr/>
         </p:nvSpPr>
@@ -18774,7 +18625,7 @@
       </p:sp>
       <p:sp>
         <p:nvSpPr>
-          <p:cNvPr id="27" name="Rounded Rectangle 26"/>
+          <p:cNvPr id="28" name="Rounded Rectangle 27"/>
           <p:cNvSpPr/>
           <p:nvPr/>
         </p:nvSpPr>
@@ -18822,7 +18673,7 @@
       </p:sp>
       <p:sp>
         <p:nvSpPr>
-          <p:cNvPr id="28" name="TextBox 27"/>
+          <p:cNvPr id="29" name="TextBox 28"/>
           <p:cNvSpPr txBox="1"/>
           <p:nvPr/>
         </p:nvSpPr>
@@ -18867,7 +18718,7 @@
       </p:sp>
       <p:sp>
         <p:nvSpPr>
-          <p:cNvPr id="29" name="Rounded Rectangle 28"/>
+          <p:cNvPr id="30" name="Rounded Rectangle 29"/>
           <p:cNvSpPr/>
           <p:nvPr/>
         </p:nvSpPr>
@@ -18915,7 +18766,7 @@
       </p:sp>
       <p:sp>
         <p:nvSpPr>
-          <p:cNvPr id="30" name="TextBox 29"/>
+          <p:cNvPr id="31" name="TextBox 30"/>
           <p:cNvSpPr txBox="1"/>
           <p:nvPr/>
         </p:nvSpPr>
@@ -18960,7 +18811,7 @@
       </p:sp>
       <p:sp>
         <p:nvSpPr>
-          <p:cNvPr id="31" name="Rounded Rectangle 30"/>
+          <p:cNvPr id="32" name="Rounded Rectangle 31"/>
           <p:cNvSpPr/>
           <p:nvPr/>
         </p:nvSpPr>
@@ -19008,7 +18859,7 @@
       </p:sp>
       <p:sp>
         <p:nvSpPr>
-          <p:cNvPr id="32" name="TextBox 31"/>
+          <p:cNvPr id="33" name="TextBox 32"/>
           <p:cNvSpPr txBox="1"/>
           <p:nvPr/>
         </p:nvSpPr>
@@ -19053,14 +18904,14 @@
       </p:sp>
       <p:sp>
         <p:nvSpPr>
-          <p:cNvPr id="33" name="TextBox 32"/>
+          <p:cNvPr id="34" name="TextBox 33"/>
           <p:cNvSpPr txBox="1"/>
           <p:nvPr/>
         </p:nvSpPr>
         <p:spPr>
           <a:xfrm>
-            <a:off x="5486400" y="5669280"/>
-            <a:ext cx="5943600" cy="320040"/>
+            <a:off x="5029200" y="5532120"/>
+            <a:ext cx="6537960" cy="274320"/>
           </a:xfrm>
           <a:prstGeom prst="rect">
             <a:avLst/>
@@ -19083,7 +18934,7 @@
               <a:spcAft>
                 <a:spcPts val="400"/>
               </a:spcAft>
-              <a:defRPr sz="1700" b="0">
+              <a:defRPr sz="1500" b="0">
                 <a:solidFill>
                   <a:srgbClr val="425D50"/>
                 </a:solidFill>
@@ -19091,21 +18942,67 @@
               </a:defRPr>
             </a:pPr>
             <a:r>
-              <a:t>Illustrative two-step search</a:t>
-            </a:r>
-          </a:p>
-        </p:txBody>
-      </p:sp>
-      <p:sp>
-        <p:nvSpPr>
-          <p:cNvPr id="34" name="TextBox 33"/>
+              <a:t>Illustrative search · 0 is a board score, not a match result.</a:t>
+            </a:r>
+          </a:p>
+        </p:txBody>
+      </p:sp>
+      <p:sp>
+        <p:nvSpPr>
+          <p:cNvPr id="35" name="Rounded Rectangle 34"/>
+          <p:cNvSpPr/>
+          <p:nvPr/>
+        </p:nvSpPr>
+        <p:spPr>
+          <a:xfrm>
+            <a:off x="594360" y="5934456"/>
+            <a:ext cx="11018520" cy="429768"/>
+          </a:xfrm>
+          <a:prstGeom prst="roundRect">
+            <a:avLst>
+              <a:gd name="adj" fmla="val 12000"/>
+            </a:avLst>
+          </a:prstGeom>
+          <a:solidFill>
+            <a:srgbClr val="E8F0E7"/>
+          </a:solidFill>
+          <a:ln>
+            <a:noFill/>
+          </a:ln>
+          <a:effectLst/>
+        </p:spPr>
+        <p:style>
+          <a:lnRef idx="1">
+            <a:schemeClr val="accent1"/>
+          </a:lnRef>
+          <a:fillRef idx="3">
+            <a:schemeClr val="accent1"/>
+          </a:fillRef>
+          <a:effectRef idx="0">
+            <a:schemeClr val="accent1"/>
+          </a:effectRef>
+          <a:fontRef idx="minor">
+            <a:schemeClr val="lt1"/>
+          </a:fontRef>
+        </p:style>
+        <p:txBody>
+          <a:bodyPr rtlCol="0" anchor="ctr"/>
+          <a:lstStyle/>
+          <a:p>
+            <a:pPr algn="ctr"/>
+          </a:p>
+        </p:txBody>
+      </p:sp>
+      <p:sp>
+        <p:nvSpPr>
+          <p:cNvPr id="36" name="TextBox 35"/>
           <p:cNvSpPr txBox="1"/>
           <p:nvPr/>
         </p:nvSpPr>
         <p:spPr>
           <a:xfrm>
-            <a:off x="594360" y="6080760"/>
-            <a:ext cx="10972800" cy="292608"/>
+            <a:off x="758952" y="6025896"/>
+            <a:ext cx="10698480" cy="292608"/>
           </a:xfrm>
           <a:prstGeom prst="rect">
             <a:avLst/>
@@ -19128,7 +19025,7 @@
               <a:spcAft>
                 <a:spcPts val="400"/>
               </a:spcAft>
-              <a:defRPr sz="1900" b="0">
+              <a:defRPr sz="2200" b="1">
                 <a:solidFill>
                   <a:srgbClr val="285942"/>
                 </a:solidFill>
@@ -19136,7 +19033,7 @@
               </a:defRPr>
             </a:pPr>
             <a:r>
-              <a:t>Alpha–Beta skips branches that cannot improve the decision.</a:t>
+              <a:t>Final choice: move B — MAX(−3, 0) = 0</a:t>
             </a:r>
           </a:p>
         </p:txBody>

</xml_diff>